<commit_message>
docs: polish final pitch copy and verify searchable PDF export
</commit_message>
<xml_diff>
--- a/docs/submission/Financial-Friday-AI-Builder-Cup.pptx
+++ b/docs/submission/Financial-Friday-AI-Builder-Cup.pptx
@@ -2,28 +2,28 @@
 <file path=ppt/presentation.xml><?xml version="1.0" encoding="utf-8"?>
 <p:presentation xmlns:p="http://schemas.openxmlformats.org/presentationml/2006/main">
   <p:sldMasterIdLst>
-    <p:sldMasterId xmlns:r="http://schemas.openxmlformats.org/officeDocument/2006/relationships" id="2147483648" r:id="R5ac7ee21d2c34c17"/>
+    <p:sldMasterId xmlns:r="http://schemas.openxmlformats.org/officeDocument/2006/relationships" id="2147483648" r:id="R1ae051abc48a4154"/>
   </p:sldMasterIdLst>
   <p:notesMasterIdLst>
-    <p:notesMasterId xmlns:r="http://schemas.openxmlformats.org/officeDocument/2006/relationships" r:id="R14b5ba0454884c81"/>
+    <p:notesMasterId xmlns:r="http://schemas.openxmlformats.org/officeDocument/2006/relationships" r:id="R4e17db42df1549ad"/>
   </p:notesMasterIdLst>
   <p:sldIdLst>
-    <p:sldId xmlns:r="http://schemas.openxmlformats.org/officeDocument/2006/relationships" id="256" r:id="R10f87408135a463c"/>
-    <p:sldId xmlns:r="http://schemas.openxmlformats.org/officeDocument/2006/relationships" id="257" r:id="Rf0f3cf3c22034f21"/>
-    <p:sldId xmlns:r="http://schemas.openxmlformats.org/officeDocument/2006/relationships" id="258" r:id="R4ad24ddf68d3414f"/>
-    <p:sldId xmlns:r="http://schemas.openxmlformats.org/officeDocument/2006/relationships" id="259" r:id="R3ab87477538247ab"/>
-    <p:sldId xmlns:r="http://schemas.openxmlformats.org/officeDocument/2006/relationships" id="260" r:id="Ra36180e0a7fd4f10"/>
-    <p:sldId xmlns:r="http://schemas.openxmlformats.org/officeDocument/2006/relationships" id="261" r:id="R7c9dc73bf6994cb5"/>
-    <p:sldId xmlns:r="http://schemas.openxmlformats.org/officeDocument/2006/relationships" id="262" r:id="R48f6229075d04dc2"/>
-    <p:sldId xmlns:r="http://schemas.openxmlformats.org/officeDocument/2006/relationships" id="263" r:id="Rbde27f09abba4171"/>
-    <p:sldId xmlns:r="http://schemas.openxmlformats.org/officeDocument/2006/relationships" id="264" r:id="R983bc987d7844361"/>
-    <p:sldId xmlns:r="http://schemas.openxmlformats.org/officeDocument/2006/relationships" id="265" r:id="R96e1c3b049604a6a"/>
-    <p:sldId xmlns:r="http://schemas.openxmlformats.org/officeDocument/2006/relationships" id="266" r:id="R85c7150e58594739"/>
-    <p:sldId xmlns:r="http://schemas.openxmlformats.org/officeDocument/2006/relationships" id="267" r:id="R732c660dce6941a0"/>
-    <p:sldId xmlns:r="http://schemas.openxmlformats.org/officeDocument/2006/relationships" id="268" r:id="Rd09c227d16494d91"/>
-    <p:sldId xmlns:r="http://schemas.openxmlformats.org/officeDocument/2006/relationships" id="269" r:id="R86abc7f0b5a4465a"/>
-    <p:sldId xmlns:r="http://schemas.openxmlformats.org/officeDocument/2006/relationships" id="270" r:id="Rb153928c699c4114"/>
-    <p:sldId xmlns:r="http://schemas.openxmlformats.org/officeDocument/2006/relationships" id="271" r:id="R3e7d7a32023c4e33"/>
+    <p:sldId xmlns:r="http://schemas.openxmlformats.org/officeDocument/2006/relationships" id="256" r:id="R24756135275f4fd7"/>
+    <p:sldId xmlns:r="http://schemas.openxmlformats.org/officeDocument/2006/relationships" id="257" r:id="Rae00bf37f76e4b6d"/>
+    <p:sldId xmlns:r="http://schemas.openxmlformats.org/officeDocument/2006/relationships" id="258" r:id="R93a1bfc4661b4a0a"/>
+    <p:sldId xmlns:r="http://schemas.openxmlformats.org/officeDocument/2006/relationships" id="259" r:id="R777ca9feb746403d"/>
+    <p:sldId xmlns:r="http://schemas.openxmlformats.org/officeDocument/2006/relationships" id="260" r:id="R91aba699558e4635"/>
+    <p:sldId xmlns:r="http://schemas.openxmlformats.org/officeDocument/2006/relationships" id="261" r:id="Rf1f003cad7184f01"/>
+    <p:sldId xmlns:r="http://schemas.openxmlformats.org/officeDocument/2006/relationships" id="262" r:id="R3b913e38f9f04a73"/>
+    <p:sldId xmlns:r="http://schemas.openxmlformats.org/officeDocument/2006/relationships" id="263" r:id="R79c37e51261c4c00"/>
+    <p:sldId xmlns:r="http://schemas.openxmlformats.org/officeDocument/2006/relationships" id="264" r:id="R78cd15ae8a6c4103"/>
+    <p:sldId xmlns:r="http://schemas.openxmlformats.org/officeDocument/2006/relationships" id="265" r:id="R205f76b92a6743c4"/>
+    <p:sldId xmlns:r="http://schemas.openxmlformats.org/officeDocument/2006/relationships" id="266" r:id="Rcd713fb32e6e48e9"/>
+    <p:sldId xmlns:r="http://schemas.openxmlformats.org/officeDocument/2006/relationships" id="267" r:id="R038c719cb4b0466b"/>
+    <p:sldId xmlns:r="http://schemas.openxmlformats.org/officeDocument/2006/relationships" id="268" r:id="Ra7354d24469d466b"/>
+    <p:sldId xmlns:r="http://schemas.openxmlformats.org/officeDocument/2006/relationships" id="269" r:id="R49d9032bd98a4878"/>
+    <p:sldId xmlns:r="http://schemas.openxmlformats.org/officeDocument/2006/relationships" id="270" r:id="Rf8d3964442bd4edb"/>
+    <p:sldId xmlns:r="http://schemas.openxmlformats.org/officeDocument/2006/relationships" id="271" r:id="R6412f0c4718042a3"/>
   </p:sldIdLst>
   <p:sldSz cx="9144000" cy="5143500"/>
   <p:notesSz cx="6858000" cy="9144000"/>
@@ -2207,7 +2207,7 @@
           <p:cNvPr id="10" name="Google Shape;10;p2">
             <a:extLst xmlns:a="http://schemas.openxmlformats.org/drawingml/2006/main">
               <a:ext uri="{FF2B5EF4-FFF2-40B4-BE49-F238E27FC236}">
-                <a16:creationId xmlns:a16="http://schemas.microsoft.com/office/drawing/2014/main" id="{D86A2B04-E1D7-4672-BBD1-2ED5450100AB}"/>
+                <a16:creationId xmlns:a16="http://schemas.microsoft.com/office/drawing/2014/main" id="{1758CB06-150F-4056-AD51-6AAA5E85D174}"/>
               </a:ext>
             </a:extLst>
           </p:cNvPr>
@@ -2340,7 +2340,7 @@
           <p:cNvPr id="11" name="Google Shape;11;p2">
             <a:extLst xmlns:a="http://schemas.openxmlformats.org/drawingml/2006/main">
               <a:ext uri="{FF2B5EF4-FFF2-40B4-BE49-F238E27FC236}">
-                <a16:creationId xmlns:a16="http://schemas.microsoft.com/office/drawing/2014/main" id="{700D9676-48FA-43C0-A327-B884769D6CA2}"/>
+                <a16:creationId xmlns:a16="http://schemas.microsoft.com/office/drawing/2014/main" id="{AADE221E-A460-4A3D-BFA3-9B42D5692169}"/>
               </a:ext>
             </a:extLst>
           </p:cNvPr>
@@ -2500,7 +2500,7 @@
           <p:cNvPr id="12" name="Google Shape;12;p2">
             <a:extLst xmlns:a="http://schemas.openxmlformats.org/drawingml/2006/main">
               <a:ext uri="{FF2B5EF4-FFF2-40B4-BE49-F238E27FC236}">
-                <a16:creationId xmlns:a16="http://schemas.microsoft.com/office/drawing/2014/main" id="{B6A8A17A-6BD5-4234-8F50-704C866F216D}"/>
+                <a16:creationId xmlns:a16="http://schemas.microsoft.com/office/drawing/2014/main" id="{20645393-05B5-4455-8452-732AE223EB45}"/>
               </a:ext>
             </a:extLst>
           </p:cNvPr>
@@ -2601,7 +2601,7 @@
           <p:cNvPr id="45" name="Google Shape;45;p11">
             <a:extLst xmlns:a="http://schemas.openxmlformats.org/drawingml/2006/main">
               <a:ext uri="{FF2B5EF4-FFF2-40B4-BE49-F238E27FC236}">
-                <a16:creationId xmlns:a16="http://schemas.microsoft.com/office/drawing/2014/main" id="{D1CFE41D-09EA-4491-A86B-86239B36A1CB}"/>
+                <a16:creationId xmlns:a16="http://schemas.microsoft.com/office/drawing/2014/main" id="{1D26E2DE-C260-4A9F-BAC0-56EE4DCE39C5}"/>
               </a:ext>
             </a:extLst>
           </p:cNvPr>
@@ -2738,7 +2738,7 @@
           <p:cNvPr id="46" name="Google Shape;46;p11">
             <a:extLst xmlns:a="http://schemas.openxmlformats.org/drawingml/2006/main">
               <a:ext uri="{FF2B5EF4-FFF2-40B4-BE49-F238E27FC236}">
-                <a16:creationId xmlns:a16="http://schemas.microsoft.com/office/drawing/2014/main" id="{EA928388-08C9-46DD-A713-3548032CECDB}"/>
+                <a16:creationId xmlns:a16="http://schemas.microsoft.com/office/drawing/2014/main" id="{87447B44-BBBD-4F15-A204-D2F185186309}"/>
               </a:ext>
             </a:extLst>
           </p:cNvPr>
@@ -2871,7 +2871,7 @@
           <p:cNvPr id="47" name="Google Shape;47;p11">
             <a:extLst xmlns:a="http://schemas.openxmlformats.org/drawingml/2006/main">
               <a:ext uri="{FF2B5EF4-FFF2-40B4-BE49-F238E27FC236}">
-                <a16:creationId xmlns:a16="http://schemas.microsoft.com/office/drawing/2014/main" id="{99316ADC-5519-46F4-87BB-61405AED1A0C}"/>
+                <a16:creationId xmlns:a16="http://schemas.microsoft.com/office/drawing/2014/main" id="{17BCBB2E-D24B-42CE-8250-079D33253769}"/>
               </a:ext>
             </a:extLst>
           </p:cNvPr>
@@ -2972,7 +2972,7 @@
           <p:cNvPr id="49" name="Google Shape;49;p12">
             <a:extLst xmlns:a="http://schemas.openxmlformats.org/drawingml/2006/main">
               <a:ext uri="{FF2B5EF4-FFF2-40B4-BE49-F238E27FC236}">
-                <a16:creationId xmlns:a16="http://schemas.microsoft.com/office/drawing/2014/main" id="{21500D23-11C8-45C4-BD67-A16B0289C502}"/>
+                <a16:creationId xmlns:a16="http://schemas.microsoft.com/office/drawing/2014/main" id="{B3771183-6119-4AAB-91FC-B569980FF395}"/>
               </a:ext>
             </a:extLst>
           </p:cNvPr>
@@ -3073,7 +3073,7 @@
           <p:cNvPr id="14" name="Google Shape;14;p3">
             <a:extLst xmlns:a="http://schemas.openxmlformats.org/drawingml/2006/main">
               <a:ext uri="{FF2B5EF4-FFF2-40B4-BE49-F238E27FC236}">
-                <a16:creationId xmlns:a16="http://schemas.microsoft.com/office/drawing/2014/main" id="{4C9A4F21-F8CF-447A-A4AF-6EFEA94D554D}"/>
+                <a16:creationId xmlns:a16="http://schemas.microsoft.com/office/drawing/2014/main" id="{7B65CD2D-2CFE-4233-ABD2-DFB9C131FBFB}"/>
               </a:ext>
             </a:extLst>
           </p:cNvPr>
@@ -3206,7 +3206,7 @@
           <p:cNvPr id="15" name="Google Shape;15;p3">
             <a:extLst xmlns:a="http://schemas.openxmlformats.org/drawingml/2006/main">
               <a:ext uri="{FF2B5EF4-FFF2-40B4-BE49-F238E27FC236}">
-                <a16:creationId xmlns:a16="http://schemas.microsoft.com/office/drawing/2014/main" id="{CB284492-776B-46B2-B4CE-6B4C0A0D85CA}"/>
+                <a16:creationId xmlns:a16="http://schemas.microsoft.com/office/drawing/2014/main" id="{9AD4E5EF-B54B-442D-8501-903A770DCFDB}"/>
               </a:ext>
             </a:extLst>
           </p:cNvPr>
@@ -3307,7 +3307,7 @@
           <p:cNvPr id="17" name="Google Shape;17;p4">
             <a:extLst xmlns:a="http://schemas.openxmlformats.org/drawingml/2006/main">
               <a:ext uri="{FF2B5EF4-FFF2-40B4-BE49-F238E27FC236}">
-                <a16:creationId xmlns:a16="http://schemas.microsoft.com/office/drawing/2014/main" id="{109EDCE1-B369-4AAE-A8AF-61E9D52A750C}"/>
+                <a16:creationId xmlns:a16="http://schemas.microsoft.com/office/drawing/2014/main" id="{92FDA42B-3A54-4829-AA78-170BE8A60213}"/>
               </a:ext>
             </a:extLst>
           </p:cNvPr>
@@ -3440,7 +3440,7 @@
           <p:cNvPr id="18" name="Google Shape;18;p4">
             <a:extLst xmlns:a="http://schemas.openxmlformats.org/drawingml/2006/main">
               <a:ext uri="{FF2B5EF4-FFF2-40B4-BE49-F238E27FC236}">
-                <a16:creationId xmlns:a16="http://schemas.microsoft.com/office/drawing/2014/main" id="{E8634F05-5903-437C-8E7C-84E8EA7D142D}"/>
+                <a16:creationId xmlns:a16="http://schemas.microsoft.com/office/drawing/2014/main" id="{ABB5A5B9-5B18-4AFF-8DD8-D7E26176F8A0}"/>
               </a:ext>
             </a:extLst>
           </p:cNvPr>
@@ -3573,7 +3573,7 @@
           <p:cNvPr id="19" name="Google Shape;19;p4">
             <a:extLst xmlns:a="http://schemas.openxmlformats.org/drawingml/2006/main">
               <a:ext uri="{FF2B5EF4-FFF2-40B4-BE49-F238E27FC236}">
-                <a16:creationId xmlns:a16="http://schemas.microsoft.com/office/drawing/2014/main" id="{E864B08C-9FE9-4D0E-AB66-3AD970C351AA}"/>
+                <a16:creationId xmlns:a16="http://schemas.microsoft.com/office/drawing/2014/main" id="{3CD27DC8-0758-4DB6-98FD-E540CF29AB24}"/>
               </a:ext>
             </a:extLst>
           </p:cNvPr>
@@ -3674,7 +3674,7 @@
           <p:cNvPr id="21" name="Google Shape;21;p5">
             <a:extLst xmlns:a="http://schemas.openxmlformats.org/drawingml/2006/main">
               <a:ext uri="{FF2B5EF4-FFF2-40B4-BE49-F238E27FC236}">
-                <a16:creationId xmlns:a16="http://schemas.microsoft.com/office/drawing/2014/main" id="{E622D5ED-2024-477F-AFCD-8D6452994B88}"/>
+                <a16:creationId xmlns:a16="http://schemas.microsoft.com/office/drawing/2014/main" id="{BDED9EC1-A381-47A0-AA21-4150D1204940}"/>
               </a:ext>
             </a:extLst>
           </p:cNvPr>
@@ -3807,7 +3807,7 @@
           <p:cNvPr id="22" name="Google Shape;22;p5">
             <a:extLst xmlns:a="http://schemas.openxmlformats.org/drawingml/2006/main">
               <a:ext uri="{FF2B5EF4-FFF2-40B4-BE49-F238E27FC236}">
-                <a16:creationId xmlns:a16="http://schemas.microsoft.com/office/drawing/2014/main" id="{1B826FCF-D7EF-497D-81EB-720D377A2DCD}"/>
+                <a16:creationId xmlns:a16="http://schemas.microsoft.com/office/drawing/2014/main" id="{3556C3D6-DE3A-4844-AACC-3EEFBECF8173}"/>
               </a:ext>
             </a:extLst>
           </p:cNvPr>
@@ -3940,7 +3940,7 @@
           <p:cNvPr id="23" name="Google Shape;23;p5">
             <a:extLst xmlns:a="http://schemas.openxmlformats.org/drawingml/2006/main">
               <a:ext uri="{FF2B5EF4-FFF2-40B4-BE49-F238E27FC236}">
-                <a16:creationId xmlns:a16="http://schemas.microsoft.com/office/drawing/2014/main" id="{2FC29F33-68B7-46B7-A916-7035A6ED3DF9}"/>
+                <a16:creationId xmlns:a16="http://schemas.microsoft.com/office/drawing/2014/main" id="{D937BE37-28A2-46AD-B9E2-4919AC8199D5}"/>
               </a:ext>
             </a:extLst>
           </p:cNvPr>
@@ -4073,7 +4073,7 @@
           <p:cNvPr id="24" name="Google Shape;24;p5">
             <a:extLst xmlns:a="http://schemas.openxmlformats.org/drawingml/2006/main">
               <a:ext uri="{FF2B5EF4-FFF2-40B4-BE49-F238E27FC236}">
-                <a16:creationId xmlns:a16="http://schemas.microsoft.com/office/drawing/2014/main" id="{01B627EA-53D2-4A5B-96E6-2A9FA399181C}"/>
+                <a16:creationId xmlns:a16="http://schemas.microsoft.com/office/drawing/2014/main" id="{39A4E475-4FC0-4A74-812F-BCA6A0D470F5}"/>
               </a:ext>
             </a:extLst>
           </p:cNvPr>
@@ -4174,7 +4174,7 @@
           <p:cNvPr id="26" name="Google Shape;26;p6">
             <a:extLst xmlns:a="http://schemas.openxmlformats.org/drawingml/2006/main">
               <a:ext uri="{FF2B5EF4-FFF2-40B4-BE49-F238E27FC236}">
-                <a16:creationId xmlns:a16="http://schemas.microsoft.com/office/drawing/2014/main" id="{AE21253E-B99E-4A0C-96C5-8E3714CB4147}"/>
+                <a16:creationId xmlns:a16="http://schemas.microsoft.com/office/drawing/2014/main" id="{1F882063-9C96-4B2E-907A-48E926BE2FC0}"/>
               </a:ext>
             </a:extLst>
           </p:cNvPr>
@@ -4307,7 +4307,7 @@
           <p:cNvPr id="27" name="Google Shape;27;p6">
             <a:extLst xmlns:a="http://schemas.openxmlformats.org/drawingml/2006/main">
               <a:ext uri="{FF2B5EF4-FFF2-40B4-BE49-F238E27FC236}">
-                <a16:creationId xmlns:a16="http://schemas.microsoft.com/office/drawing/2014/main" id="{45C4082D-0016-4F68-AB8D-6207C2EAE35D}"/>
+                <a16:creationId xmlns:a16="http://schemas.microsoft.com/office/drawing/2014/main" id="{DFC0E5E0-7B42-4B2F-8AB6-A22250EFFA94}"/>
               </a:ext>
             </a:extLst>
           </p:cNvPr>
@@ -4408,7 +4408,7 @@
           <p:cNvPr id="29" name="Google Shape;29;p7">
             <a:extLst xmlns:a="http://schemas.openxmlformats.org/drawingml/2006/main">
               <a:ext uri="{FF2B5EF4-FFF2-40B4-BE49-F238E27FC236}">
-                <a16:creationId xmlns:a16="http://schemas.microsoft.com/office/drawing/2014/main" id="{9D671EEE-5D5B-466F-8AD7-836C3D1CFFA7}"/>
+                <a16:creationId xmlns:a16="http://schemas.microsoft.com/office/drawing/2014/main" id="{15123CA7-5256-46EB-A850-437645CFBA01}"/>
               </a:ext>
             </a:extLst>
           </p:cNvPr>
@@ -4541,7 +4541,7 @@
           <p:cNvPr id="30" name="Google Shape;30;p7">
             <a:extLst xmlns:a="http://schemas.openxmlformats.org/drawingml/2006/main">
               <a:ext uri="{FF2B5EF4-FFF2-40B4-BE49-F238E27FC236}">
-                <a16:creationId xmlns:a16="http://schemas.microsoft.com/office/drawing/2014/main" id="{937E675B-A496-4F10-9045-FC958B1AF0AA}"/>
+                <a16:creationId xmlns:a16="http://schemas.microsoft.com/office/drawing/2014/main" id="{04569416-24E1-4600-83B0-9A4ABE94E4BD}"/>
               </a:ext>
             </a:extLst>
           </p:cNvPr>
@@ -4674,7 +4674,7 @@
           <p:cNvPr id="31" name="Google Shape;31;p7">
             <a:extLst xmlns:a="http://schemas.openxmlformats.org/drawingml/2006/main">
               <a:ext uri="{FF2B5EF4-FFF2-40B4-BE49-F238E27FC236}">
-                <a16:creationId xmlns:a16="http://schemas.microsoft.com/office/drawing/2014/main" id="{259D788D-BD51-47AF-BC5F-CDF07CC980BE}"/>
+                <a16:creationId xmlns:a16="http://schemas.microsoft.com/office/drawing/2014/main" id="{037248C8-CCA5-4CEA-B4D3-18DB751ACD1A}"/>
               </a:ext>
             </a:extLst>
           </p:cNvPr>
@@ -4775,7 +4775,7 @@
           <p:cNvPr id="33" name="Google Shape;33;p8">
             <a:extLst xmlns:a="http://schemas.openxmlformats.org/drawingml/2006/main">
               <a:ext uri="{FF2B5EF4-FFF2-40B4-BE49-F238E27FC236}">
-                <a16:creationId xmlns:a16="http://schemas.microsoft.com/office/drawing/2014/main" id="{3EF9F911-EF32-4061-AD7E-60228E1F2974}"/>
+                <a16:creationId xmlns:a16="http://schemas.microsoft.com/office/drawing/2014/main" id="{E2633E06-753B-4DA3-8D62-07CE0253787E}"/>
               </a:ext>
             </a:extLst>
           </p:cNvPr>
@@ -4908,7 +4908,7 @@
           <p:cNvPr id="34" name="Google Shape;34;p8">
             <a:extLst xmlns:a="http://schemas.openxmlformats.org/drawingml/2006/main">
               <a:ext uri="{FF2B5EF4-FFF2-40B4-BE49-F238E27FC236}">
-                <a16:creationId xmlns:a16="http://schemas.microsoft.com/office/drawing/2014/main" id="{F2FC9DA6-BCD1-49BF-9749-0299D24042AA}"/>
+                <a16:creationId xmlns:a16="http://schemas.microsoft.com/office/drawing/2014/main" id="{F1BD41E9-5067-45A8-9D87-C11C0E6D78B7}"/>
               </a:ext>
             </a:extLst>
           </p:cNvPr>
@@ -5009,7 +5009,7 @@
           <p:cNvPr id="36" name="Google Shape;36;p9">
             <a:extLst xmlns:a="http://schemas.openxmlformats.org/drawingml/2006/main">
               <a:ext uri="{FF2B5EF4-FFF2-40B4-BE49-F238E27FC236}">
-                <a16:creationId xmlns:a16="http://schemas.microsoft.com/office/drawing/2014/main" id="{D0249554-1624-4596-9C39-90CCA7E2A6C2}"/>
+                <a16:creationId xmlns:a16="http://schemas.microsoft.com/office/drawing/2014/main" id="{AB7A6285-A83B-4419-8435-E8627C6F8C4F}"/>
               </a:ext>
             </a:extLst>
           </p:cNvPr>
@@ -5060,7 +5060,7 @@
           <p:cNvPr id="37" name="Google Shape;37;p9">
             <a:extLst xmlns:a="http://schemas.openxmlformats.org/drawingml/2006/main">
               <a:ext uri="{FF2B5EF4-FFF2-40B4-BE49-F238E27FC236}">
-                <a16:creationId xmlns:a16="http://schemas.microsoft.com/office/drawing/2014/main" id="{414DC930-450A-4516-992C-37A892C826C5}"/>
+                <a16:creationId xmlns:a16="http://schemas.microsoft.com/office/drawing/2014/main" id="{B347CCF6-ED9C-4DC6-9AE3-B3A23A2C3317}"/>
               </a:ext>
             </a:extLst>
           </p:cNvPr>
@@ -5193,7 +5193,7 @@
           <p:cNvPr id="38" name="Google Shape;38;p9">
             <a:extLst xmlns:a="http://schemas.openxmlformats.org/drawingml/2006/main">
               <a:ext uri="{FF2B5EF4-FFF2-40B4-BE49-F238E27FC236}">
-                <a16:creationId xmlns:a16="http://schemas.microsoft.com/office/drawing/2014/main" id="{BA41C374-B534-48D1-9813-B94AB3F6FCE7}"/>
+                <a16:creationId xmlns:a16="http://schemas.microsoft.com/office/drawing/2014/main" id="{C6555059-27E2-48F2-BCF9-1179A34F04FC}"/>
               </a:ext>
             </a:extLst>
           </p:cNvPr>
@@ -5353,7 +5353,7 @@
           <p:cNvPr id="39" name="Google Shape;39;p9">
             <a:extLst xmlns:a="http://schemas.openxmlformats.org/drawingml/2006/main">
               <a:ext uri="{FF2B5EF4-FFF2-40B4-BE49-F238E27FC236}">
-                <a16:creationId xmlns:a16="http://schemas.microsoft.com/office/drawing/2014/main" id="{69465A11-0663-4DDB-B8AA-9F2B4A220D5A}"/>
+                <a16:creationId xmlns:a16="http://schemas.microsoft.com/office/drawing/2014/main" id="{299CC320-FD3E-4A25-8120-DAA1C8F8E3D4}"/>
               </a:ext>
             </a:extLst>
           </p:cNvPr>
@@ -5486,7 +5486,7 @@
           <p:cNvPr id="40" name="Google Shape;40;p9">
             <a:extLst xmlns:a="http://schemas.openxmlformats.org/drawingml/2006/main">
               <a:ext uri="{FF2B5EF4-FFF2-40B4-BE49-F238E27FC236}">
-                <a16:creationId xmlns:a16="http://schemas.microsoft.com/office/drawing/2014/main" id="{53FC7DD8-BB2B-4EAD-966B-341305D3C78B}"/>
+                <a16:creationId xmlns:a16="http://schemas.microsoft.com/office/drawing/2014/main" id="{0EFB2C06-207A-465F-958D-F11957DC3C74}"/>
               </a:ext>
             </a:extLst>
           </p:cNvPr>
@@ -5587,7 +5587,7 @@
           <p:cNvPr id="42" name="Google Shape;42;p10">
             <a:extLst xmlns:a="http://schemas.openxmlformats.org/drawingml/2006/main">
               <a:ext uri="{FF2B5EF4-FFF2-40B4-BE49-F238E27FC236}">
-                <a16:creationId xmlns:a16="http://schemas.microsoft.com/office/drawing/2014/main" id="{8EA01A42-73DF-49FC-93D6-CA3639E7F862}"/>
+                <a16:creationId xmlns:a16="http://schemas.microsoft.com/office/drawing/2014/main" id="{10494E5A-5F02-4CFC-859A-A6B99C8817D5}"/>
               </a:ext>
             </a:extLst>
           </p:cNvPr>
@@ -5635,7 +5635,7 @@
           <p:cNvPr id="43" name="Google Shape;43;p10">
             <a:extLst xmlns:a="http://schemas.openxmlformats.org/drawingml/2006/main">
               <a:ext uri="{FF2B5EF4-FFF2-40B4-BE49-F238E27FC236}">
-                <a16:creationId xmlns:a16="http://schemas.microsoft.com/office/drawing/2014/main" id="{B7578B01-A7E6-4BD1-A086-E582095E9D60}"/>
+                <a16:creationId xmlns:a16="http://schemas.microsoft.com/office/drawing/2014/main" id="{FECDD505-7A8D-4B73-815E-84280C762962}"/>
               </a:ext>
             </a:extLst>
           </p:cNvPr>
@@ -5743,7 +5743,7 @@
           <p:cNvPr id="6" name="Google Shape;6;p1">
             <a:extLst xmlns:a="http://schemas.openxmlformats.org/drawingml/2006/main">
               <a:ext uri="{FF2B5EF4-FFF2-40B4-BE49-F238E27FC236}">
-                <a16:creationId xmlns:a16="http://schemas.microsoft.com/office/drawing/2014/main" id="{0EFCBB53-B41E-44F3-8E6A-C549651C410D}"/>
+                <a16:creationId xmlns:a16="http://schemas.microsoft.com/office/drawing/2014/main" id="{732F8306-F31E-4657-905D-20F3518A8805}"/>
               </a:ext>
             </a:extLst>
           </p:cNvPr>
@@ -5943,7 +5943,7 @@
           <p:cNvPr id="7" name="Google Shape;7;p1">
             <a:extLst xmlns:a="http://schemas.openxmlformats.org/drawingml/2006/main">
               <a:ext uri="{FF2B5EF4-FFF2-40B4-BE49-F238E27FC236}">
-                <a16:creationId xmlns:a16="http://schemas.microsoft.com/office/drawing/2014/main" id="{E848B7C7-CAFD-4EFE-BE6D-4E3A16A35A2C}"/>
+                <a16:creationId xmlns:a16="http://schemas.microsoft.com/office/drawing/2014/main" id="{FF1849E6-67EF-4FE3-B011-36C6CCFFBEA8}"/>
               </a:ext>
             </a:extLst>
           </p:cNvPr>
@@ -6170,7 +6170,7 @@
           <p:cNvPr id="8" name="Google Shape;8;p1">
             <a:extLst xmlns:a="http://schemas.openxmlformats.org/drawingml/2006/main">
               <a:ext uri="{FF2B5EF4-FFF2-40B4-BE49-F238E27FC236}">
-                <a16:creationId xmlns:a16="http://schemas.microsoft.com/office/drawing/2014/main" id="{F20CAF77-BCA6-47CD-80D9-82D4B92B45D0}"/>
+                <a16:creationId xmlns:a16="http://schemas.microsoft.com/office/drawing/2014/main" id="{1FE367D2-E7C6-4040-94F0-62A9E6E6BDB9}"/>
               </a:ext>
             </a:extLst>
           </p:cNvPr>
@@ -6293,17 +6293,17 @@
   </p:cSld>
   <p:clrMap bg1="lt1" tx1="dk1" bg2="dk2" tx2="lt2" accent1="accent1" accent2="accent2" accent3="accent3" accent4="accent4" accent5="accent5" accent6="accent6" hlink="hlink" folHlink="folHlink"/>
   <p:sldLayoutIdLst>
-    <p:sldLayoutId xmlns:r="http://schemas.openxmlformats.org/officeDocument/2006/relationships" id="2147483649" r:id="R3ec5049798fe47c5"/>
-    <p:sldLayoutId xmlns:r="http://schemas.openxmlformats.org/officeDocument/2006/relationships" id="2147483650" r:id="Rfc11ffc5247546b4"/>
-    <p:sldLayoutId xmlns:r="http://schemas.openxmlformats.org/officeDocument/2006/relationships" id="2147483651" r:id="R5e30ded6ff584d1c"/>
-    <p:sldLayoutId xmlns:r="http://schemas.openxmlformats.org/officeDocument/2006/relationships" id="2147483652" r:id="Rdb4e235436b945c4"/>
-    <p:sldLayoutId xmlns:r="http://schemas.openxmlformats.org/officeDocument/2006/relationships" id="2147483653" r:id="R0c324ef857b04c3d"/>
-    <p:sldLayoutId xmlns:r="http://schemas.openxmlformats.org/officeDocument/2006/relationships" id="2147483654" r:id="R1c728a70013f4f37"/>
-    <p:sldLayoutId xmlns:r="http://schemas.openxmlformats.org/officeDocument/2006/relationships" id="2147483655" r:id="R75ddff947f7b4559"/>
-    <p:sldLayoutId xmlns:r="http://schemas.openxmlformats.org/officeDocument/2006/relationships" id="2147483656" r:id="Ra07344390ced4a44"/>
-    <p:sldLayoutId xmlns:r="http://schemas.openxmlformats.org/officeDocument/2006/relationships" id="2147483657" r:id="Rd961991e81cc4981"/>
-    <p:sldLayoutId xmlns:r="http://schemas.openxmlformats.org/officeDocument/2006/relationships" id="2147483658" r:id="R76d03862a06c488a"/>
-    <p:sldLayoutId xmlns:r="http://schemas.openxmlformats.org/officeDocument/2006/relationships" id="2147483659" r:id="R5eb95af53b7e4b38"/>
+    <p:sldLayoutId xmlns:r="http://schemas.openxmlformats.org/officeDocument/2006/relationships" id="2147483649" r:id="R5680108837bb400e"/>
+    <p:sldLayoutId xmlns:r="http://schemas.openxmlformats.org/officeDocument/2006/relationships" id="2147483650" r:id="R06132917945a43aa"/>
+    <p:sldLayoutId xmlns:r="http://schemas.openxmlformats.org/officeDocument/2006/relationships" id="2147483651" r:id="R0146455d819f4cdb"/>
+    <p:sldLayoutId xmlns:r="http://schemas.openxmlformats.org/officeDocument/2006/relationships" id="2147483652" r:id="R5800a0357c474e9e"/>
+    <p:sldLayoutId xmlns:r="http://schemas.openxmlformats.org/officeDocument/2006/relationships" id="2147483653" r:id="R183b5e80cb6149d0"/>
+    <p:sldLayoutId xmlns:r="http://schemas.openxmlformats.org/officeDocument/2006/relationships" id="2147483654" r:id="R0968c25d588c4dd6"/>
+    <p:sldLayoutId xmlns:r="http://schemas.openxmlformats.org/officeDocument/2006/relationships" id="2147483655" r:id="Re443237a18284355"/>
+    <p:sldLayoutId xmlns:r="http://schemas.openxmlformats.org/officeDocument/2006/relationships" id="2147483656" r:id="R764be296915a4024"/>
+    <p:sldLayoutId xmlns:r="http://schemas.openxmlformats.org/officeDocument/2006/relationships" id="2147483657" r:id="Rdf4966de340b41d4"/>
+    <p:sldLayoutId xmlns:r="http://schemas.openxmlformats.org/officeDocument/2006/relationships" id="2147483658" r:id="Ra165bb629aad46a1"/>
+    <p:sldLayoutId xmlns:r="http://schemas.openxmlformats.org/officeDocument/2006/relationships" id="2147483659" r:id="R51795fccd3234c88"/>
   </p:sldLayoutIdLst>
   <p:hf sldNum="0" hdr="0" ftr="0" dt="0"/>
   <p:txStyles>
@@ -7250,7 +7250,7 @@
           <p:cNvPr id="54" name="Google Shape;54;p13">
             <a:extLst xmlns:a="http://schemas.openxmlformats.org/drawingml/2006/main">
               <a:ext uri="{FF2B5EF4-FFF2-40B4-BE49-F238E27FC236}">
-                <a16:creationId xmlns:a16="http://schemas.microsoft.com/office/drawing/2014/main" id="{B102BEC8-D15F-4479-8199-191E8152B355}"/>
+                <a16:creationId xmlns:a16="http://schemas.microsoft.com/office/drawing/2014/main" id="{B4B81E3E-C538-4580-8A05-111E6473B697}"/>
               </a:ext>
             </a:extLst>
           </p:cNvPr>
@@ -7422,7 +7422,7 @@
           <p:cNvPr id="55" name="Google Shape;55;p13">
             <a:extLst xmlns:a="http://schemas.openxmlformats.org/drawingml/2006/main">
               <a:ext uri="{FF2B5EF4-FFF2-40B4-BE49-F238E27FC236}">
-                <a16:creationId xmlns:a16="http://schemas.microsoft.com/office/drawing/2014/main" id="{E5061F6C-E24F-4132-A730-4948B3AEF860}"/>
+                <a16:creationId xmlns:a16="http://schemas.microsoft.com/office/drawing/2014/main" id="{7F2AD657-8E9E-4B74-9D74-9FEBA8A29B1A}"/>
               </a:ext>
             </a:extLst>
           </p:cNvPr>
@@ -7432,7 +7432,7 @@
           <p:nvPr/>
         </p:nvPicPr>
         <p:blipFill>
-          <a:blip xmlns:r="http://schemas.openxmlformats.org/officeDocument/2006/relationships" xmlns:a="http://schemas.openxmlformats.org/drawingml/2006/main" r:embed="Rb3a7151b04e04f88">
+          <a:blip xmlns:r="http://schemas.openxmlformats.org/officeDocument/2006/relationships" xmlns:a="http://schemas.openxmlformats.org/drawingml/2006/main" r:embed="R8acad5baa6c24dc3">
             <a:alphaModFix/>
           </a:blip>
           <a:stretch xmlns:a="http://schemas.openxmlformats.org/drawingml/2006/main">
@@ -7457,7 +7457,7 @@
           <p:cNvPr id="56" name="Google Shape;56;p13">
             <a:extLst xmlns:a="http://schemas.openxmlformats.org/drawingml/2006/main">
               <a:ext uri="{FF2B5EF4-FFF2-40B4-BE49-F238E27FC236}">
-                <a16:creationId xmlns:a16="http://schemas.microsoft.com/office/drawing/2014/main" id="{FC9BA43B-43C3-4CE4-9451-5C92139CDE66}"/>
+                <a16:creationId xmlns:a16="http://schemas.microsoft.com/office/drawing/2014/main" id="{E31463E0-43C2-4AB2-96F2-B491C58A61B9}"/>
               </a:ext>
             </a:extLst>
           </p:cNvPr>
@@ -7467,7 +7467,7 @@
           <p:nvPr/>
         </p:nvPicPr>
         <p:blipFill rotWithShape="1">
-          <a:blip xmlns:r="http://schemas.openxmlformats.org/officeDocument/2006/relationships" xmlns:a="http://schemas.openxmlformats.org/drawingml/2006/main" r:embed="R73438b77274d430b">
+          <a:blip xmlns:r="http://schemas.openxmlformats.org/officeDocument/2006/relationships" xmlns:a="http://schemas.openxmlformats.org/drawingml/2006/main" r:embed="R2b3961188cb64d1d">
             <a:alphaModFix/>
           </a:blip>
           <a:srcRect xmlns:a="http://schemas.openxmlformats.org/drawingml/2006/main" l="0" t="0" r="0" b="98001"/>
@@ -7489,7 +7489,7 @@
     </p:spTree>
     <p:extLst>
       <p:ext uri="{BB962C8B-B14F-4D97-AF65-F5344CB8AC3E}">
-        <p14:creationId xmlns:p14="http://schemas.microsoft.com/office/powerpoint/2010/main" val="1688802388"/>
+        <p14:creationId xmlns:p14="http://schemas.microsoft.com/office/powerpoint/2010/main" val="340458854"/>
       </p:ext>
     </p:extLst>
   </p:cSld>
@@ -7513,7 +7513,7 @@
           <p:cNvPr id="124" name="Google Shape;124;p22">
             <a:extLst xmlns:a="http://schemas.openxmlformats.org/drawingml/2006/main">
               <a:ext uri="{FF2B5EF4-FFF2-40B4-BE49-F238E27FC236}">
-                <a16:creationId xmlns:a16="http://schemas.microsoft.com/office/drawing/2014/main" id="{A2E08608-D639-4D1E-BC77-C8C2DE095014}"/>
+                <a16:creationId xmlns:a16="http://schemas.microsoft.com/office/drawing/2014/main" id="{61C952EB-7DEC-43A9-A069-703C8748C9B8}"/>
               </a:ext>
             </a:extLst>
           </p:cNvPr>
@@ -7523,7 +7523,7 @@
           <p:nvPr/>
         </p:nvPicPr>
         <p:blipFill rotWithShape="1">
-          <a:blip xmlns:r="http://schemas.openxmlformats.org/officeDocument/2006/relationships" xmlns:a="http://schemas.openxmlformats.org/drawingml/2006/main" r:embed="R5b714f4b9af54b16">
+          <a:blip xmlns:r="http://schemas.openxmlformats.org/officeDocument/2006/relationships" xmlns:a="http://schemas.openxmlformats.org/drawingml/2006/main" r:embed="R7b44e44cd16e417e">
             <a:alphaModFix/>
           </a:blip>
           <a:srcRect xmlns:a="http://schemas.openxmlformats.org/drawingml/2006/main" l="0" t="0" r="0" b="98001"/>
@@ -7547,7 +7547,7 @@
           <p:cNvPr id="125" name="Google Shape;125;p22">
             <a:extLst xmlns:a="http://schemas.openxmlformats.org/drawingml/2006/main">
               <a:ext uri="{FF2B5EF4-FFF2-40B4-BE49-F238E27FC236}">
-                <a16:creationId xmlns:a16="http://schemas.microsoft.com/office/drawing/2014/main" id="{1A5F8ED7-6C2E-458B-B8BC-66AF52EC2CB8}"/>
+                <a16:creationId xmlns:a16="http://schemas.microsoft.com/office/drawing/2014/main" id="{2E8F0EF7-E3B8-49C8-93CA-D8B9E022C958}"/>
               </a:ext>
             </a:extLst>
           </p:cNvPr>
@@ -7557,7 +7557,7 @@
           <p:nvPr/>
         </p:nvPicPr>
         <p:blipFill>
-          <a:blip xmlns:r="http://schemas.openxmlformats.org/officeDocument/2006/relationships" xmlns:a="http://schemas.openxmlformats.org/drawingml/2006/main" r:embed="Ra4932098ac0b4042">
+          <a:blip xmlns:r="http://schemas.openxmlformats.org/officeDocument/2006/relationships" xmlns:a="http://schemas.openxmlformats.org/drawingml/2006/main" r:embed="R727707cacceb482d">
             <a:alphaModFix/>
           </a:blip>
           <a:stretch xmlns:a="http://schemas.openxmlformats.org/drawingml/2006/main">
@@ -7582,7 +7582,7 @@
           <p:cNvPr id="126" name="Google Shape;126;p22">
             <a:extLst xmlns:a="http://schemas.openxmlformats.org/drawingml/2006/main">
               <a:ext uri="{FF2B5EF4-FFF2-40B4-BE49-F238E27FC236}">
-                <a16:creationId xmlns:a16="http://schemas.microsoft.com/office/drawing/2014/main" id="{FBAD6D83-F688-4778-BF50-648D4EAE9F37}"/>
+                <a16:creationId xmlns:a16="http://schemas.microsoft.com/office/drawing/2014/main" id="{C3100673-016B-4220-ADC4-817CD5F8F8B9}"/>
               </a:ext>
             </a:extLst>
           </p:cNvPr>
@@ -7633,7 +7633,7 @@
           <p:cNvPr id="127" name="Google Shape;127;p22">
             <a:extLst xmlns:a="http://schemas.openxmlformats.org/drawingml/2006/main">
               <a:ext uri="{FF2B5EF4-FFF2-40B4-BE49-F238E27FC236}">
-                <a16:creationId xmlns:a16="http://schemas.microsoft.com/office/drawing/2014/main" id="{63AFD14E-2D0E-4B30-98DC-B5AC02519E28}"/>
+                <a16:creationId xmlns:a16="http://schemas.microsoft.com/office/drawing/2014/main" id="{29575BFC-FA60-4280-BF88-839E267F8042}"/>
               </a:ext>
             </a:extLst>
           </p:cNvPr>
@@ -7713,7 +7713,7 @@
           <p:cNvPr id="128" name="">
             <a:extLst xmlns:a="http://schemas.openxmlformats.org/drawingml/2006/main">
               <a:ext uri="{FF2B5EF4-FFF2-40B4-BE49-F238E27FC236}">
-                <a16:creationId xmlns:a16="http://schemas.microsoft.com/office/drawing/2014/main" id="{BC1C934A-C6D9-4B0E-8E50-838B64DE32B1}"/>
+                <a16:creationId xmlns:a16="http://schemas.microsoft.com/office/drawing/2014/main" id="{33D8BF22-964C-4711-8815-FF5DAF9452EB}"/>
               </a:ext>
             </a:extLst>
           </p:cNvPr>
@@ -7781,7 +7781,7 @@
           <p:cNvPr id="129" name="">
             <a:extLst xmlns:a="http://schemas.openxmlformats.org/drawingml/2006/main">
               <a:ext uri="{FF2B5EF4-FFF2-40B4-BE49-F238E27FC236}">
-                <a16:creationId xmlns:a16="http://schemas.microsoft.com/office/drawing/2014/main" id="{6FD7F7F5-A635-4D1E-937E-EDB7425F2328}"/>
+                <a16:creationId xmlns:a16="http://schemas.microsoft.com/office/drawing/2014/main" id="{ED42E26D-8084-4E5A-9358-8534D84ABC03}"/>
               </a:ext>
             </a:extLst>
           </p:cNvPr>
@@ -8241,7 +8241,7 @@
           <p:cNvPr id="130" name="">
             <a:extLst xmlns:a="http://schemas.openxmlformats.org/drawingml/2006/main">
               <a:ext uri="{FF2B5EF4-FFF2-40B4-BE49-F238E27FC236}">
-                <a16:creationId xmlns:a16="http://schemas.microsoft.com/office/drawing/2014/main" id="{8885CDA5-BC0D-4356-BB74-7EDC691CD23F}"/>
+                <a16:creationId xmlns:a16="http://schemas.microsoft.com/office/drawing/2014/main" id="{E76C481A-E726-41F9-AF57-36E719B3A738}"/>
               </a:ext>
             </a:extLst>
           </p:cNvPr>
@@ -8309,7 +8309,7 @@
           <p:cNvPr id="131" name="">
             <a:extLst xmlns:a="http://schemas.openxmlformats.org/drawingml/2006/main">
               <a:ext uri="{FF2B5EF4-FFF2-40B4-BE49-F238E27FC236}">
-                <a16:creationId xmlns:a16="http://schemas.microsoft.com/office/drawing/2014/main" id="{DA1C339E-E7AF-4B91-97BF-853263190F08}"/>
+                <a16:creationId xmlns:a16="http://schemas.microsoft.com/office/drawing/2014/main" id="{E9FB4108-82C3-4B60-A309-A9F1EB3AB393}"/>
               </a:ext>
             </a:extLst>
           </p:cNvPr>
@@ -8367,7 +8367,7 @@
                 <a:ea typeface="Google Sans Flex"/>
                 <a:cs typeface="Google Sans Flex"/>
               </a:rPr>
-              <a:t>No fabricated spend, savings or cost-per-user claim.</a:t>
+              <a:t>Production pricing depends on measured usage and the selected provider services.</a:t>
             </a:r>
           </a:p>
         </p:txBody>
@@ -8377,7 +8377,7 @@
           <p:cNvPr id="132" name="">
             <a:extLst xmlns:a="http://schemas.openxmlformats.org/drawingml/2006/main">
               <a:ext uri="{FF2B5EF4-FFF2-40B4-BE49-F238E27FC236}">
-                <a16:creationId xmlns:a16="http://schemas.microsoft.com/office/drawing/2014/main" id="{8AC79F51-A99C-4E60-8AD6-2129C6A30C83}"/>
+                <a16:creationId xmlns:a16="http://schemas.microsoft.com/office/drawing/2014/main" id="{51294504-8C20-4F12-A411-81B9749C94C8}"/>
               </a:ext>
             </a:extLst>
           </p:cNvPr>
@@ -8443,7 +8443,7 @@
     </p:spTree>
     <p:extLst>
       <p:ext uri="{BB962C8B-B14F-4D97-AF65-F5344CB8AC3E}">
-        <p14:creationId xmlns:p14="http://schemas.microsoft.com/office/powerpoint/2010/main" val="374203403"/>
+        <p14:creationId xmlns:p14="http://schemas.microsoft.com/office/powerpoint/2010/main" val="1670269351"/>
       </p:ext>
     </p:extLst>
   </p:cSld>
@@ -8467,7 +8467,7 @@
           <p:cNvPr id="132" name="Google Shape;132;p23">
             <a:extLst xmlns:a="http://schemas.openxmlformats.org/drawingml/2006/main">
               <a:ext uri="{FF2B5EF4-FFF2-40B4-BE49-F238E27FC236}">
-                <a16:creationId xmlns:a16="http://schemas.microsoft.com/office/drawing/2014/main" id="{DD2C6964-2DE1-4CCE-8F22-53CCB922534B}"/>
+                <a16:creationId xmlns:a16="http://schemas.microsoft.com/office/drawing/2014/main" id="{BFCD118E-FC71-4F5F-A876-E723B9954B9B}"/>
               </a:ext>
             </a:extLst>
           </p:cNvPr>
@@ -8477,7 +8477,7 @@
           <p:nvPr/>
         </p:nvPicPr>
         <p:blipFill rotWithShape="1">
-          <a:blip xmlns:r="http://schemas.openxmlformats.org/officeDocument/2006/relationships" xmlns:a="http://schemas.openxmlformats.org/drawingml/2006/main" r:embed="Rc154c62b78f04db5">
+          <a:blip xmlns:r="http://schemas.openxmlformats.org/officeDocument/2006/relationships" xmlns:a="http://schemas.openxmlformats.org/drawingml/2006/main" r:embed="Rb084f2bb1d6841f2">
             <a:alphaModFix/>
           </a:blip>
           <a:srcRect xmlns:a="http://schemas.openxmlformats.org/drawingml/2006/main" l="0" t="0" r="0" b="98001"/>
@@ -8501,7 +8501,7 @@
           <p:cNvPr id="133" name="Google Shape;133;p23">
             <a:extLst xmlns:a="http://schemas.openxmlformats.org/drawingml/2006/main">
               <a:ext uri="{FF2B5EF4-FFF2-40B4-BE49-F238E27FC236}">
-                <a16:creationId xmlns:a16="http://schemas.microsoft.com/office/drawing/2014/main" id="{FE930594-9E4A-49C4-AAC6-FEC62E56DE9E}"/>
+                <a16:creationId xmlns:a16="http://schemas.microsoft.com/office/drawing/2014/main" id="{31396A44-0E78-4DA6-A316-45B004A0D07D}"/>
               </a:ext>
             </a:extLst>
           </p:cNvPr>
@@ -8511,7 +8511,7 @@
           <p:nvPr/>
         </p:nvPicPr>
         <p:blipFill>
-          <a:blip xmlns:r="http://schemas.openxmlformats.org/officeDocument/2006/relationships" xmlns:a="http://schemas.openxmlformats.org/drawingml/2006/main" r:embed="R80aa524fd3a64442">
+          <a:blip xmlns:r="http://schemas.openxmlformats.org/officeDocument/2006/relationships" xmlns:a="http://schemas.openxmlformats.org/drawingml/2006/main" r:embed="R143d0a1e6e2a4b25">
             <a:alphaModFix/>
           </a:blip>
           <a:stretch xmlns:a="http://schemas.openxmlformats.org/drawingml/2006/main">
@@ -8536,7 +8536,7 @@
           <p:cNvPr id="134" name="Google Shape;134;p23">
             <a:extLst xmlns:a="http://schemas.openxmlformats.org/drawingml/2006/main">
               <a:ext uri="{FF2B5EF4-FFF2-40B4-BE49-F238E27FC236}">
-                <a16:creationId xmlns:a16="http://schemas.microsoft.com/office/drawing/2014/main" id="{6D62F52C-6BC6-4C5B-92EF-2820F7396591}"/>
+                <a16:creationId xmlns:a16="http://schemas.microsoft.com/office/drawing/2014/main" id="{EFD92CEF-9F3E-4669-9C52-6F893E9E808F}"/>
               </a:ext>
             </a:extLst>
           </p:cNvPr>
@@ -8587,7 +8587,7 @@
           <p:cNvPr id="135" name="Google Shape;135;p23">
             <a:extLst xmlns:a="http://schemas.openxmlformats.org/drawingml/2006/main">
               <a:ext uri="{FF2B5EF4-FFF2-40B4-BE49-F238E27FC236}">
-                <a16:creationId xmlns:a16="http://schemas.microsoft.com/office/drawing/2014/main" id="{7E88970D-64B4-4CA3-A96D-9C0C5CE8367F}"/>
+                <a16:creationId xmlns:a16="http://schemas.microsoft.com/office/drawing/2014/main" id="{21A04D2B-0C70-4008-ACB0-4CC37A504095}"/>
               </a:ext>
             </a:extLst>
           </p:cNvPr>
@@ -8667,7 +8667,7 @@
           <p:cNvPr id="136" name="">
             <a:extLst xmlns:a="http://schemas.openxmlformats.org/drawingml/2006/main">
               <a:ext uri="{FF2B5EF4-FFF2-40B4-BE49-F238E27FC236}">
-                <a16:creationId xmlns:a16="http://schemas.microsoft.com/office/drawing/2014/main" id="{611B7A75-B3AB-45B6-ACFA-1FEC918FEF40}"/>
+                <a16:creationId xmlns:a16="http://schemas.microsoft.com/office/drawing/2014/main" id="{494FC534-4068-47EF-B454-C6F743F552D2}"/>
               </a:ext>
             </a:extLst>
           </p:cNvPr>
@@ -8677,7 +8677,7 @@
           <p:nvPr/>
         </p:nvPicPr>
         <p:blipFill>
-          <a:blip xmlns:r="http://schemas.openxmlformats.org/officeDocument/2006/relationships" xmlns:a="http://schemas.openxmlformats.org/drawingml/2006/main" r:embed="Rf5786dc7e59d4cd6"/>
+          <a:blip xmlns:r="http://schemas.openxmlformats.org/officeDocument/2006/relationships" xmlns:a="http://schemas.openxmlformats.org/drawingml/2006/main" r:embed="Rf3dc652c5b9b42c0"/>
           <a:srcRect xmlns:a="http://schemas.openxmlformats.org/drawingml/2006/main" l="0" t="24800" r="0" b="43000"/>
           <a:stretch xmlns:a="http://schemas.openxmlformats.org/drawingml/2006/main"/>
         </p:blipFill>
@@ -8696,7 +8696,7 @@
           <p:cNvPr id="137" name="">
             <a:extLst xmlns:a="http://schemas.openxmlformats.org/drawingml/2006/main">
               <a:ext uri="{FF2B5EF4-FFF2-40B4-BE49-F238E27FC236}">
-                <a16:creationId xmlns:a16="http://schemas.microsoft.com/office/drawing/2014/main" id="{BCA9183C-4521-49D7-B843-A09CCEBFE937}"/>
+                <a16:creationId xmlns:a16="http://schemas.microsoft.com/office/drawing/2014/main" id="{6193978F-6133-4C80-B8BD-D712FC89FBE5}"/>
               </a:ext>
             </a:extLst>
           </p:cNvPr>
@@ -8764,7 +8764,7 @@
           <p:cNvPr id="138" name="">
             <a:extLst xmlns:a="http://schemas.openxmlformats.org/drawingml/2006/main">
               <a:ext uri="{FF2B5EF4-FFF2-40B4-BE49-F238E27FC236}">
-                <a16:creationId xmlns:a16="http://schemas.microsoft.com/office/drawing/2014/main" id="{49DAC319-7BD8-4242-844F-68C32208A150}"/>
+                <a16:creationId xmlns:a16="http://schemas.microsoft.com/office/drawing/2014/main" id="{B51E215E-2B5B-4CE9-B331-0A351DEE9840}"/>
               </a:ext>
             </a:extLst>
           </p:cNvPr>
@@ -9224,7 +9224,7 @@
           <p:cNvPr id="139" name="">
             <a:extLst xmlns:a="http://schemas.openxmlformats.org/drawingml/2006/main">
               <a:ext uri="{FF2B5EF4-FFF2-40B4-BE49-F238E27FC236}">
-                <a16:creationId xmlns:a16="http://schemas.microsoft.com/office/drawing/2014/main" id="{1A8E304D-CE39-4AFE-8F00-4245A91EF0A6}"/>
+                <a16:creationId xmlns:a16="http://schemas.microsoft.com/office/drawing/2014/main" id="{A23A34BC-2B83-4624-9E7D-8A3AD0CD7832}"/>
               </a:ext>
             </a:extLst>
           </p:cNvPr>
@@ -9292,7 +9292,7 @@
           <p:cNvPr id="140" name="">
             <a:extLst xmlns:a="http://schemas.openxmlformats.org/drawingml/2006/main">
               <a:ext uri="{FF2B5EF4-FFF2-40B4-BE49-F238E27FC236}">
-                <a16:creationId xmlns:a16="http://schemas.microsoft.com/office/drawing/2014/main" id="{CCA93FD9-1B76-4375-AF8A-EC2D87D7743E}"/>
+                <a16:creationId xmlns:a16="http://schemas.microsoft.com/office/drawing/2014/main" id="{AA8A8179-4BF9-4351-AD81-53DCBB259BD6}"/>
               </a:ext>
             </a:extLst>
           </p:cNvPr>
@@ -9360,7 +9360,7 @@
           <p:cNvPr id="141" name="">
             <a:extLst xmlns:a="http://schemas.openxmlformats.org/drawingml/2006/main">
               <a:ext uri="{FF2B5EF4-FFF2-40B4-BE49-F238E27FC236}">
-                <a16:creationId xmlns:a16="http://schemas.microsoft.com/office/drawing/2014/main" id="{D61F092B-84F3-4729-8728-76F41D985512}"/>
+                <a16:creationId xmlns:a16="http://schemas.microsoft.com/office/drawing/2014/main" id="{163109CA-A258-4F15-813E-4CDF156FA81F}"/>
               </a:ext>
             </a:extLst>
           </p:cNvPr>
@@ -9426,7 +9426,7 @@
     </p:spTree>
     <p:extLst>
       <p:ext uri="{BB962C8B-B14F-4D97-AF65-F5344CB8AC3E}">
-        <p14:creationId xmlns:p14="http://schemas.microsoft.com/office/powerpoint/2010/main" val="773178084"/>
+        <p14:creationId xmlns:p14="http://schemas.microsoft.com/office/powerpoint/2010/main" val="414888396"/>
       </p:ext>
     </p:extLst>
   </p:cSld>
@@ -9450,7 +9450,7 @@
           <p:cNvPr id="140" name="Google Shape;140;p24">
             <a:extLst xmlns:a="http://schemas.openxmlformats.org/drawingml/2006/main">
               <a:ext uri="{FF2B5EF4-FFF2-40B4-BE49-F238E27FC236}">
-                <a16:creationId xmlns:a16="http://schemas.microsoft.com/office/drawing/2014/main" id="{7E0E8FF1-A5EA-43F7-B4C8-7C4782C5D528}"/>
+                <a16:creationId xmlns:a16="http://schemas.microsoft.com/office/drawing/2014/main" id="{631B9865-2170-4F84-A092-D6EF51629149}"/>
               </a:ext>
             </a:extLst>
           </p:cNvPr>
@@ -9460,7 +9460,7 @@
           <p:nvPr/>
         </p:nvPicPr>
         <p:blipFill rotWithShape="1">
-          <a:blip xmlns:r="http://schemas.openxmlformats.org/officeDocument/2006/relationships" xmlns:a="http://schemas.openxmlformats.org/drawingml/2006/main" r:embed="R47484e6e009a4f49">
+          <a:blip xmlns:r="http://schemas.openxmlformats.org/officeDocument/2006/relationships" xmlns:a="http://schemas.openxmlformats.org/drawingml/2006/main" r:embed="R3c1ba07653ac4e43">
             <a:alphaModFix/>
           </a:blip>
           <a:srcRect xmlns:a="http://schemas.openxmlformats.org/drawingml/2006/main" l="0" t="0" r="0" b="98001"/>
@@ -9484,7 +9484,7 @@
           <p:cNvPr id="141" name="Google Shape;141;p24">
             <a:extLst xmlns:a="http://schemas.openxmlformats.org/drawingml/2006/main">
               <a:ext uri="{FF2B5EF4-FFF2-40B4-BE49-F238E27FC236}">
-                <a16:creationId xmlns:a16="http://schemas.microsoft.com/office/drawing/2014/main" id="{AA585BAB-5F9F-4818-9CA1-9F025C5CEA68}"/>
+                <a16:creationId xmlns:a16="http://schemas.microsoft.com/office/drawing/2014/main" id="{B7200179-C3D7-470A-9BEE-5851B3DABD6A}"/>
               </a:ext>
             </a:extLst>
           </p:cNvPr>
@@ -9494,7 +9494,7 @@
           <p:nvPr/>
         </p:nvPicPr>
         <p:blipFill>
-          <a:blip xmlns:r="http://schemas.openxmlformats.org/officeDocument/2006/relationships" xmlns:a="http://schemas.openxmlformats.org/drawingml/2006/main" r:embed="Re953540ee6414941">
+          <a:blip xmlns:r="http://schemas.openxmlformats.org/officeDocument/2006/relationships" xmlns:a="http://schemas.openxmlformats.org/drawingml/2006/main" r:embed="R1ee6bbc52a234c7d">
             <a:alphaModFix/>
           </a:blip>
           <a:stretch xmlns:a="http://schemas.openxmlformats.org/drawingml/2006/main">
@@ -9519,7 +9519,7 @@
           <p:cNvPr id="142" name="Google Shape;142;p24">
             <a:extLst xmlns:a="http://schemas.openxmlformats.org/drawingml/2006/main">
               <a:ext uri="{FF2B5EF4-FFF2-40B4-BE49-F238E27FC236}">
-                <a16:creationId xmlns:a16="http://schemas.microsoft.com/office/drawing/2014/main" id="{2347DD84-CB94-425E-8EBC-7E57B00F25AC}"/>
+                <a16:creationId xmlns:a16="http://schemas.microsoft.com/office/drawing/2014/main" id="{80138F10-D7C8-448A-9B4E-B0DA99B8D577}"/>
               </a:ext>
             </a:extLst>
           </p:cNvPr>
@@ -9570,7 +9570,7 @@
           <p:cNvPr id="143" name="Google Shape;143;p24">
             <a:extLst xmlns:a="http://schemas.openxmlformats.org/drawingml/2006/main">
               <a:ext uri="{FF2B5EF4-FFF2-40B4-BE49-F238E27FC236}">
-                <a16:creationId xmlns:a16="http://schemas.microsoft.com/office/drawing/2014/main" id="{2D50441F-49D7-4CFE-8837-6B5F9AB5D388}"/>
+                <a16:creationId xmlns:a16="http://schemas.microsoft.com/office/drawing/2014/main" id="{9D989415-2ECD-461B-9582-18744E364E35}"/>
               </a:ext>
             </a:extLst>
           </p:cNvPr>
@@ -9650,7 +9650,7 @@
           <p:cNvPr id="144" name="">
             <a:extLst xmlns:a="http://schemas.openxmlformats.org/drawingml/2006/main">
               <a:ext uri="{FF2B5EF4-FFF2-40B4-BE49-F238E27FC236}">
-                <a16:creationId xmlns:a16="http://schemas.microsoft.com/office/drawing/2014/main" id="{A7EA9D9D-8AB8-4327-94FD-94307E13A27C}"/>
+                <a16:creationId xmlns:a16="http://schemas.microsoft.com/office/drawing/2014/main" id="{5E384E1B-6F1E-4BF0-83E1-5EF07CA8E026}"/>
               </a:ext>
             </a:extLst>
           </p:cNvPr>
@@ -10194,7 +10194,7 @@
           <p:cNvPr id="145" name="">
             <a:extLst xmlns:a="http://schemas.openxmlformats.org/drawingml/2006/main">
               <a:ext uri="{FF2B5EF4-FFF2-40B4-BE49-F238E27FC236}">
-                <a16:creationId xmlns:a16="http://schemas.microsoft.com/office/drawing/2014/main" id="{70A0E621-9E86-4CAB-B93B-08A25FF57271}"/>
+                <a16:creationId xmlns:a16="http://schemas.microsoft.com/office/drawing/2014/main" id="{102E74DB-7DF8-4A0D-984C-BA0415604DB2}"/>
               </a:ext>
             </a:extLst>
           </p:cNvPr>
@@ -10262,7 +10262,7 @@
           <p:cNvPr id="146" name="">
             <a:extLst xmlns:a="http://schemas.openxmlformats.org/drawingml/2006/main">
               <a:ext uri="{FF2B5EF4-FFF2-40B4-BE49-F238E27FC236}">
-                <a16:creationId xmlns:a16="http://schemas.microsoft.com/office/drawing/2014/main" id="{D8AD7F06-FDAC-4964-961C-88F7E9591E69}"/>
+                <a16:creationId xmlns:a16="http://schemas.microsoft.com/office/drawing/2014/main" id="{BCC17936-609D-4B4F-A0FA-F4BEDAA62FA3}"/>
               </a:ext>
             </a:extLst>
           </p:cNvPr>
@@ -10330,7 +10330,7 @@
           <p:cNvPr id="147" name="">
             <a:extLst xmlns:a="http://schemas.openxmlformats.org/drawingml/2006/main">
               <a:ext uri="{FF2B5EF4-FFF2-40B4-BE49-F238E27FC236}">
-                <a16:creationId xmlns:a16="http://schemas.microsoft.com/office/drawing/2014/main" id="{B3CBCF6A-0912-4ABF-930A-63B53AB126B9}"/>
+                <a16:creationId xmlns:a16="http://schemas.microsoft.com/office/drawing/2014/main" id="{0FE11053-50DF-49E3-AEA8-8BCD94B95D33}"/>
               </a:ext>
             </a:extLst>
           </p:cNvPr>
@@ -10396,7 +10396,7 @@
     </p:spTree>
     <p:extLst>
       <p:ext uri="{BB962C8B-B14F-4D97-AF65-F5344CB8AC3E}">
-        <p14:creationId xmlns:p14="http://schemas.microsoft.com/office/powerpoint/2010/main" val="1533216453"/>
+        <p14:creationId xmlns:p14="http://schemas.microsoft.com/office/powerpoint/2010/main" val="571021746"/>
       </p:ext>
     </p:extLst>
   </p:cSld>
@@ -10420,7 +10420,7 @@
           <p:cNvPr id="148" name="Google Shape;148;p25">
             <a:extLst xmlns:a="http://schemas.openxmlformats.org/drawingml/2006/main">
               <a:ext uri="{FF2B5EF4-FFF2-40B4-BE49-F238E27FC236}">
-                <a16:creationId xmlns:a16="http://schemas.microsoft.com/office/drawing/2014/main" id="{F41AC84B-B436-4FCF-AFD2-4D14FAB4529A}"/>
+                <a16:creationId xmlns:a16="http://schemas.microsoft.com/office/drawing/2014/main" id="{C6173731-C4D1-4173-A786-642E316D03CC}"/>
               </a:ext>
             </a:extLst>
           </p:cNvPr>
@@ -10430,7 +10430,7 @@
           <p:nvPr/>
         </p:nvPicPr>
         <p:blipFill rotWithShape="1">
-          <a:blip xmlns:r="http://schemas.openxmlformats.org/officeDocument/2006/relationships" xmlns:a="http://schemas.openxmlformats.org/drawingml/2006/main" r:embed="R84bec60d90b246cb">
+          <a:blip xmlns:r="http://schemas.openxmlformats.org/officeDocument/2006/relationships" xmlns:a="http://schemas.openxmlformats.org/drawingml/2006/main" r:embed="R7a6e21f3a53a4498">
             <a:alphaModFix/>
           </a:blip>
           <a:srcRect xmlns:a="http://schemas.openxmlformats.org/drawingml/2006/main" l="0" t="0" r="0" b="98001"/>
@@ -10454,7 +10454,7 @@
           <p:cNvPr id="149" name="Google Shape;149;p25">
             <a:extLst xmlns:a="http://schemas.openxmlformats.org/drawingml/2006/main">
               <a:ext uri="{FF2B5EF4-FFF2-40B4-BE49-F238E27FC236}">
-                <a16:creationId xmlns:a16="http://schemas.microsoft.com/office/drawing/2014/main" id="{A020E908-8679-4A29-B566-45FC0765349D}"/>
+                <a16:creationId xmlns:a16="http://schemas.microsoft.com/office/drawing/2014/main" id="{9D5060C5-5CC3-48FE-B350-5BF36463EA71}"/>
               </a:ext>
             </a:extLst>
           </p:cNvPr>
@@ -10464,7 +10464,7 @@
           <p:nvPr/>
         </p:nvPicPr>
         <p:blipFill>
-          <a:blip xmlns:r="http://schemas.openxmlformats.org/officeDocument/2006/relationships" xmlns:a="http://schemas.openxmlformats.org/drawingml/2006/main" r:embed="R58a8180c2ae4484c">
+          <a:blip xmlns:r="http://schemas.openxmlformats.org/officeDocument/2006/relationships" xmlns:a="http://schemas.openxmlformats.org/drawingml/2006/main" r:embed="R84c633dc7a3b4017">
             <a:alphaModFix/>
           </a:blip>
           <a:stretch xmlns:a="http://schemas.openxmlformats.org/drawingml/2006/main">
@@ -10489,7 +10489,7 @@
           <p:cNvPr id="150" name="Google Shape;150;p25">
             <a:extLst xmlns:a="http://schemas.openxmlformats.org/drawingml/2006/main">
               <a:ext uri="{FF2B5EF4-FFF2-40B4-BE49-F238E27FC236}">
-                <a16:creationId xmlns:a16="http://schemas.microsoft.com/office/drawing/2014/main" id="{7515320E-57D8-45D2-B1E8-D3239FE2851E}"/>
+                <a16:creationId xmlns:a16="http://schemas.microsoft.com/office/drawing/2014/main" id="{8D035A79-20A5-4EC4-A017-B869D77C491B}"/>
               </a:ext>
             </a:extLst>
           </p:cNvPr>
@@ -10540,7 +10540,7 @@
           <p:cNvPr id="151" name="Google Shape;151;p25">
             <a:extLst xmlns:a="http://schemas.openxmlformats.org/drawingml/2006/main">
               <a:ext uri="{FF2B5EF4-FFF2-40B4-BE49-F238E27FC236}">
-                <a16:creationId xmlns:a16="http://schemas.microsoft.com/office/drawing/2014/main" id="{19BC8E99-E0AC-437F-AD87-AFB1ADF578B6}"/>
+                <a16:creationId xmlns:a16="http://schemas.microsoft.com/office/drawing/2014/main" id="{46841582-4BFA-4586-AD01-0758C9A1E6C6}"/>
               </a:ext>
             </a:extLst>
           </p:cNvPr>
@@ -10620,7 +10620,7 @@
           <p:cNvPr id="152" name="">
             <a:extLst xmlns:a="http://schemas.openxmlformats.org/drawingml/2006/main">
               <a:ext uri="{FF2B5EF4-FFF2-40B4-BE49-F238E27FC236}">
-                <a16:creationId xmlns:a16="http://schemas.microsoft.com/office/drawing/2014/main" id="{380C17FC-93CB-467F-84A5-A4918D7CE463}"/>
+                <a16:creationId xmlns:a16="http://schemas.microsoft.com/office/drawing/2014/main" id="{53748010-464F-447A-87E0-A6ACA4955931}"/>
               </a:ext>
             </a:extLst>
           </p:cNvPr>
@@ -10688,7 +10688,7 @@
           <p:cNvPr id="153" name="">
             <a:extLst xmlns:a="http://schemas.openxmlformats.org/drawingml/2006/main">
               <a:ext uri="{FF2B5EF4-FFF2-40B4-BE49-F238E27FC236}">
-                <a16:creationId xmlns:a16="http://schemas.microsoft.com/office/drawing/2014/main" id="{FF74B558-0278-47B8-895F-4312E66E0BF4}"/>
+                <a16:creationId xmlns:a16="http://schemas.microsoft.com/office/drawing/2014/main" id="{56873F9D-27FA-4E73-86A4-C940D55972D4}"/>
               </a:ext>
             </a:extLst>
           </p:cNvPr>
@@ -10841,7 +10841,7 @@
           <p:cNvPr id="154" name="">
             <a:extLst xmlns:a="http://schemas.openxmlformats.org/drawingml/2006/main">
               <a:ext uri="{FF2B5EF4-FFF2-40B4-BE49-F238E27FC236}">
-                <a16:creationId xmlns:a16="http://schemas.microsoft.com/office/drawing/2014/main" id="{08511C0A-728D-4FB4-B495-478B8E2D8499}"/>
+                <a16:creationId xmlns:a16="http://schemas.microsoft.com/office/drawing/2014/main" id="{CBB37EBB-FAE9-4126-95E6-00E159798FED}"/>
               </a:ext>
             </a:extLst>
           </p:cNvPr>
@@ -10909,7 +10909,7 @@
           <p:cNvPr id="155" name="">
             <a:extLst xmlns:a="http://schemas.openxmlformats.org/drawingml/2006/main">
               <a:ext uri="{FF2B5EF4-FFF2-40B4-BE49-F238E27FC236}">
-                <a16:creationId xmlns:a16="http://schemas.microsoft.com/office/drawing/2014/main" id="{9AD76558-9BAF-478D-BF4E-EC8A0A91AA42}"/>
+                <a16:creationId xmlns:a16="http://schemas.microsoft.com/office/drawing/2014/main" id="{BEA7FFA6-A1C0-475D-B5F3-2271F6CAB6CF}"/>
               </a:ext>
             </a:extLst>
           </p:cNvPr>
@@ -11062,7 +11062,7 @@
           <p:cNvPr id="156" name="">
             <a:extLst xmlns:a="http://schemas.openxmlformats.org/drawingml/2006/main">
               <a:ext uri="{FF2B5EF4-FFF2-40B4-BE49-F238E27FC236}">
-                <a16:creationId xmlns:a16="http://schemas.microsoft.com/office/drawing/2014/main" id="{E54B4C60-CAB6-428F-A344-458373565F63}"/>
+                <a16:creationId xmlns:a16="http://schemas.microsoft.com/office/drawing/2014/main" id="{98258C4C-E9A0-4E84-8F05-DE9B2A2F9851}"/>
               </a:ext>
             </a:extLst>
           </p:cNvPr>
@@ -11130,7 +11130,7 @@
           <p:cNvPr id="157" name="">
             <a:extLst xmlns:a="http://schemas.openxmlformats.org/drawingml/2006/main">
               <a:ext uri="{FF2B5EF4-FFF2-40B4-BE49-F238E27FC236}">
-                <a16:creationId xmlns:a16="http://schemas.microsoft.com/office/drawing/2014/main" id="{2E2F2EFF-9077-4478-A71C-03CA85689EAC}"/>
+                <a16:creationId xmlns:a16="http://schemas.microsoft.com/office/drawing/2014/main" id="{1B579689-6F9C-4689-BA0A-C80905D7044F}"/>
               </a:ext>
             </a:extLst>
           </p:cNvPr>
@@ -11196,7 +11196,7 @@
     </p:spTree>
     <p:extLst>
       <p:ext uri="{BB962C8B-B14F-4D97-AF65-F5344CB8AC3E}">
-        <p14:creationId xmlns:p14="http://schemas.microsoft.com/office/powerpoint/2010/main" val="2140926740"/>
+        <p14:creationId xmlns:p14="http://schemas.microsoft.com/office/powerpoint/2010/main" val="1130231027"/>
       </p:ext>
     </p:extLst>
   </p:cSld>
@@ -11220,7 +11220,7 @@
           <p:cNvPr id="156" name="Google Shape;156;p26">
             <a:extLst xmlns:a="http://schemas.openxmlformats.org/drawingml/2006/main">
               <a:ext uri="{FF2B5EF4-FFF2-40B4-BE49-F238E27FC236}">
-                <a16:creationId xmlns:a16="http://schemas.microsoft.com/office/drawing/2014/main" id="{26A34F23-F69F-4CBD-AEE6-B5D02A4D0638}"/>
+                <a16:creationId xmlns:a16="http://schemas.microsoft.com/office/drawing/2014/main" id="{E2FF7D86-CEC8-450E-9C44-EA1E9F347B55}"/>
               </a:ext>
             </a:extLst>
           </p:cNvPr>
@@ -11230,7 +11230,7 @@
           <p:nvPr/>
         </p:nvPicPr>
         <p:blipFill rotWithShape="1">
-          <a:blip xmlns:r="http://schemas.openxmlformats.org/officeDocument/2006/relationships" xmlns:a="http://schemas.openxmlformats.org/drawingml/2006/main" r:embed="R2a54ba5807664a95">
+          <a:blip xmlns:r="http://schemas.openxmlformats.org/officeDocument/2006/relationships" xmlns:a="http://schemas.openxmlformats.org/drawingml/2006/main" r:embed="R303dbce5123444e6">
             <a:alphaModFix/>
           </a:blip>
           <a:srcRect xmlns:a="http://schemas.openxmlformats.org/drawingml/2006/main" l="0" t="0" r="0" b="98001"/>
@@ -11254,7 +11254,7 @@
           <p:cNvPr id="157" name="Google Shape;157;p26">
             <a:extLst xmlns:a="http://schemas.openxmlformats.org/drawingml/2006/main">
               <a:ext uri="{FF2B5EF4-FFF2-40B4-BE49-F238E27FC236}">
-                <a16:creationId xmlns:a16="http://schemas.microsoft.com/office/drawing/2014/main" id="{E9A810A3-56AF-41CB-85F6-1E3DC702CBB9}"/>
+                <a16:creationId xmlns:a16="http://schemas.microsoft.com/office/drawing/2014/main" id="{DF2CC578-2739-46E0-A31E-4552F75F098F}"/>
               </a:ext>
             </a:extLst>
           </p:cNvPr>
@@ -11264,7 +11264,7 @@
           <p:nvPr/>
         </p:nvPicPr>
         <p:blipFill>
-          <a:blip xmlns:r="http://schemas.openxmlformats.org/officeDocument/2006/relationships" xmlns:a="http://schemas.openxmlformats.org/drawingml/2006/main" r:embed="R7b77831553f34604">
+          <a:blip xmlns:r="http://schemas.openxmlformats.org/officeDocument/2006/relationships" xmlns:a="http://schemas.openxmlformats.org/drawingml/2006/main" r:embed="R81e721b813ee4e40">
             <a:alphaModFix/>
           </a:blip>
           <a:stretch xmlns:a="http://schemas.openxmlformats.org/drawingml/2006/main">
@@ -11289,7 +11289,7 @@
           <p:cNvPr id="158" name="Google Shape;158;p26">
             <a:extLst xmlns:a="http://schemas.openxmlformats.org/drawingml/2006/main">
               <a:ext uri="{FF2B5EF4-FFF2-40B4-BE49-F238E27FC236}">
-                <a16:creationId xmlns:a16="http://schemas.microsoft.com/office/drawing/2014/main" id="{73E36985-9D70-4128-9E13-4F3F0B897BC5}"/>
+                <a16:creationId xmlns:a16="http://schemas.microsoft.com/office/drawing/2014/main" id="{F09F1BF4-FE46-4293-AA38-51827FF5A89B}"/>
               </a:ext>
             </a:extLst>
           </p:cNvPr>
@@ -11340,7 +11340,7 @@
           <p:cNvPr id="159" name="Google Shape;159;p26">
             <a:extLst xmlns:a="http://schemas.openxmlformats.org/drawingml/2006/main">
               <a:ext uri="{FF2B5EF4-FFF2-40B4-BE49-F238E27FC236}">
-                <a16:creationId xmlns:a16="http://schemas.microsoft.com/office/drawing/2014/main" id="{7AED7845-DFA8-4DA5-8801-0DECDE935C06}"/>
+                <a16:creationId xmlns:a16="http://schemas.microsoft.com/office/drawing/2014/main" id="{A2E3EDD8-8843-4479-8888-1879123C5D73}"/>
               </a:ext>
             </a:extLst>
           </p:cNvPr>
@@ -11420,7 +11420,7 @@
           <p:cNvPr id="160" name="">
             <a:extLst xmlns:a="http://schemas.openxmlformats.org/drawingml/2006/main">
               <a:ext uri="{FF2B5EF4-FFF2-40B4-BE49-F238E27FC236}">
-                <a16:creationId xmlns:a16="http://schemas.microsoft.com/office/drawing/2014/main" id="{7B83BCBA-3FED-4D75-A870-61911E0BC0B9}"/>
+                <a16:creationId xmlns:a16="http://schemas.microsoft.com/office/drawing/2014/main" id="{FF6C172D-B170-4C46-8EDD-9898157BB869}"/>
               </a:ext>
             </a:extLst>
           </p:cNvPr>
@@ -11488,7 +11488,7 @@
           <p:cNvPr id="161" name="">
             <a:extLst xmlns:a="http://schemas.openxmlformats.org/drawingml/2006/main">
               <a:ext uri="{FF2B5EF4-FFF2-40B4-BE49-F238E27FC236}">
-                <a16:creationId xmlns:a16="http://schemas.microsoft.com/office/drawing/2014/main" id="{3141E2D7-5237-43B1-99E9-598AAA415B61}"/>
+                <a16:creationId xmlns:a16="http://schemas.microsoft.com/office/drawing/2014/main" id="{D27D8559-2ACF-4BAF-A641-2598E5F943CA}"/>
               </a:ext>
             </a:extLst>
           </p:cNvPr>
@@ -11545,7 +11545,7 @@
                 <a:latin typeface="Google Sans Flex"/>
                 <a:ea typeface="Google Sans Flex"/>
                 <a:cs typeface="Google Sans Flex"/>
-                <a:hlinkClick xmlns:r="http://schemas.openxmlformats.org/officeDocument/2006/relationships" r:id="R0a79f529f63e4757"/>
+                <a:hlinkClick xmlns:r="http://schemas.openxmlformats.org/officeDocument/2006/relationships" r:id="R1d4cbcca4fa64a36"/>
               </a:rPr>
               <a:t>https://github.com/Santxsh27/financial-friday</a:t>
             </a:r>
@@ -11557,7 +11557,7 @@
           <p:cNvPr id="162" name="">
             <a:extLst xmlns:a="http://schemas.openxmlformats.org/drawingml/2006/main">
               <a:ext uri="{FF2B5EF4-FFF2-40B4-BE49-F238E27FC236}">
-                <a16:creationId xmlns:a16="http://schemas.microsoft.com/office/drawing/2014/main" id="{373FE028-CF64-4CAE-B003-7366C7634976}"/>
+                <a16:creationId xmlns:a16="http://schemas.microsoft.com/office/drawing/2014/main" id="{4C3E7940-D3EF-4305-A9D0-95228DB7FB40}"/>
               </a:ext>
             </a:extLst>
           </p:cNvPr>
@@ -11625,7 +11625,7 @@
           <p:cNvPr id="163" name="">
             <a:extLst xmlns:a="http://schemas.openxmlformats.org/drawingml/2006/main">
               <a:ext uri="{FF2B5EF4-FFF2-40B4-BE49-F238E27FC236}">
-                <a16:creationId xmlns:a16="http://schemas.microsoft.com/office/drawing/2014/main" id="{515DD5CD-7606-4704-B386-0F854CA13278}"/>
+                <a16:creationId xmlns:a16="http://schemas.microsoft.com/office/drawing/2014/main" id="{00EA653B-604F-4469-824B-D1EE118AC63A}"/>
               </a:ext>
             </a:extLst>
           </p:cNvPr>
@@ -11682,7 +11682,7 @@
                 <a:latin typeface="Google Sans Flex"/>
                 <a:ea typeface="Google Sans Flex"/>
                 <a:cs typeface="Google Sans Flex"/>
-                <a:hlinkClick xmlns:r="http://schemas.openxmlformats.org/officeDocument/2006/relationships" r:id="R60918cd8d6c94815"/>
+                <a:hlinkClick xmlns:r="http://schemas.openxmlformats.org/officeDocument/2006/relationships" r:id="R28ffb8c99a0e4635"/>
               </a:rPr>
               <a:t>https://financial-friday-web-171681243260.asia-south1.run.app/#home</a:t>
             </a:r>
@@ -11694,7 +11694,7 @@
           <p:cNvPr id="164" name="">
             <a:extLst xmlns:a="http://schemas.openxmlformats.org/drawingml/2006/main">
               <a:ext uri="{FF2B5EF4-FFF2-40B4-BE49-F238E27FC236}">
-                <a16:creationId xmlns:a16="http://schemas.microsoft.com/office/drawing/2014/main" id="{9FF9CD39-C0BB-4CBC-92E0-E99F21BA5BDB}"/>
+                <a16:creationId xmlns:a16="http://schemas.microsoft.com/office/drawing/2014/main" id="{FA58D611-0DDB-48A9-ACBA-3FEE050A7F51}"/>
               </a:ext>
             </a:extLst>
           </p:cNvPr>
@@ -11762,7 +11762,7 @@
           <p:cNvPr id="165" name="">
             <a:extLst xmlns:a="http://schemas.openxmlformats.org/drawingml/2006/main">
               <a:ext uri="{FF2B5EF4-FFF2-40B4-BE49-F238E27FC236}">
-                <a16:creationId xmlns:a16="http://schemas.microsoft.com/office/drawing/2014/main" id="{5DA209C4-92FE-43CA-A82D-78B7E0A3C70D}"/>
+                <a16:creationId xmlns:a16="http://schemas.microsoft.com/office/drawing/2014/main" id="{E826195E-DCA8-41EA-BC1E-C38046C5EE41}"/>
               </a:ext>
             </a:extLst>
           </p:cNvPr>
@@ -11830,7 +11830,7 @@
           <p:cNvPr id="166" name="">
             <a:extLst xmlns:a="http://schemas.openxmlformats.org/drawingml/2006/main">
               <a:ext uri="{FF2B5EF4-FFF2-40B4-BE49-F238E27FC236}">
-                <a16:creationId xmlns:a16="http://schemas.microsoft.com/office/drawing/2014/main" id="{32F85AB8-E783-4004-97C2-E9E1342ADCD0}"/>
+                <a16:creationId xmlns:a16="http://schemas.microsoft.com/office/drawing/2014/main" id="{43D3166C-406D-420C-B202-418E5FE92B24}"/>
               </a:ext>
             </a:extLst>
           </p:cNvPr>
@@ -11898,7 +11898,7 @@
           <p:cNvPr id="167" name="">
             <a:extLst xmlns:a="http://schemas.openxmlformats.org/drawingml/2006/main">
               <a:ext uri="{FF2B5EF4-FFF2-40B4-BE49-F238E27FC236}">
-                <a16:creationId xmlns:a16="http://schemas.microsoft.com/office/drawing/2014/main" id="{D6F12720-C54F-4120-BE79-F526C67B3034}"/>
+                <a16:creationId xmlns:a16="http://schemas.microsoft.com/office/drawing/2014/main" id="{196F54B7-ABD8-4572-A760-505709EAF346}"/>
               </a:ext>
             </a:extLst>
           </p:cNvPr>
@@ -11955,7 +11955,7 @@
                 <a:latin typeface="Google Sans Flex"/>
                 <a:ea typeface="Google Sans Flex"/>
                 <a:cs typeface="Google Sans Flex"/>
-                <a:hlinkClick xmlns:r="http://schemas.openxmlformats.org/officeDocument/2006/relationships" r:id="Rde510ac259d74b8b"/>
+                <a:hlinkClick xmlns:r="http://schemas.openxmlformats.org/officeDocument/2006/relationships" r:id="R1620c48a98744e60"/>
               </a:rPr>
               <a:t>https://financial-friday-web-171681243260.asia-south1.run.app/assets/friday-judge-guide.html</a:t>
             </a:r>
@@ -11967,7 +11967,7 @@
           <p:cNvPr id="168" name="">
             <a:extLst xmlns:a="http://schemas.openxmlformats.org/drawingml/2006/main">
               <a:ext uri="{FF2B5EF4-FFF2-40B4-BE49-F238E27FC236}">
-                <a16:creationId xmlns:a16="http://schemas.microsoft.com/office/drawing/2014/main" id="{796D345B-B9F4-46B5-AE77-71C01FA588D0}"/>
+                <a16:creationId xmlns:a16="http://schemas.microsoft.com/office/drawing/2014/main" id="{D4469A65-09BF-4170-B889-6BF19D7EC61E}"/>
               </a:ext>
             </a:extLst>
           </p:cNvPr>
@@ -12035,7 +12035,7 @@
           <p:cNvPr id="169" name="">
             <a:extLst xmlns:a="http://schemas.openxmlformats.org/drawingml/2006/main">
               <a:ext uri="{FF2B5EF4-FFF2-40B4-BE49-F238E27FC236}">
-                <a16:creationId xmlns:a16="http://schemas.microsoft.com/office/drawing/2014/main" id="{05AFBA1E-41C6-4DCA-BB0A-58BE8C0F3971}"/>
+                <a16:creationId xmlns:a16="http://schemas.microsoft.com/office/drawing/2014/main" id="{9C94EE7B-6E1D-4462-A85F-9C23A6586FAB}"/>
               </a:ext>
             </a:extLst>
           </p:cNvPr>
@@ -12101,7 +12101,7 @@
     </p:spTree>
     <p:extLst>
       <p:ext uri="{BB962C8B-B14F-4D97-AF65-F5344CB8AC3E}">
-        <p14:creationId xmlns:p14="http://schemas.microsoft.com/office/powerpoint/2010/main" val="8987720"/>
+        <p14:creationId xmlns:p14="http://schemas.microsoft.com/office/powerpoint/2010/main" val="2091065402"/>
       </p:ext>
     </p:extLst>
   </p:cSld>
@@ -12125,7 +12125,7 @@
           <p:cNvPr id="164" name="Google Shape;164;p27">
             <a:extLst xmlns:a="http://schemas.openxmlformats.org/drawingml/2006/main">
               <a:ext uri="{FF2B5EF4-FFF2-40B4-BE49-F238E27FC236}">
-                <a16:creationId xmlns:a16="http://schemas.microsoft.com/office/drawing/2014/main" id="{22931831-6B1D-4227-9AD2-B433BB9FCFD0}"/>
+                <a16:creationId xmlns:a16="http://schemas.microsoft.com/office/drawing/2014/main" id="{C51A70C1-D037-4CE3-B950-777D85439DBC}"/>
               </a:ext>
             </a:extLst>
           </p:cNvPr>
@@ -12135,7 +12135,7 @@
           <p:nvPr/>
         </p:nvPicPr>
         <p:blipFill rotWithShape="1">
-          <a:blip xmlns:r="http://schemas.openxmlformats.org/officeDocument/2006/relationships" xmlns:a="http://schemas.openxmlformats.org/drawingml/2006/main" r:embed="R19a9c1f408dd44d1">
+          <a:blip xmlns:r="http://schemas.openxmlformats.org/officeDocument/2006/relationships" xmlns:a="http://schemas.openxmlformats.org/drawingml/2006/main" r:embed="R2582dbfa8033429e">
             <a:alphaModFix/>
           </a:blip>
           <a:srcRect xmlns:a="http://schemas.openxmlformats.org/drawingml/2006/main" l="0" t="0" r="0" b="98001"/>
@@ -12159,7 +12159,7 @@
           <p:cNvPr id="165" name="Google Shape;165;p27">
             <a:extLst xmlns:a="http://schemas.openxmlformats.org/drawingml/2006/main">
               <a:ext uri="{FF2B5EF4-FFF2-40B4-BE49-F238E27FC236}">
-                <a16:creationId xmlns:a16="http://schemas.microsoft.com/office/drawing/2014/main" id="{9766D6DA-6698-4CAB-AB07-742E71066DD3}"/>
+                <a16:creationId xmlns:a16="http://schemas.microsoft.com/office/drawing/2014/main" id="{8F9A72DA-E9AC-40C3-A094-B77756D1C8C5}"/>
               </a:ext>
             </a:extLst>
           </p:cNvPr>
@@ -12169,7 +12169,7 @@
           <p:nvPr/>
         </p:nvPicPr>
         <p:blipFill>
-          <a:blip xmlns:r="http://schemas.openxmlformats.org/officeDocument/2006/relationships" xmlns:a="http://schemas.openxmlformats.org/drawingml/2006/main" r:embed="Rf5dbd79fb4984b38">
+          <a:blip xmlns:r="http://schemas.openxmlformats.org/officeDocument/2006/relationships" xmlns:a="http://schemas.openxmlformats.org/drawingml/2006/main" r:embed="R5ec8f29d6ba1422c">
             <a:alphaModFix/>
           </a:blip>
           <a:stretch xmlns:a="http://schemas.openxmlformats.org/drawingml/2006/main">
@@ -12194,7 +12194,7 @@
           <p:cNvPr id="166" name="Google Shape;166;p27">
             <a:extLst xmlns:a="http://schemas.openxmlformats.org/drawingml/2006/main">
               <a:ext uri="{FF2B5EF4-FFF2-40B4-BE49-F238E27FC236}">
-                <a16:creationId xmlns:a16="http://schemas.microsoft.com/office/drawing/2014/main" id="{A02F9751-4AD0-40C6-850B-0C954D6ED2EF}"/>
+                <a16:creationId xmlns:a16="http://schemas.microsoft.com/office/drawing/2014/main" id="{3F180C7E-F074-4B3D-AB2A-C09A93EE9F52}"/>
               </a:ext>
             </a:extLst>
           </p:cNvPr>
@@ -12245,7 +12245,7 @@
           <p:cNvPr id="167" name="">
             <a:extLst xmlns:a="http://schemas.openxmlformats.org/drawingml/2006/main">
               <a:ext uri="{FF2B5EF4-FFF2-40B4-BE49-F238E27FC236}">
-                <a16:creationId xmlns:a16="http://schemas.microsoft.com/office/drawing/2014/main" id="{CF63B562-CDA3-4A6D-A3EC-A6845456D86E}"/>
+                <a16:creationId xmlns:a16="http://schemas.microsoft.com/office/drawing/2014/main" id="{0FA86A03-5C5C-4A38-A6B8-6F5404B8098E}"/>
               </a:ext>
             </a:extLst>
           </p:cNvPr>
@@ -12313,7 +12313,7 @@
           <p:cNvPr id="168" name="">
             <a:extLst xmlns:a="http://schemas.openxmlformats.org/drawingml/2006/main">
               <a:ext uri="{FF2B5EF4-FFF2-40B4-BE49-F238E27FC236}">
-                <a16:creationId xmlns:a16="http://schemas.microsoft.com/office/drawing/2014/main" id="{7EAE68F0-D769-4740-AF50-C83DAFAF317B}"/>
+                <a16:creationId xmlns:a16="http://schemas.microsoft.com/office/drawing/2014/main" id="{3CB5AF3A-F54D-46CD-9F26-B04648836F72}"/>
               </a:ext>
             </a:extLst>
           </p:cNvPr>
@@ -12371,7 +12371,7 @@
                 <a:ea typeface="Google Sans Flex SemiBold"/>
                 <a:cs typeface="Google Sans Flex SemiBold"/>
               </a:rPr>
-              <a:t>One sample. A visible result. Your own private workspace.</a:t>
+              <a:t>Five-minute walkthrough with artificial data</a:t>
             </a:r>
           </a:p>
         </p:txBody>
@@ -12381,7 +12381,7 @@
           <p:cNvPr id="169" name="">
             <a:extLst xmlns:a="http://schemas.openxmlformats.org/drawingml/2006/main">
               <a:ext uri="{FF2B5EF4-FFF2-40B4-BE49-F238E27FC236}">
-                <a16:creationId xmlns:a16="http://schemas.microsoft.com/office/drawing/2014/main" id="{C491CC91-555F-438E-969B-3D17BE0C1B10}"/>
+                <a16:creationId xmlns:a16="http://schemas.microsoft.com/office/drawing/2014/main" id="{1DAFBA21-658D-4DF5-8777-160DAADF436D}"/>
               </a:ext>
             </a:extLst>
           </p:cNvPr>
@@ -12561,7 +12561,7 @@
           <p:cNvPr id="170" name="">
             <a:extLst xmlns:a="http://schemas.openxmlformats.org/drawingml/2006/main">
               <a:ext uri="{FF2B5EF4-FFF2-40B4-BE49-F238E27FC236}">
-                <a16:creationId xmlns:a16="http://schemas.microsoft.com/office/drawing/2014/main" id="{0BF6B773-A103-4082-A139-B4EEFDF3B71F}"/>
+                <a16:creationId xmlns:a16="http://schemas.microsoft.com/office/drawing/2014/main" id="{538E2AE4-2C08-4880-A99E-E2C2F3489F9B}"/>
               </a:ext>
             </a:extLst>
           </p:cNvPr>
@@ -12629,7 +12629,7 @@
           <p:cNvPr id="171" name="">
             <a:extLst xmlns:a="http://schemas.openxmlformats.org/drawingml/2006/main">
               <a:ext uri="{FF2B5EF4-FFF2-40B4-BE49-F238E27FC236}">
-                <a16:creationId xmlns:a16="http://schemas.microsoft.com/office/drawing/2014/main" id="{54A29627-AB7F-429E-8A55-5D9D0EA04881}"/>
+                <a16:creationId xmlns:a16="http://schemas.microsoft.com/office/drawing/2014/main" id="{D84FC1D6-3DBA-41C0-B46D-BF95612DCEFD}"/>
               </a:ext>
             </a:extLst>
           </p:cNvPr>
@@ -12697,7 +12697,7 @@
           <p:cNvPr id="172" name="">
             <a:extLst xmlns:a="http://schemas.openxmlformats.org/drawingml/2006/main">
               <a:ext uri="{FF2B5EF4-FFF2-40B4-BE49-F238E27FC236}">
-                <a16:creationId xmlns:a16="http://schemas.microsoft.com/office/drawing/2014/main" id="{31E693D8-A306-4CE4-B596-8BFB512442A1}"/>
+                <a16:creationId xmlns:a16="http://schemas.microsoft.com/office/drawing/2014/main" id="{8F90A1A9-B961-494E-8FC4-B93E19947137}"/>
               </a:ext>
             </a:extLst>
           </p:cNvPr>
@@ -12763,7 +12763,7 @@
     </p:spTree>
     <p:extLst>
       <p:ext uri="{BB962C8B-B14F-4D97-AF65-F5344CB8AC3E}">
-        <p14:creationId xmlns:p14="http://schemas.microsoft.com/office/powerpoint/2010/main" val="1835235108"/>
+        <p14:creationId xmlns:p14="http://schemas.microsoft.com/office/powerpoint/2010/main" val="703109419"/>
       </p:ext>
     </p:extLst>
   </p:cSld>
@@ -12787,7 +12787,7 @@
           <p:cNvPr id="171" name="Google Shape;171;p28">
             <a:extLst xmlns:a="http://schemas.openxmlformats.org/drawingml/2006/main">
               <a:ext uri="{FF2B5EF4-FFF2-40B4-BE49-F238E27FC236}">
-                <a16:creationId xmlns:a16="http://schemas.microsoft.com/office/drawing/2014/main" id="{04919576-557A-4C1C-AF5E-E84B32E0ADC3}"/>
+                <a16:creationId xmlns:a16="http://schemas.microsoft.com/office/drawing/2014/main" id="{E57721DC-82F9-4348-B8B2-3FD0BBA590B9}"/>
               </a:ext>
             </a:extLst>
           </p:cNvPr>
@@ -12797,7 +12797,7 @@
           <p:nvPr/>
         </p:nvPicPr>
         <p:blipFill rotWithShape="1">
-          <a:blip xmlns:r="http://schemas.openxmlformats.org/officeDocument/2006/relationships" xmlns:a="http://schemas.openxmlformats.org/drawingml/2006/main" r:embed="R6c411bacac6247e2">
+          <a:blip xmlns:r="http://schemas.openxmlformats.org/officeDocument/2006/relationships" xmlns:a="http://schemas.openxmlformats.org/drawingml/2006/main" r:embed="R064cc2191d6145c1">
             <a:alphaModFix/>
           </a:blip>
           <a:srcRect xmlns:a="http://schemas.openxmlformats.org/drawingml/2006/main" l="0" t="0" r="0" b="98001"/>
@@ -12821,7 +12821,7 @@
           <p:cNvPr id="172" name="Google Shape;172;p28">
             <a:extLst xmlns:a="http://schemas.openxmlformats.org/drawingml/2006/main">
               <a:ext uri="{FF2B5EF4-FFF2-40B4-BE49-F238E27FC236}">
-                <a16:creationId xmlns:a16="http://schemas.microsoft.com/office/drawing/2014/main" id="{BA0EBD8D-DBB4-4FC3-90AB-9B74FBE797EE}"/>
+                <a16:creationId xmlns:a16="http://schemas.microsoft.com/office/drawing/2014/main" id="{428509F7-DB81-4991-B8E0-E841E9C427B3}"/>
               </a:ext>
             </a:extLst>
           </p:cNvPr>
@@ -12831,7 +12831,7 @@
           <p:nvPr/>
         </p:nvPicPr>
         <p:blipFill>
-          <a:blip xmlns:r="http://schemas.openxmlformats.org/officeDocument/2006/relationships" xmlns:a="http://schemas.openxmlformats.org/drawingml/2006/main" r:embed="Ra6eba92c05bf406f">
+          <a:blip xmlns:r="http://schemas.openxmlformats.org/officeDocument/2006/relationships" xmlns:a="http://schemas.openxmlformats.org/drawingml/2006/main" r:embed="R328a6aa6e43f41d2">
             <a:alphaModFix/>
           </a:blip>
           <a:stretch xmlns:a="http://schemas.openxmlformats.org/drawingml/2006/main">
@@ -12854,7 +12854,7 @@
     </p:spTree>
     <p:extLst>
       <p:ext uri="{BB962C8B-B14F-4D97-AF65-F5344CB8AC3E}">
-        <p14:creationId xmlns:p14="http://schemas.microsoft.com/office/powerpoint/2010/main" val="864191011"/>
+        <p14:creationId xmlns:p14="http://schemas.microsoft.com/office/powerpoint/2010/main" val="1650439861"/>
       </p:ext>
     </p:extLst>
   </p:cSld>
@@ -12878,7 +12878,7 @@
           <p:cNvPr id="61" name="Google Shape;61;p14">
             <a:extLst xmlns:a="http://schemas.openxmlformats.org/drawingml/2006/main">
               <a:ext uri="{FF2B5EF4-FFF2-40B4-BE49-F238E27FC236}">
-                <a16:creationId xmlns:a16="http://schemas.microsoft.com/office/drawing/2014/main" id="{ACFEEB6C-6C48-4A31-83AA-61232D9E669B}"/>
+                <a16:creationId xmlns:a16="http://schemas.microsoft.com/office/drawing/2014/main" id="{5BB6A2CD-A25D-4216-8E47-4218AE6659B9}"/>
               </a:ext>
             </a:extLst>
           </p:cNvPr>
@@ -12888,7 +12888,7 @@
           <p:nvPr/>
         </p:nvPicPr>
         <p:blipFill rotWithShape="1">
-          <a:blip xmlns:r="http://schemas.openxmlformats.org/officeDocument/2006/relationships" xmlns:a="http://schemas.openxmlformats.org/drawingml/2006/main" r:embed="Ra26db897f1c644cd">
+          <a:blip xmlns:r="http://schemas.openxmlformats.org/officeDocument/2006/relationships" xmlns:a="http://schemas.openxmlformats.org/drawingml/2006/main" r:embed="R1b15c1c0dea645ae">
             <a:alphaModFix/>
           </a:blip>
           <a:srcRect xmlns:a="http://schemas.openxmlformats.org/drawingml/2006/main" l="0" t="0" r="0" b="98001"/>
@@ -12912,7 +12912,7 @@
           <p:cNvPr id="62" name="Google Shape;62;p14">
             <a:extLst xmlns:a="http://schemas.openxmlformats.org/drawingml/2006/main">
               <a:ext uri="{FF2B5EF4-FFF2-40B4-BE49-F238E27FC236}">
-                <a16:creationId xmlns:a16="http://schemas.microsoft.com/office/drawing/2014/main" id="{AE941CD0-98C4-44D3-B0C8-B815108ACC8E}"/>
+                <a16:creationId xmlns:a16="http://schemas.microsoft.com/office/drawing/2014/main" id="{D4E1ACDA-513E-468D-AFDB-8AFAD56B6FEF}"/>
               </a:ext>
             </a:extLst>
           </p:cNvPr>
@@ -12963,7 +12963,7 @@
           <p:cNvPr id="63" name="Google Shape;63;p14">
             <a:extLst xmlns:a="http://schemas.openxmlformats.org/drawingml/2006/main">
               <a:ext uri="{FF2B5EF4-FFF2-40B4-BE49-F238E27FC236}">
-                <a16:creationId xmlns:a16="http://schemas.microsoft.com/office/drawing/2014/main" id="{C6C5A8F4-9D6E-45F3-9DD3-3A1A5FE51C20}"/>
+                <a16:creationId xmlns:a16="http://schemas.microsoft.com/office/drawing/2014/main" id="{6F7DAA71-CF54-488C-AFEA-2D9310D842A7}"/>
               </a:ext>
             </a:extLst>
           </p:cNvPr>
@@ -13091,7 +13091,7 @@
           <p:cNvPr id="64" name="Google Shape;64;p14">
             <a:extLst xmlns:a="http://schemas.openxmlformats.org/drawingml/2006/main">
               <a:ext uri="{FF2B5EF4-FFF2-40B4-BE49-F238E27FC236}">
-                <a16:creationId xmlns:a16="http://schemas.microsoft.com/office/drawing/2014/main" id="{5F0A2A2C-D3CA-4718-809A-8887E4F752ED}"/>
+                <a16:creationId xmlns:a16="http://schemas.microsoft.com/office/drawing/2014/main" id="{3C4BC159-F875-47C7-99B4-3B73AA9323B8}"/>
               </a:ext>
             </a:extLst>
           </p:cNvPr>
@@ -13101,7 +13101,7 @@
           <p:nvPr/>
         </p:nvPicPr>
         <p:blipFill>
-          <a:blip xmlns:r="http://schemas.openxmlformats.org/officeDocument/2006/relationships" xmlns:a="http://schemas.openxmlformats.org/drawingml/2006/main" r:embed="R6b06937c098a4e24">
+          <a:blip xmlns:r="http://schemas.openxmlformats.org/officeDocument/2006/relationships" xmlns:a="http://schemas.openxmlformats.org/drawingml/2006/main" r:embed="Rc5b5a64f090248c0">
             <a:alphaModFix/>
           </a:blip>
           <a:stretch xmlns:a="http://schemas.openxmlformats.org/drawingml/2006/main">
@@ -13131,7 +13131,7 @@
     </p:spTree>
     <p:extLst>
       <p:ext uri="{BB962C8B-B14F-4D97-AF65-F5344CB8AC3E}">
-        <p14:creationId xmlns:p14="http://schemas.microsoft.com/office/powerpoint/2010/main" val="1692168653"/>
+        <p14:creationId xmlns:p14="http://schemas.microsoft.com/office/powerpoint/2010/main" val="1570871567"/>
       </p:ext>
     </p:extLst>
   </p:cSld>
@@ -13155,7 +13155,7 @@
           <p:cNvPr id="69" name="Google Shape;69;p15">
             <a:extLst xmlns:a="http://schemas.openxmlformats.org/drawingml/2006/main">
               <a:ext uri="{FF2B5EF4-FFF2-40B4-BE49-F238E27FC236}">
-                <a16:creationId xmlns:a16="http://schemas.microsoft.com/office/drawing/2014/main" id="{94C11B72-15AA-400B-A032-16179FB5B58A}"/>
+                <a16:creationId xmlns:a16="http://schemas.microsoft.com/office/drawing/2014/main" id="{1426E7A7-D38B-42C0-9716-90E78086A597}"/>
               </a:ext>
             </a:extLst>
           </p:cNvPr>
@@ -13165,7 +13165,7 @@
           <p:nvPr/>
         </p:nvPicPr>
         <p:blipFill>
-          <a:blip xmlns:r="http://schemas.openxmlformats.org/officeDocument/2006/relationships" xmlns:a="http://schemas.openxmlformats.org/drawingml/2006/main" r:embed="R31de7831db674f81">
+          <a:blip xmlns:r="http://schemas.openxmlformats.org/officeDocument/2006/relationships" xmlns:a="http://schemas.openxmlformats.org/drawingml/2006/main" r:embed="Re9ef2acb7e6f48d5">
             <a:alphaModFix/>
           </a:blip>
           <a:stretch xmlns:a="http://schemas.openxmlformats.org/drawingml/2006/main">
@@ -13190,7 +13190,7 @@
           <p:cNvPr id="70" name="Google Shape;70;p15">
             <a:extLst xmlns:a="http://schemas.openxmlformats.org/drawingml/2006/main">
               <a:ext uri="{FF2B5EF4-FFF2-40B4-BE49-F238E27FC236}">
-                <a16:creationId xmlns:a16="http://schemas.microsoft.com/office/drawing/2014/main" id="{C1914997-5FD7-40FA-870E-B4F13CF6A7EE}"/>
+                <a16:creationId xmlns:a16="http://schemas.microsoft.com/office/drawing/2014/main" id="{0D377E49-BF76-4F6B-85EC-085754B243A3}"/>
               </a:ext>
             </a:extLst>
           </p:cNvPr>
@@ -13241,7 +13241,7 @@
           <p:cNvPr id="71" name="Google Shape;71;p15">
             <a:extLst xmlns:a="http://schemas.openxmlformats.org/drawingml/2006/main">
               <a:ext uri="{FF2B5EF4-FFF2-40B4-BE49-F238E27FC236}">
-                <a16:creationId xmlns:a16="http://schemas.microsoft.com/office/drawing/2014/main" id="{0FC70BCC-651F-422E-97D6-BC2B27FF0DF9}"/>
+                <a16:creationId xmlns:a16="http://schemas.microsoft.com/office/drawing/2014/main" id="{B24CDA3D-528F-4843-B405-DDFE0FDBB6EA}"/>
               </a:ext>
             </a:extLst>
           </p:cNvPr>
@@ -13321,7 +13321,7 @@
           <p:cNvPr id="72" name="">
             <a:extLst xmlns:a="http://schemas.openxmlformats.org/drawingml/2006/main">
               <a:ext uri="{FF2B5EF4-FFF2-40B4-BE49-F238E27FC236}">
-                <a16:creationId xmlns:a16="http://schemas.microsoft.com/office/drawing/2014/main" id="{4750FF45-274E-4556-AF58-949F08038D0F}"/>
+                <a16:creationId xmlns:a16="http://schemas.microsoft.com/office/drawing/2014/main" id="{ED55FB5C-0A96-4747-BDE8-00888B73EAC7}"/>
               </a:ext>
             </a:extLst>
           </p:cNvPr>
@@ -13389,7 +13389,7 @@
           <p:cNvPr id="73" name="">
             <a:extLst xmlns:a="http://schemas.openxmlformats.org/drawingml/2006/main">
               <a:ext uri="{FF2B5EF4-FFF2-40B4-BE49-F238E27FC236}">
-                <a16:creationId xmlns:a16="http://schemas.microsoft.com/office/drawing/2014/main" id="{EF23010D-B334-4432-9B82-2599604D6736}"/>
+                <a16:creationId xmlns:a16="http://schemas.microsoft.com/office/drawing/2014/main" id="{FC8EACAC-85B5-4DF3-80DB-783668CFF506}"/>
               </a:ext>
             </a:extLst>
           </p:cNvPr>
@@ -13457,7 +13457,7 @@
           <p:cNvPr id="74" name="">
             <a:extLst xmlns:a="http://schemas.openxmlformats.org/drawingml/2006/main">
               <a:ext uri="{FF2B5EF4-FFF2-40B4-BE49-F238E27FC236}">
-                <a16:creationId xmlns:a16="http://schemas.microsoft.com/office/drawing/2014/main" id="{54DAFE83-C02F-421E-B357-A39216B5ECD8}"/>
+                <a16:creationId xmlns:a16="http://schemas.microsoft.com/office/drawing/2014/main" id="{2A38490E-604D-4D54-82DE-B3CAB4342008}"/>
               </a:ext>
             </a:extLst>
           </p:cNvPr>
@@ -13525,7 +13525,7 @@
           <p:cNvPr id="75" name="">
             <a:extLst xmlns:a="http://schemas.openxmlformats.org/drawingml/2006/main">
               <a:ext uri="{FF2B5EF4-FFF2-40B4-BE49-F238E27FC236}">
-                <a16:creationId xmlns:a16="http://schemas.microsoft.com/office/drawing/2014/main" id="{CFB73869-3F95-4E59-A6BA-C733C8DDE061}"/>
+                <a16:creationId xmlns:a16="http://schemas.microsoft.com/office/drawing/2014/main" id="{8FFB0A61-5899-4146-94EB-0037443F6070}"/>
               </a:ext>
             </a:extLst>
           </p:cNvPr>
@@ -13583,7 +13583,7 @@
                 <a:ea typeface="Google Sans Flex SemiBold"/>
                 <a:cs typeface="Google Sans Flex SemiBold"/>
               </a:rPr>
-              <a:t>One supported statement. One conversation. A visual cash roadmap with clear assumptions.</a:t>
+              <a:t>Reviewed history and a confirmed budget support a visual roadmap with clear assumptions.</a:t>
             </a:r>
           </a:p>
         </p:txBody>
@@ -13593,7 +13593,7 @@
           <p:cNvPr id="76" name="">
             <a:extLst xmlns:a="http://schemas.openxmlformats.org/drawingml/2006/main">
               <a:ext uri="{FF2B5EF4-FFF2-40B4-BE49-F238E27FC236}">
-                <a16:creationId xmlns:a16="http://schemas.microsoft.com/office/drawing/2014/main" id="{6511C636-9BB0-48F3-96DB-33A22217577F}"/>
+                <a16:creationId xmlns:a16="http://schemas.microsoft.com/office/drawing/2014/main" id="{00A4AD23-7AB7-44C0-BD04-15CBAC41BC65}"/>
               </a:ext>
             </a:extLst>
           </p:cNvPr>
@@ -13603,7 +13603,7 @@
           <p:nvPr/>
         </p:nvPicPr>
         <p:blipFill>
-          <a:blip xmlns:r="http://schemas.openxmlformats.org/officeDocument/2006/relationships" xmlns:a="http://schemas.openxmlformats.org/drawingml/2006/main" r:embed="Rdcf8fa4c39d5496a"/>
+          <a:blip xmlns:r="http://schemas.openxmlformats.org/officeDocument/2006/relationships" xmlns:a="http://schemas.openxmlformats.org/drawingml/2006/main" r:embed="R6d3dadb7f30c47b8"/>
           <a:stretch xmlns:a="http://schemas.openxmlformats.org/drawingml/2006/main"/>
         </p:blipFill>
         <p:spPr>
@@ -13621,7 +13621,7 @@
           <p:cNvPr id="77" name="">
             <a:extLst xmlns:a="http://schemas.openxmlformats.org/drawingml/2006/main">
               <a:ext uri="{FF2B5EF4-FFF2-40B4-BE49-F238E27FC236}">
-                <a16:creationId xmlns:a16="http://schemas.microsoft.com/office/drawing/2014/main" id="{78A6568C-04D7-4006-A30E-A7DFF491FBC1}"/>
+                <a16:creationId xmlns:a16="http://schemas.microsoft.com/office/drawing/2014/main" id="{33328776-8203-4CFE-BC75-E71124E1DE30}"/>
               </a:ext>
             </a:extLst>
           </p:cNvPr>
@@ -13689,7 +13689,7 @@
           <p:cNvPr id="78" name="">
             <a:extLst xmlns:a="http://schemas.openxmlformats.org/drawingml/2006/main">
               <a:ext uri="{FF2B5EF4-FFF2-40B4-BE49-F238E27FC236}">
-                <a16:creationId xmlns:a16="http://schemas.microsoft.com/office/drawing/2014/main" id="{B240D89F-2FDF-4D38-A334-CA30D4334FE6}"/>
+                <a16:creationId xmlns:a16="http://schemas.microsoft.com/office/drawing/2014/main" id="{599DECA1-E6DF-498F-979D-259874ABC68B}"/>
               </a:ext>
             </a:extLst>
           </p:cNvPr>
@@ -13755,7 +13755,7 @@
     </p:spTree>
     <p:extLst>
       <p:ext uri="{BB962C8B-B14F-4D97-AF65-F5344CB8AC3E}">
-        <p14:creationId xmlns:p14="http://schemas.microsoft.com/office/powerpoint/2010/main" val="91817738"/>
+        <p14:creationId xmlns:p14="http://schemas.microsoft.com/office/powerpoint/2010/main" val="636371927"/>
       </p:ext>
     </p:extLst>
   </p:cSld>
@@ -13779,7 +13779,7 @@
           <p:cNvPr id="76" name="Google Shape;76;p16">
             <a:extLst xmlns:a="http://schemas.openxmlformats.org/drawingml/2006/main">
               <a:ext uri="{FF2B5EF4-FFF2-40B4-BE49-F238E27FC236}">
-                <a16:creationId xmlns:a16="http://schemas.microsoft.com/office/drawing/2014/main" id="{B63332D7-A4A5-4359-B4A9-BEB834352A94}"/>
+                <a16:creationId xmlns:a16="http://schemas.microsoft.com/office/drawing/2014/main" id="{5D53FE96-0D59-4D84-918F-39FE53329632}"/>
               </a:ext>
             </a:extLst>
           </p:cNvPr>
@@ -13789,7 +13789,7 @@
           <p:nvPr/>
         </p:nvPicPr>
         <p:blipFill rotWithShape="1">
-          <a:blip xmlns:r="http://schemas.openxmlformats.org/officeDocument/2006/relationships" xmlns:a="http://schemas.openxmlformats.org/drawingml/2006/main" r:embed="R13edbe2ccfda426c">
+          <a:blip xmlns:r="http://schemas.openxmlformats.org/officeDocument/2006/relationships" xmlns:a="http://schemas.openxmlformats.org/drawingml/2006/main" r:embed="R45a648da2b1d4aae">
             <a:alphaModFix/>
           </a:blip>
           <a:srcRect xmlns:a="http://schemas.openxmlformats.org/drawingml/2006/main" l="0" t="0" r="0" b="98001"/>
@@ -13813,7 +13813,7 @@
           <p:cNvPr id="77" name="Google Shape;77;p16">
             <a:extLst xmlns:a="http://schemas.openxmlformats.org/drawingml/2006/main">
               <a:ext uri="{FF2B5EF4-FFF2-40B4-BE49-F238E27FC236}">
-                <a16:creationId xmlns:a16="http://schemas.microsoft.com/office/drawing/2014/main" id="{A17211EB-D4DB-4121-9F4C-22211EE8880E}"/>
+                <a16:creationId xmlns:a16="http://schemas.microsoft.com/office/drawing/2014/main" id="{CB976E37-26EF-44E6-BCC5-39329E7B3E03}"/>
               </a:ext>
             </a:extLst>
           </p:cNvPr>
@@ -13823,7 +13823,7 @@
           <p:nvPr/>
         </p:nvPicPr>
         <p:blipFill>
-          <a:blip xmlns:r="http://schemas.openxmlformats.org/officeDocument/2006/relationships" xmlns:a="http://schemas.openxmlformats.org/drawingml/2006/main" r:embed="R63a4ab69d12d48e8">
+          <a:blip xmlns:r="http://schemas.openxmlformats.org/officeDocument/2006/relationships" xmlns:a="http://schemas.openxmlformats.org/drawingml/2006/main" r:embed="Rc371b0b000274c64">
             <a:alphaModFix/>
           </a:blip>
           <a:stretch xmlns:a="http://schemas.openxmlformats.org/drawingml/2006/main">
@@ -13848,7 +13848,7 @@
           <p:cNvPr id="78" name="Google Shape;78;p16">
             <a:extLst xmlns:a="http://schemas.openxmlformats.org/drawingml/2006/main">
               <a:ext uri="{FF2B5EF4-FFF2-40B4-BE49-F238E27FC236}">
-                <a16:creationId xmlns:a16="http://schemas.microsoft.com/office/drawing/2014/main" id="{DE8163EC-7C21-4BF7-8210-F29FB16F4474}"/>
+                <a16:creationId xmlns:a16="http://schemas.microsoft.com/office/drawing/2014/main" id="{E2546498-CC3B-4081-9E23-20CFFB757AB1}"/>
               </a:ext>
             </a:extLst>
           </p:cNvPr>
@@ -13899,7 +13899,7 @@
           <p:cNvPr id="79" name="Google Shape;79;p16">
             <a:extLst xmlns:a="http://schemas.openxmlformats.org/drawingml/2006/main">
               <a:ext uri="{FF2B5EF4-FFF2-40B4-BE49-F238E27FC236}">
-                <a16:creationId xmlns:a16="http://schemas.microsoft.com/office/drawing/2014/main" id="{71D72137-36FA-41F5-8EFF-594E8164BF89}"/>
+                <a16:creationId xmlns:a16="http://schemas.microsoft.com/office/drawing/2014/main" id="{F77454C5-A27B-4ABB-82B2-29AFA7C42B7A}"/>
               </a:ext>
             </a:extLst>
           </p:cNvPr>
@@ -13979,7 +13979,7 @@
           <p:cNvPr id="80" name="">
             <a:extLst xmlns:a="http://schemas.openxmlformats.org/drawingml/2006/main">
               <a:ext uri="{FF2B5EF4-FFF2-40B4-BE49-F238E27FC236}">
-                <a16:creationId xmlns:a16="http://schemas.microsoft.com/office/drawing/2014/main" id="{5EE9BA81-7D9C-409E-B9D0-91A55DCDDB75}"/>
+                <a16:creationId xmlns:a16="http://schemas.microsoft.com/office/drawing/2014/main" id="{8AE59DF3-8E73-49A5-94F5-7876A0CA3CE1}"/>
               </a:ext>
             </a:extLst>
           </p:cNvPr>
@@ -14047,7 +14047,7 @@
           <p:cNvPr id="81" name="">
             <a:extLst xmlns:a="http://schemas.openxmlformats.org/drawingml/2006/main">
               <a:ext uri="{FF2B5EF4-FFF2-40B4-BE49-F238E27FC236}">
-                <a16:creationId xmlns:a16="http://schemas.microsoft.com/office/drawing/2014/main" id="{3725FF85-6D38-430E-BE46-F5B8F293D5AC}"/>
+                <a16:creationId xmlns:a16="http://schemas.microsoft.com/office/drawing/2014/main" id="{53154058-E2C7-4AC5-A404-6BBF31810033}"/>
               </a:ext>
             </a:extLst>
           </p:cNvPr>
@@ -14115,7 +14115,7 @@
           <p:cNvPr id="82" name="">
             <a:extLst xmlns:a="http://schemas.openxmlformats.org/drawingml/2006/main">
               <a:ext uri="{FF2B5EF4-FFF2-40B4-BE49-F238E27FC236}">
-                <a16:creationId xmlns:a16="http://schemas.microsoft.com/office/drawing/2014/main" id="{24F7AB2F-63CB-4101-9305-56E76C3AC695}"/>
+                <a16:creationId xmlns:a16="http://schemas.microsoft.com/office/drawing/2014/main" id="{2586F22F-9950-40B9-8570-BE05ECC34E79}"/>
               </a:ext>
             </a:extLst>
           </p:cNvPr>
@@ -14183,7 +14183,7 @@
           <p:cNvPr id="83" name="">
             <a:extLst xmlns:a="http://schemas.openxmlformats.org/drawingml/2006/main">
               <a:ext uri="{FF2B5EF4-FFF2-40B4-BE49-F238E27FC236}">
-                <a16:creationId xmlns:a16="http://schemas.microsoft.com/office/drawing/2014/main" id="{1C6A547C-3AA1-47B6-BB5E-0A391C641BA2}"/>
+                <a16:creationId xmlns:a16="http://schemas.microsoft.com/office/drawing/2014/main" id="{1CA47DC0-06A2-456F-BD42-663554553622}"/>
               </a:ext>
             </a:extLst>
           </p:cNvPr>
@@ -14251,7 +14251,7 @@
           <p:cNvPr id="84" name="">
             <a:extLst xmlns:a="http://schemas.openxmlformats.org/drawingml/2006/main">
               <a:ext uri="{FF2B5EF4-FFF2-40B4-BE49-F238E27FC236}">
-                <a16:creationId xmlns:a16="http://schemas.microsoft.com/office/drawing/2014/main" id="{ED510800-0AC5-404A-9F53-4752661A8301}"/>
+                <a16:creationId xmlns:a16="http://schemas.microsoft.com/office/drawing/2014/main" id="{84ED998D-A6B6-4038-A621-D9D0C8E66D2D}"/>
               </a:ext>
             </a:extLst>
           </p:cNvPr>
@@ -14319,7 +14319,7 @@
           <p:cNvPr id="85" name="">
             <a:extLst xmlns:a="http://schemas.openxmlformats.org/drawingml/2006/main">
               <a:ext uri="{FF2B5EF4-FFF2-40B4-BE49-F238E27FC236}">
-                <a16:creationId xmlns:a16="http://schemas.microsoft.com/office/drawing/2014/main" id="{6C52CC39-F6CE-4CD7-AB59-4CBD79132276}"/>
+                <a16:creationId xmlns:a16="http://schemas.microsoft.com/office/drawing/2014/main" id="{6AB62C5F-11CE-482D-A38D-417866636A97}"/>
               </a:ext>
             </a:extLst>
           </p:cNvPr>
@@ -14387,7 +14387,7 @@
           <p:cNvPr id="86" name="">
             <a:extLst xmlns:a="http://schemas.openxmlformats.org/drawingml/2006/main">
               <a:ext uri="{FF2B5EF4-FFF2-40B4-BE49-F238E27FC236}">
-                <a16:creationId xmlns:a16="http://schemas.microsoft.com/office/drawing/2014/main" id="{3B98DFBB-3C42-4D96-89A1-5EDAA80E7489}"/>
+                <a16:creationId xmlns:a16="http://schemas.microsoft.com/office/drawing/2014/main" id="{7401B158-D13C-4171-8F24-485E7A1148BC}"/>
               </a:ext>
             </a:extLst>
           </p:cNvPr>
@@ -14455,7 +14455,7 @@
           <p:cNvPr id="87" name="">
             <a:extLst xmlns:a="http://schemas.openxmlformats.org/drawingml/2006/main">
               <a:ext uri="{FF2B5EF4-FFF2-40B4-BE49-F238E27FC236}">
-                <a16:creationId xmlns:a16="http://schemas.microsoft.com/office/drawing/2014/main" id="{895E27AE-AF33-481B-9C5F-982742F75FCC}"/>
+                <a16:creationId xmlns:a16="http://schemas.microsoft.com/office/drawing/2014/main" id="{6FFB844F-3F93-4ED8-8DDF-CCE3C5C3952F}"/>
               </a:ext>
             </a:extLst>
           </p:cNvPr>
@@ -14521,7 +14521,7 @@
     </p:spTree>
     <p:extLst>
       <p:ext uri="{BB962C8B-B14F-4D97-AF65-F5344CB8AC3E}">
-        <p14:creationId xmlns:p14="http://schemas.microsoft.com/office/powerpoint/2010/main" val="249098974"/>
+        <p14:creationId xmlns:p14="http://schemas.microsoft.com/office/powerpoint/2010/main" val="957823106"/>
       </p:ext>
     </p:extLst>
   </p:cSld>
@@ -14545,7 +14545,7 @@
           <p:cNvPr id="84" name="Google Shape;84;p17">
             <a:extLst xmlns:a="http://schemas.openxmlformats.org/drawingml/2006/main">
               <a:ext uri="{FF2B5EF4-FFF2-40B4-BE49-F238E27FC236}">
-                <a16:creationId xmlns:a16="http://schemas.microsoft.com/office/drawing/2014/main" id="{FEA868DD-D511-4508-83D7-E2799808C371}"/>
+                <a16:creationId xmlns:a16="http://schemas.microsoft.com/office/drawing/2014/main" id="{B12103D1-F48E-42BF-8624-3B72678032BF}"/>
               </a:ext>
             </a:extLst>
           </p:cNvPr>
@@ -14555,7 +14555,7 @@
           <p:nvPr/>
         </p:nvPicPr>
         <p:blipFill rotWithShape="1">
-          <a:blip xmlns:r="http://schemas.openxmlformats.org/officeDocument/2006/relationships" xmlns:a="http://schemas.openxmlformats.org/drawingml/2006/main" r:embed="R230ef9ad497c461d">
+          <a:blip xmlns:r="http://schemas.openxmlformats.org/officeDocument/2006/relationships" xmlns:a="http://schemas.openxmlformats.org/drawingml/2006/main" r:embed="R93f053c542d140d9">
             <a:alphaModFix/>
           </a:blip>
           <a:srcRect xmlns:a="http://schemas.openxmlformats.org/drawingml/2006/main" l="0" t="0" r="0" b="98001"/>
@@ -14579,7 +14579,7 @@
           <p:cNvPr id="85" name="Google Shape;85;p17">
             <a:extLst xmlns:a="http://schemas.openxmlformats.org/drawingml/2006/main">
               <a:ext uri="{FF2B5EF4-FFF2-40B4-BE49-F238E27FC236}">
-                <a16:creationId xmlns:a16="http://schemas.microsoft.com/office/drawing/2014/main" id="{3558ED9B-7037-4362-96B3-225181BB0531}"/>
+                <a16:creationId xmlns:a16="http://schemas.microsoft.com/office/drawing/2014/main" id="{268D2047-A4AC-46EA-804B-94490973B020}"/>
               </a:ext>
             </a:extLst>
           </p:cNvPr>
@@ -14589,7 +14589,7 @@
           <p:nvPr/>
         </p:nvPicPr>
         <p:blipFill>
-          <a:blip xmlns:r="http://schemas.openxmlformats.org/officeDocument/2006/relationships" xmlns:a="http://schemas.openxmlformats.org/drawingml/2006/main" r:embed="R7b0c471cfa954439">
+          <a:blip xmlns:r="http://schemas.openxmlformats.org/officeDocument/2006/relationships" xmlns:a="http://schemas.openxmlformats.org/drawingml/2006/main" r:embed="Rde6d4b1af24f43fc">
             <a:alphaModFix/>
           </a:blip>
           <a:stretch xmlns:a="http://schemas.openxmlformats.org/drawingml/2006/main">
@@ -14614,7 +14614,7 @@
           <p:cNvPr id="86" name="Google Shape;86;p17">
             <a:extLst xmlns:a="http://schemas.openxmlformats.org/drawingml/2006/main">
               <a:ext uri="{FF2B5EF4-FFF2-40B4-BE49-F238E27FC236}">
-                <a16:creationId xmlns:a16="http://schemas.microsoft.com/office/drawing/2014/main" id="{43F8FF6B-96C6-4BC2-99FA-9657DB098CE3}"/>
+                <a16:creationId xmlns:a16="http://schemas.microsoft.com/office/drawing/2014/main" id="{B920BDBC-E86C-455C-8892-674CE0CAAAF2}"/>
               </a:ext>
             </a:extLst>
           </p:cNvPr>
@@ -14665,7 +14665,7 @@
           <p:cNvPr id="87" name="Google Shape;87;p17">
             <a:extLst xmlns:a="http://schemas.openxmlformats.org/drawingml/2006/main">
               <a:ext uri="{FF2B5EF4-FFF2-40B4-BE49-F238E27FC236}">
-                <a16:creationId xmlns:a16="http://schemas.microsoft.com/office/drawing/2014/main" id="{B433120F-F513-4580-B4F9-FEA8C863D957}"/>
+                <a16:creationId xmlns:a16="http://schemas.microsoft.com/office/drawing/2014/main" id="{F6DC0EFE-E193-42EE-99B2-3C4BAB84B710}"/>
               </a:ext>
             </a:extLst>
           </p:cNvPr>
@@ -14745,7 +14745,7 @@
           <p:cNvPr id="88" name="">
             <a:extLst xmlns:a="http://schemas.openxmlformats.org/drawingml/2006/main">
               <a:ext uri="{FF2B5EF4-FFF2-40B4-BE49-F238E27FC236}">
-                <a16:creationId xmlns:a16="http://schemas.microsoft.com/office/drawing/2014/main" id="{F3E1403E-DCFB-4EA1-9D2E-238868781138}"/>
+                <a16:creationId xmlns:a16="http://schemas.microsoft.com/office/drawing/2014/main" id="{8B2EC7BC-60EB-4FC0-B979-E8D5CD2E2B56}"/>
               </a:ext>
             </a:extLst>
           </p:cNvPr>
@@ -14952,7 +14952,7 @@
           <p:cNvPr id="89" name="">
             <a:extLst xmlns:a="http://schemas.openxmlformats.org/drawingml/2006/main">
               <a:ext uri="{FF2B5EF4-FFF2-40B4-BE49-F238E27FC236}">
-                <a16:creationId xmlns:a16="http://schemas.microsoft.com/office/drawing/2014/main" id="{D23264CF-87B1-4F4F-A110-27F9D61F3BF4}"/>
+                <a16:creationId xmlns:a16="http://schemas.microsoft.com/office/drawing/2014/main" id="{79FD3A7B-968A-42AC-933F-D4C89D724305}"/>
               </a:ext>
             </a:extLst>
           </p:cNvPr>
@@ -15020,7 +15020,7 @@
           <p:cNvPr id="90" name="">
             <a:extLst xmlns:a="http://schemas.openxmlformats.org/drawingml/2006/main">
               <a:ext uri="{FF2B5EF4-FFF2-40B4-BE49-F238E27FC236}">
-                <a16:creationId xmlns:a16="http://schemas.microsoft.com/office/drawing/2014/main" id="{FFF506F1-DD7B-4389-9DFD-0BDF765A337A}"/>
+                <a16:creationId xmlns:a16="http://schemas.microsoft.com/office/drawing/2014/main" id="{DC73607D-B563-4BDB-8115-2D146F9B3D46}"/>
               </a:ext>
             </a:extLst>
           </p:cNvPr>
@@ -15086,7 +15086,7 @@
     </p:spTree>
     <p:extLst>
       <p:ext uri="{BB962C8B-B14F-4D97-AF65-F5344CB8AC3E}">
-        <p14:creationId xmlns:p14="http://schemas.microsoft.com/office/powerpoint/2010/main" val="1829558732"/>
+        <p14:creationId xmlns:p14="http://schemas.microsoft.com/office/powerpoint/2010/main" val="479200512"/>
       </p:ext>
     </p:extLst>
   </p:cSld>
@@ -15110,7 +15110,7 @@
           <p:cNvPr id="106" name="">
             <a:extLst xmlns:a="http://schemas.openxmlformats.org/drawingml/2006/main">
               <a:ext uri="{FF2B5EF4-FFF2-40B4-BE49-F238E27FC236}">
-                <a16:creationId xmlns:a16="http://schemas.microsoft.com/office/drawing/2014/main" id="{FA974CE6-1071-4FDB-98AF-CFFC599F5258}"/>
+                <a16:creationId xmlns:a16="http://schemas.microsoft.com/office/drawing/2014/main" id="{76437B3A-5C22-4250-8757-CEBA4CCFDC26}"/>
               </a:ext>
             </a:extLst>
           </p:cNvPr>
@@ -15141,7 +15141,7 @@
           <p:cNvPr id="105" name="">
             <a:extLst xmlns:a="http://schemas.openxmlformats.org/drawingml/2006/main">
               <a:ext uri="{FF2B5EF4-FFF2-40B4-BE49-F238E27FC236}">
-                <a16:creationId xmlns:a16="http://schemas.microsoft.com/office/drawing/2014/main" id="{CDFD8E7C-3DB0-4B83-A8CC-928DC2046219}"/>
+                <a16:creationId xmlns:a16="http://schemas.microsoft.com/office/drawing/2014/main" id="{4015AF4E-59B0-4068-A809-034BD52BB910}"/>
               </a:ext>
             </a:extLst>
           </p:cNvPr>
@@ -15172,7 +15172,7 @@
           <p:cNvPr id="104" name="">
             <a:extLst xmlns:a="http://schemas.openxmlformats.org/drawingml/2006/main">
               <a:ext uri="{FF2B5EF4-FFF2-40B4-BE49-F238E27FC236}">
-                <a16:creationId xmlns:a16="http://schemas.microsoft.com/office/drawing/2014/main" id="{B93AC678-75EB-49B4-8934-7665B564E50A}"/>
+                <a16:creationId xmlns:a16="http://schemas.microsoft.com/office/drawing/2014/main" id="{704057E8-0847-4E27-8E69-A7D4FE67DC99}"/>
               </a:ext>
             </a:extLst>
           </p:cNvPr>
@@ -15203,7 +15203,7 @@
           <p:cNvPr id="100" name="">
             <a:extLst xmlns:a="http://schemas.openxmlformats.org/drawingml/2006/main">
               <a:ext uri="{FF2B5EF4-FFF2-40B4-BE49-F238E27FC236}">
-                <a16:creationId xmlns:a16="http://schemas.microsoft.com/office/drawing/2014/main" id="{89720D6C-CA35-4FB3-9A44-6385B2747E9D}"/>
+                <a16:creationId xmlns:a16="http://schemas.microsoft.com/office/drawing/2014/main" id="{F0136D48-FCF0-4030-AA2F-1B9BB8F9984A}"/>
               </a:ext>
             </a:extLst>
           </p:cNvPr>
@@ -15234,7 +15234,7 @@
           <p:cNvPr id="99" name="">
             <a:extLst xmlns:a="http://schemas.openxmlformats.org/drawingml/2006/main">
               <a:ext uri="{FF2B5EF4-FFF2-40B4-BE49-F238E27FC236}">
-                <a16:creationId xmlns:a16="http://schemas.microsoft.com/office/drawing/2014/main" id="{A58313F5-0957-4055-B9F2-EC1A0E03F9DB}"/>
+                <a16:creationId xmlns:a16="http://schemas.microsoft.com/office/drawing/2014/main" id="{54634E5D-B765-4D09-8E64-9CDE32318FEF}"/>
               </a:ext>
             </a:extLst>
           </p:cNvPr>
@@ -15265,7 +15265,7 @@
           <p:cNvPr id="92" name="Google Shape;92;p18">
             <a:extLst xmlns:a="http://schemas.openxmlformats.org/drawingml/2006/main">
               <a:ext uri="{FF2B5EF4-FFF2-40B4-BE49-F238E27FC236}">
-                <a16:creationId xmlns:a16="http://schemas.microsoft.com/office/drawing/2014/main" id="{E528D56D-B4AF-4998-902C-F598CAECF1F2}"/>
+                <a16:creationId xmlns:a16="http://schemas.microsoft.com/office/drawing/2014/main" id="{6374B89F-2666-42DE-BD7A-0C9F9C1AF73A}"/>
               </a:ext>
             </a:extLst>
           </p:cNvPr>
@@ -15275,7 +15275,7 @@
           <p:nvPr/>
         </p:nvPicPr>
         <p:blipFill rotWithShape="1">
-          <a:blip xmlns:r="http://schemas.openxmlformats.org/officeDocument/2006/relationships" xmlns:a="http://schemas.openxmlformats.org/drawingml/2006/main" r:embed="Rb0d25e490178454b">
+          <a:blip xmlns:r="http://schemas.openxmlformats.org/officeDocument/2006/relationships" xmlns:a="http://schemas.openxmlformats.org/drawingml/2006/main" r:embed="Re8d93fb4f0d04567">
             <a:alphaModFix/>
           </a:blip>
           <a:srcRect xmlns:a="http://schemas.openxmlformats.org/drawingml/2006/main" l="0" t="0" r="0" b="98001"/>
@@ -15299,7 +15299,7 @@
           <p:cNvPr id="93" name="Google Shape;93;p18">
             <a:extLst xmlns:a="http://schemas.openxmlformats.org/drawingml/2006/main">
               <a:ext uri="{FF2B5EF4-FFF2-40B4-BE49-F238E27FC236}">
-                <a16:creationId xmlns:a16="http://schemas.microsoft.com/office/drawing/2014/main" id="{10D07761-C448-4F14-A5C4-C25FB3A89587}"/>
+                <a16:creationId xmlns:a16="http://schemas.microsoft.com/office/drawing/2014/main" id="{7A450C0C-DDC5-4479-B576-8DCD8F7BF18F}"/>
               </a:ext>
             </a:extLst>
           </p:cNvPr>
@@ -15309,7 +15309,7 @@
           <p:nvPr/>
         </p:nvPicPr>
         <p:blipFill>
-          <a:blip xmlns:r="http://schemas.openxmlformats.org/officeDocument/2006/relationships" xmlns:a="http://schemas.openxmlformats.org/drawingml/2006/main" r:embed="Re7b7872647bf4741">
+          <a:blip xmlns:r="http://schemas.openxmlformats.org/officeDocument/2006/relationships" xmlns:a="http://schemas.openxmlformats.org/drawingml/2006/main" r:embed="Rcfb6a3a4d7ea4a0e">
             <a:alphaModFix/>
           </a:blip>
           <a:stretch xmlns:a="http://schemas.openxmlformats.org/drawingml/2006/main">
@@ -15334,7 +15334,7 @@
           <p:cNvPr id="94" name="Google Shape;94;p18">
             <a:extLst xmlns:a="http://schemas.openxmlformats.org/drawingml/2006/main">
               <a:ext uri="{FF2B5EF4-FFF2-40B4-BE49-F238E27FC236}">
-                <a16:creationId xmlns:a16="http://schemas.microsoft.com/office/drawing/2014/main" id="{8BEC3398-09AC-461E-AE8F-371E852FF1EC}"/>
+                <a16:creationId xmlns:a16="http://schemas.microsoft.com/office/drawing/2014/main" id="{A364FF9F-995B-47CB-B2C0-C2A6B47D507F}"/>
               </a:ext>
             </a:extLst>
           </p:cNvPr>
@@ -15385,7 +15385,7 @@
           <p:cNvPr id="95" name="Google Shape;95;p18">
             <a:extLst xmlns:a="http://schemas.openxmlformats.org/drawingml/2006/main">
               <a:ext uri="{FF2B5EF4-FFF2-40B4-BE49-F238E27FC236}">
-                <a16:creationId xmlns:a16="http://schemas.microsoft.com/office/drawing/2014/main" id="{30735458-E50A-4A53-BEB2-4446378843D9}"/>
+                <a16:creationId xmlns:a16="http://schemas.microsoft.com/office/drawing/2014/main" id="{5B2C53DB-98E5-46E8-B39E-0C71ECA9A6A5}"/>
               </a:ext>
             </a:extLst>
           </p:cNvPr>
@@ -15465,7 +15465,7 @@
           <p:cNvPr id="96" name="">
             <a:extLst xmlns:a="http://schemas.openxmlformats.org/drawingml/2006/main">
               <a:ext uri="{FF2B5EF4-FFF2-40B4-BE49-F238E27FC236}">
-                <a16:creationId xmlns:a16="http://schemas.microsoft.com/office/drawing/2014/main" id="{04BEDD6B-A6EE-4E4E-A7BB-AF113570F751}"/>
+                <a16:creationId xmlns:a16="http://schemas.microsoft.com/office/drawing/2014/main" id="{86C1406B-DB60-4358-AB22-54B8B031E45C}"/>
               </a:ext>
             </a:extLst>
           </p:cNvPr>
@@ -15562,7 +15562,7 @@
           <p:cNvPr id="97" name="">
             <a:extLst xmlns:a="http://schemas.openxmlformats.org/drawingml/2006/main">
               <a:ext uri="{FF2B5EF4-FFF2-40B4-BE49-F238E27FC236}">
-                <a16:creationId xmlns:a16="http://schemas.microsoft.com/office/drawing/2014/main" id="{4264A2A6-8CA2-43AB-B59C-8ED2A468BD12}"/>
+                <a16:creationId xmlns:a16="http://schemas.microsoft.com/office/drawing/2014/main" id="{2E665448-D8A7-4CBA-9A92-6BF39F726FFB}"/>
               </a:ext>
             </a:extLst>
           </p:cNvPr>
@@ -15659,7 +15659,7 @@
           <p:cNvPr id="98" name="">
             <a:extLst xmlns:a="http://schemas.openxmlformats.org/drawingml/2006/main">
               <a:ext uri="{FF2B5EF4-FFF2-40B4-BE49-F238E27FC236}">
-                <a16:creationId xmlns:a16="http://schemas.microsoft.com/office/drawing/2014/main" id="{207ECD17-D72E-4ACA-AAF1-7C74C4BC1F6D}"/>
+                <a16:creationId xmlns:a16="http://schemas.microsoft.com/office/drawing/2014/main" id="{046D3BEB-1247-4A83-AC5F-7834FE78C0FB}"/>
               </a:ext>
             </a:extLst>
           </p:cNvPr>
@@ -15756,7 +15756,7 @@
           <p:cNvPr id="101" name="">
             <a:extLst xmlns:a="http://schemas.openxmlformats.org/drawingml/2006/main">
               <a:ext uri="{FF2B5EF4-FFF2-40B4-BE49-F238E27FC236}">
-                <a16:creationId xmlns:a16="http://schemas.microsoft.com/office/drawing/2014/main" id="{3976B458-C6D0-4796-823B-4E847D99907D}"/>
+                <a16:creationId xmlns:a16="http://schemas.microsoft.com/office/drawing/2014/main" id="{B3E76024-2FA5-42EC-9906-06A0AF715B4E}"/>
               </a:ext>
             </a:extLst>
           </p:cNvPr>
@@ -15853,7 +15853,7 @@
           <p:cNvPr id="102" name="">
             <a:extLst xmlns:a="http://schemas.openxmlformats.org/drawingml/2006/main">
               <a:ext uri="{FF2B5EF4-FFF2-40B4-BE49-F238E27FC236}">
-                <a16:creationId xmlns:a16="http://schemas.microsoft.com/office/drawing/2014/main" id="{2E3E30F3-BE37-4406-A33F-22616648D623}"/>
+                <a16:creationId xmlns:a16="http://schemas.microsoft.com/office/drawing/2014/main" id="{E936DF11-7F51-4934-B52D-DD58DE5FE93C}"/>
               </a:ext>
             </a:extLst>
           </p:cNvPr>
@@ -15950,7 +15950,7 @@
           <p:cNvPr id="103" name="">
             <a:extLst xmlns:a="http://schemas.openxmlformats.org/drawingml/2006/main">
               <a:ext uri="{FF2B5EF4-FFF2-40B4-BE49-F238E27FC236}">
-                <a16:creationId xmlns:a16="http://schemas.microsoft.com/office/drawing/2014/main" id="{FE7B7F27-EEC8-416D-B05F-4AF81264B1DF}"/>
+                <a16:creationId xmlns:a16="http://schemas.microsoft.com/office/drawing/2014/main" id="{69ED51A0-20A6-495E-930C-C25FF883C62A}"/>
               </a:ext>
             </a:extLst>
           </p:cNvPr>
@@ -16047,7 +16047,7 @@
           <p:cNvPr id="107" name="">
             <a:extLst xmlns:a="http://schemas.openxmlformats.org/drawingml/2006/main">
               <a:ext uri="{FF2B5EF4-FFF2-40B4-BE49-F238E27FC236}">
-                <a16:creationId xmlns:a16="http://schemas.microsoft.com/office/drawing/2014/main" id="{92E420EA-0221-429C-A4F1-DBE1CCC78ED6}"/>
+                <a16:creationId xmlns:a16="http://schemas.microsoft.com/office/drawing/2014/main" id="{60D716CD-60D4-449D-B9F2-E543EA9B14E3}"/>
               </a:ext>
             </a:extLst>
           </p:cNvPr>
@@ -16115,7 +16115,7 @@
           <p:cNvPr id="108" name="">
             <a:extLst xmlns:a="http://schemas.openxmlformats.org/drawingml/2006/main">
               <a:ext uri="{FF2B5EF4-FFF2-40B4-BE49-F238E27FC236}">
-                <a16:creationId xmlns:a16="http://schemas.microsoft.com/office/drawing/2014/main" id="{193DEDBD-0F95-43CD-B832-9E856EB9B1D8}"/>
+                <a16:creationId xmlns:a16="http://schemas.microsoft.com/office/drawing/2014/main" id="{F783736D-7BA4-4FE5-A603-793B8EB430D4}"/>
               </a:ext>
             </a:extLst>
           </p:cNvPr>
@@ -16183,7 +16183,7 @@
           <p:cNvPr id="109" name="">
             <a:extLst xmlns:a="http://schemas.openxmlformats.org/drawingml/2006/main">
               <a:ext uri="{FF2B5EF4-FFF2-40B4-BE49-F238E27FC236}">
-                <a16:creationId xmlns:a16="http://schemas.microsoft.com/office/drawing/2014/main" id="{99AA22B5-E9BD-4A9B-ACFA-DBFC05D26F61}"/>
+                <a16:creationId xmlns:a16="http://schemas.microsoft.com/office/drawing/2014/main" id="{76F3000C-A1F3-49F2-B646-F07FBDA64E23}"/>
               </a:ext>
             </a:extLst>
           </p:cNvPr>
@@ -16249,7 +16249,7 @@
     </p:spTree>
     <p:extLst>
       <p:ext uri="{BB962C8B-B14F-4D97-AF65-F5344CB8AC3E}">
-        <p14:creationId xmlns:p14="http://schemas.microsoft.com/office/powerpoint/2010/main" val="1402938463"/>
+        <p14:creationId xmlns:p14="http://schemas.microsoft.com/office/powerpoint/2010/main" val="713666589"/>
       </p:ext>
     </p:extLst>
   </p:cSld>
@@ -16273,7 +16273,7 @@
           <p:cNvPr id="100" name="Google Shape;100;p19">
             <a:extLst xmlns:a="http://schemas.openxmlformats.org/drawingml/2006/main">
               <a:ext uri="{FF2B5EF4-FFF2-40B4-BE49-F238E27FC236}">
-                <a16:creationId xmlns:a16="http://schemas.microsoft.com/office/drawing/2014/main" id="{3A4597B4-BCB8-4E1A-9F5C-95E120A741E5}"/>
+                <a16:creationId xmlns:a16="http://schemas.microsoft.com/office/drawing/2014/main" id="{32DCD319-0B1D-4F4F-81F3-4F9A04E6B780}"/>
               </a:ext>
             </a:extLst>
           </p:cNvPr>
@@ -16283,7 +16283,7 @@
           <p:nvPr/>
         </p:nvPicPr>
         <p:blipFill rotWithShape="1">
-          <a:blip xmlns:r="http://schemas.openxmlformats.org/officeDocument/2006/relationships" xmlns:a="http://schemas.openxmlformats.org/drawingml/2006/main" r:embed="R3f3fd22fb8834222">
+          <a:blip xmlns:r="http://schemas.openxmlformats.org/officeDocument/2006/relationships" xmlns:a="http://schemas.openxmlformats.org/drawingml/2006/main" r:embed="Rc9199b30bea74473">
             <a:alphaModFix/>
           </a:blip>
           <a:srcRect xmlns:a="http://schemas.openxmlformats.org/drawingml/2006/main" l="0" t="0" r="0" b="98001"/>
@@ -16307,7 +16307,7 @@
           <p:cNvPr id="101" name="Google Shape;101;p19">
             <a:extLst xmlns:a="http://schemas.openxmlformats.org/drawingml/2006/main">
               <a:ext uri="{FF2B5EF4-FFF2-40B4-BE49-F238E27FC236}">
-                <a16:creationId xmlns:a16="http://schemas.microsoft.com/office/drawing/2014/main" id="{B585AD6F-8C93-4753-9C03-70F6F49ABCF2}"/>
+                <a16:creationId xmlns:a16="http://schemas.microsoft.com/office/drawing/2014/main" id="{8850692B-EBED-4DF9-BF02-B16C04B1B272}"/>
               </a:ext>
             </a:extLst>
           </p:cNvPr>
@@ -16317,7 +16317,7 @@
           <p:nvPr/>
         </p:nvPicPr>
         <p:blipFill>
-          <a:blip xmlns:r="http://schemas.openxmlformats.org/officeDocument/2006/relationships" xmlns:a="http://schemas.openxmlformats.org/drawingml/2006/main" r:embed="R8a199f5a4e934f50">
+          <a:blip xmlns:r="http://schemas.openxmlformats.org/officeDocument/2006/relationships" xmlns:a="http://schemas.openxmlformats.org/drawingml/2006/main" r:embed="R0abd3fb2b8044464">
             <a:alphaModFix/>
           </a:blip>
           <a:stretch xmlns:a="http://schemas.openxmlformats.org/drawingml/2006/main">
@@ -16342,7 +16342,7 @@
           <p:cNvPr id="102" name="Google Shape;102;p19">
             <a:extLst xmlns:a="http://schemas.openxmlformats.org/drawingml/2006/main">
               <a:ext uri="{FF2B5EF4-FFF2-40B4-BE49-F238E27FC236}">
-                <a16:creationId xmlns:a16="http://schemas.microsoft.com/office/drawing/2014/main" id="{073BFE16-DA99-45A7-B29A-69B28190CADD}"/>
+                <a16:creationId xmlns:a16="http://schemas.microsoft.com/office/drawing/2014/main" id="{90B0237D-DBCE-4B5C-839D-0D7295E0EF73}"/>
               </a:ext>
             </a:extLst>
           </p:cNvPr>
@@ -16393,7 +16393,7 @@
           <p:cNvPr id="103" name="Google Shape;103;p19">
             <a:extLst xmlns:a="http://schemas.openxmlformats.org/drawingml/2006/main">
               <a:ext uri="{FF2B5EF4-FFF2-40B4-BE49-F238E27FC236}">
-                <a16:creationId xmlns:a16="http://schemas.microsoft.com/office/drawing/2014/main" id="{B1EC134F-EBCE-43A8-A220-90301C8CA46C}"/>
+                <a16:creationId xmlns:a16="http://schemas.microsoft.com/office/drawing/2014/main" id="{7B3D0481-102F-4BE8-B55F-7CDF1D714CEF}"/>
               </a:ext>
             </a:extLst>
           </p:cNvPr>
@@ -16473,7 +16473,7 @@
           <p:cNvPr id="104" name="">
             <a:extLst xmlns:a="http://schemas.openxmlformats.org/drawingml/2006/main">
               <a:ext uri="{FF2B5EF4-FFF2-40B4-BE49-F238E27FC236}">
-                <a16:creationId xmlns:a16="http://schemas.microsoft.com/office/drawing/2014/main" id="{D729C867-9C33-4030-94F0-ED4EBF35D3D4}"/>
+                <a16:creationId xmlns:a16="http://schemas.microsoft.com/office/drawing/2014/main" id="{39B9767D-24BE-44A9-8B23-174FEF902588}"/>
               </a:ext>
             </a:extLst>
           </p:cNvPr>
@@ -16483,7 +16483,7 @@
           <p:nvPr/>
         </p:nvPicPr>
         <p:blipFill>
-          <a:blip xmlns:r="http://schemas.openxmlformats.org/officeDocument/2006/relationships" xmlns:a="http://schemas.openxmlformats.org/drawingml/2006/main" r:embed="R043340919c98400a"/>
+          <a:blip xmlns:r="http://schemas.openxmlformats.org/officeDocument/2006/relationships" xmlns:a="http://schemas.openxmlformats.org/drawingml/2006/main" r:embed="R9d32dfc9d59c428a"/>
           <a:stretch xmlns:a="http://schemas.openxmlformats.org/drawingml/2006/main"/>
         </p:blipFill>
         <p:spPr>
@@ -16501,7 +16501,7 @@
           <p:cNvPr id="105" name="">
             <a:extLst xmlns:a="http://schemas.openxmlformats.org/drawingml/2006/main">
               <a:ext uri="{FF2B5EF4-FFF2-40B4-BE49-F238E27FC236}">
-                <a16:creationId xmlns:a16="http://schemas.microsoft.com/office/drawing/2014/main" id="{E09D939F-0A56-4D20-9597-4F598631BD64}"/>
+                <a16:creationId xmlns:a16="http://schemas.microsoft.com/office/drawing/2014/main" id="{2E27D9F6-52D3-4DC2-B098-CAB4B64F5CA7}"/>
               </a:ext>
             </a:extLst>
           </p:cNvPr>
@@ -16569,7 +16569,7 @@
           <p:cNvPr id="106" name="">
             <a:extLst xmlns:a="http://schemas.openxmlformats.org/drawingml/2006/main">
               <a:ext uri="{FF2B5EF4-FFF2-40B4-BE49-F238E27FC236}">
-                <a16:creationId xmlns:a16="http://schemas.microsoft.com/office/drawing/2014/main" id="{AC5CD28B-6892-4858-884F-CD0F9EF02AC5}"/>
+                <a16:creationId xmlns:a16="http://schemas.microsoft.com/office/drawing/2014/main" id="{9469365F-6766-419F-9DFC-F0A8F72DCCA8}"/>
               </a:ext>
             </a:extLst>
           </p:cNvPr>
@@ -16721,7 +16721,7 @@
           <p:cNvPr id="107" name="">
             <a:extLst xmlns:a="http://schemas.openxmlformats.org/drawingml/2006/main">
               <a:ext uri="{FF2B5EF4-FFF2-40B4-BE49-F238E27FC236}">
-                <a16:creationId xmlns:a16="http://schemas.microsoft.com/office/drawing/2014/main" id="{956A76D0-1E82-4183-8030-E58DBC65C5E5}"/>
+                <a16:creationId xmlns:a16="http://schemas.microsoft.com/office/drawing/2014/main" id="{7B51C273-0F7F-44F1-BB36-AB45473AB487}"/>
               </a:ext>
             </a:extLst>
           </p:cNvPr>
@@ -16789,7 +16789,7 @@
           <p:cNvPr id="108" name="">
             <a:extLst xmlns:a="http://schemas.openxmlformats.org/drawingml/2006/main">
               <a:ext uri="{FF2B5EF4-FFF2-40B4-BE49-F238E27FC236}">
-                <a16:creationId xmlns:a16="http://schemas.microsoft.com/office/drawing/2014/main" id="{952233A2-18E0-43F3-9BCF-0F5D8070F819}"/>
+                <a16:creationId xmlns:a16="http://schemas.microsoft.com/office/drawing/2014/main" id="{2B9947B3-80EE-415D-BF1A-EE6C3796DAE6}"/>
               </a:ext>
             </a:extLst>
           </p:cNvPr>
@@ -16855,7 +16855,7 @@
     </p:spTree>
     <p:extLst>
       <p:ext uri="{BB962C8B-B14F-4D97-AF65-F5344CB8AC3E}">
-        <p14:creationId xmlns:p14="http://schemas.microsoft.com/office/powerpoint/2010/main" val="1071860994"/>
+        <p14:creationId xmlns:p14="http://schemas.microsoft.com/office/powerpoint/2010/main" val="350163269"/>
       </p:ext>
     </p:extLst>
   </p:cSld>
@@ -16879,7 +16879,7 @@
           <p:cNvPr id="125" name="">
             <a:extLst xmlns:a="http://schemas.openxmlformats.org/drawingml/2006/main">
               <a:ext uri="{FF2B5EF4-FFF2-40B4-BE49-F238E27FC236}">
-                <a16:creationId xmlns:a16="http://schemas.microsoft.com/office/drawing/2014/main" id="{A6ACC0E9-FF65-4BCD-94F5-6EF77C42D6EB}"/>
+                <a16:creationId xmlns:a16="http://schemas.microsoft.com/office/drawing/2014/main" id="{433B329A-A5E0-4CA9-B0AB-46D180A50EFE}"/>
               </a:ext>
             </a:extLst>
           </p:cNvPr>
@@ -16913,7 +16913,7 @@
           <p:cNvPr id="124" name="">
             <a:extLst xmlns:a="http://schemas.openxmlformats.org/drawingml/2006/main">
               <a:ext uri="{FF2B5EF4-FFF2-40B4-BE49-F238E27FC236}">
-                <a16:creationId xmlns:a16="http://schemas.microsoft.com/office/drawing/2014/main" id="{A2344007-B2E7-4F1B-82E8-B4C701209967}"/>
+                <a16:creationId xmlns:a16="http://schemas.microsoft.com/office/drawing/2014/main" id="{AC793B18-F3A0-4972-A7DA-416508B4F247}"/>
               </a:ext>
             </a:extLst>
           </p:cNvPr>
@@ -16944,7 +16944,7 @@
           <p:cNvPr id="123" name="">
             <a:extLst xmlns:a="http://schemas.openxmlformats.org/drawingml/2006/main">
               <a:ext uri="{FF2B5EF4-FFF2-40B4-BE49-F238E27FC236}">
-                <a16:creationId xmlns:a16="http://schemas.microsoft.com/office/drawing/2014/main" id="{A1544061-6CAE-49C2-94DD-2960D281E5C7}"/>
+                <a16:creationId xmlns:a16="http://schemas.microsoft.com/office/drawing/2014/main" id="{958D85FF-5BAD-4078-AA3C-33D6BB853163}"/>
               </a:ext>
             </a:extLst>
           </p:cNvPr>
@@ -16975,7 +16975,7 @@
           <p:cNvPr id="122" name="">
             <a:extLst xmlns:a="http://schemas.openxmlformats.org/drawingml/2006/main">
               <a:ext uri="{FF2B5EF4-FFF2-40B4-BE49-F238E27FC236}">
-                <a16:creationId xmlns:a16="http://schemas.microsoft.com/office/drawing/2014/main" id="{DEEDEE70-A9B9-452E-BEBD-F4BA26783C16}"/>
+                <a16:creationId xmlns:a16="http://schemas.microsoft.com/office/drawing/2014/main" id="{353C8088-8298-4ED6-B397-8633DA568B95}"/>
               </a:ext>
             </a:extLst>
           </p:cNvPr>
@@ -17009,7 +17009,7 @@
           <p:cNvPr id="118" name="">
             <a:extLst xmlns:a="http://schemas.openxmlformats.org/drawingml/2006/main">
               <a:ext uri="{FF2B5EF4-FFF2-40B4-BE49-F238E27FC236}">
-                <a16:creationId xmlns:a16="http://schemas.microsoft.com/office/drawing/2014/main" id="{69D2ECC3-5946-4C85-8B8E-FB2E040B1377}"/>
+                <a16:creationId xmlns:a16="http://schemas.microsoft.com/office/drawing/2014/main" id="{7E071093-9B93-4528-90D0-8A1568F07083}"/>
               </a:ext>
             </a:extLst>
           </p:cNvPr>
@@ -17040,7 +17040,7 @@
           <p:cNvPr id="117" name="">
             <a:extLst xmlns:a="http://schemas.openxmlformats.org/drawingml/2006/main">
               <a:ext uri="{FF2B5EF4-FFF2-40B4-BE49-F238E27FC236}">
-                <a16:creationId xmlns:a16="http://schemas.microsoft.com/office/drawing/2014/main" id="{97C7979F-5B63-423F-A830-84BDAEA00507}"/>
+                <a16:creationId xmlns:a16="http://schemas.microsoft.com/office/drawing/2014/main" id="{F6F9ACDB-64A5-443D-8519-45764C748642}"/>
               </a:ext>
             </a:extLst>
           </p:cNvPr>
@@ -17071,7 +17071,7 @@
           <p:cNvPr id="116" name="">
             <a:extLst xmlns:a="http://schemas.openxmlformats.org/drawingml/2006/main">
               <a:ext uri="{FF2B5EF4-FFF2-40B4-BE49-F238E27FC236}">
-                <a16:creationId xmlns:a16="http://schemas.microsoft.com/office/drawing/2014/main" id="{F764ED97-986D-4FB9-A400-12939E65B13C}"/>
+                <a16:creationId xmlns:a16="http://schemas.microsoft.com/office/drawing/2014/main" id="{66EAA9CC-9322-4BBF-A9F6-EF24B9C3F2D7}"/>
               </a:ext>
             </a:extLst>
           </p:cNvPr>
@@ -17102,7 +17102,7 @@
           <p:cNvPr id="108" name="Google Shape;108;p20">
             <a:extLst xmlns:a="http://schemas.openxmlformats.org/drawingml/2006/main">
               <a:ext uri="{FF2B5EF4-FFF2-40B4-BE49-F238E27FC236}">
-                <a16:creationId xmlns:a16="http://schemas.microsoft.com/office/drawing/2014/main" id="{57F6E958-D94E-449D-BF6F-DB145D775022}"/>
+                <a16:creationId xmlns:a16="http://schemas.microsoft.com/office/drawing/2014/main" id="{BD39418E-B33E-4063-B34B-90EE0CAFADA2}"/>
               </a:ext>
             </a:extLst>
           </p:cNvPr>
@@ -17112,7 +17112,7 @@
           <p:nvPr/>
         </p:nvPicPr>
         <p:blipFill rotWithShape="1">
-          <a:blip xmlns:r="http://schemas.openxmlformats.org/officeDocument/2006/relationships" xmlns:a="http://schemas.openxmlformats.org/drawingml/2006/main" r:embed="Rdb3ab2de32864d3b">
+          <a:blip xmlns:r="http://schemas.openxmlformats.org/officeDocument/2006/relationships" xmlns:a="http://schemas.openxmlformats.org/drawingml/2006/main" r:embed="R1270fe895fe44e86">
             <a:alphaModFix/>
           </a:blip>
           <a:srcRect xmlns:a="http://schemas.openxmlformats.org/drawingml/2006/main" l="0" t="0" r="0" b="98001"/>
@@ -17136,7 +17136,7 @@
           <p:cNvPr id="109" name="Google Shape;109;p20">
             <a:extLst xmlns:a="http://schemas.openxmlformats.org/drawingml/2006/main">
               <a:ext uri="{FF2B5EF4-FFF2-40B4-BE49-F238E27FC236}">
-                <a16:creationId xmlns:a16="http://schemas.microsoft.com/office/drawing/2014/main" id="{94516AB8-88B3-4EF9-936D-9E691C7D3235}"/>
+                <a16:creationId xmlns:a16="http://schemas.microsoft.com/office/drawing/2014/main" id="{04D1B119-528D-41F5-8310-302154AF323A}"/>
               </a:ext>
             </a:extLst>
           </p:cNvPr>
@@ -17146,7 +17146,7 @@
           <p:nvPr/>
         </p:nvPicPr>
         <p:blipFill>
-          <a:blip xmlns:r="http://schemas.openxmlformats.org/officeDocument/2006/relationships" xmlns:a="http://schemas.openxmlformats.org/drawingml/2006/main" r:embed="Racf1fcfe5268497c">
+          <a:blip xmlns:r="http://schemas.openxmlformats.org/officeDocument/2006/relationships" xmlns:a="http://schemas.openxmlformats.org/drawingml/2006/main" r:embed="Re53e21999c404bfa">
             <a:alphaModFix/>
           </a:blip>
           <a:stretch xmlns:a="http://schemas.openxmlformats.org/drawingml/2006/main">
@@ -17171,7 +17171,7 @@
           <p:cNvPr id="110" name="Google Shape;110;p20">
             <a:extLst xmlns:a="http://schemas.openxmlformats.org/drawingml/2006/main">
               <a:ext uri="{FF2B5EF4-FFF2-40B4-BE49-F238E27FC236}">
-                <a16:creationId xmlns:a16="http://schemas.microsoft.com/office/drawing/2014/main" id="{1C37C748-CC7C-4DF0-961E-BCB052CBE889}"/>
+                <a16:creationId xmlns:a16="http://schemas.microsoft.com/office/drawing/2014/main" id="{37AD664D-A18A-44DE-B321-818B02F36C4F}"/>
               </a:ext>
             </a:extLst>
           </p:cNvPr>
@@ -17222,7 +17222,7 @@
           <p:cNvPr id="111" name="Google Shape;111;p20">
             <a:extLst xmlns:a="http://schemas.openxmlformats.org/drawingml/2006/main">
               <a:ext uri="{FF2B5EF4-FFF2-40B4-BE49-F238E27FC236}">
-                <a16:creationId xmlns:a16="http://schemas.microsoft.com/office/drawing/2014/main" id="{EFCDCF7B-ADBC-4564-B67F-46DFEB8D6570}"/>
+                <a16:creationId xmlns:a16="http://schemas.microsoft.com/office/drawing/2014/main" id="{7622DAC3-3EDB-4B0A-93AB-D9FBE5CBA98B}"/>
               </a:ext>
             </a:extLst>
           </p:cNvPr>
@@ -17302,7 +17302,7 @@
           <p:cNvPr id="112" name="">
             <a:extLst xmlns:a="http://schemas.openxmlformats.org/drawingml/2006/main">
               <a:ext uri="{FF2B5EF4-FFF2-40B4-BE49-F238E27FC236}">
-                <a16:creationId xmlns:a16="http://schemas.microsoft.com/office/drawing/2014/main" id="{6A72412E-1D0F-4070-A5F0-86C24B592815}"/>
+                <a16:creationId xmlns:a16="http://schemas.microsoft.com/office/drawing/2014/main" id="{FA830FB4-7466-4FD2-9618-A38A84961086}"/>
               </a:ext>
             </a:extLst>
           </p:cNvPr>
@@ -17399,7 +17399,7 @@
           <p:cNvPr id="113" name="">
             <a:extLst xmlns:a="http://schemas.openxmlformats.org/drawingml/2006/main">
               <a:ext uri="{FF2B5EF4-FFF2-40B4-BE49-F238E27FC236}">
-                <a16:creationId xmlns:a16="http://schemas.microsoft.com/office/drawing/2014/main" id="{75208CF3-4CA2-4451-B0A6-4CCEA6921D28}"/>
+                <a16:creationId xmlns:a16="http://schemas.microsoft.com/office/drawing/2014/main" id="{CE98D94F-D783-4D33-9885-CEB5C91B1FBF}"/>
               </a:ext>
             </a:extLst>
           </p:cNvPr>
@@ -17496,7 +17496,7 @@
           <p:cNvPr id="114" name="">
             <a:extLst xmlns:a="http://schemas.openxmlformats.org/drawingml/2006/main">
               <a:ext uri="{FF2B5EF4-FFF2-40B4-BE49-F238E27FC236}">
-                <a16:creationId xmlns:a16="http://schemas.microsoft.com/office/drawing/2014/main" id="{D8B16847-314D-427D-A5AC-65FB905CF551}"/>
+                <a16:creationId xmlns:a16="http://schemas.microsoft.com/office/drawing/2014/main" id="{BCEB5575-4DEF-46F8-BD7E-B1E9ED008DD1}"/>
               </a:ext>
             </a:extLst>
           </p:cNvPr>
@@ -17593,7 +17593,7 @@
           <p:cNvPr id="115" name="">
             <a:extLst xmlns:a="http://schemas.openxmlformats.org/drawingml/2006/main">
               <a:ext uri="{FF2B5EF4-FFF2-40B4-BE49-F238E27FC236}">
-                <a16:creationId xmlns:a16="http://schemas.microsoft.com/office/drawing/2014/main" id="{496D2F81-5A63-4BE0-945F-84A2D48C6B38}"/>
+                <a16:creationId xmlns:a16="http://schemas.microsoft.com/office/drawing/2014/main" id="{22815A0A-5CC5-4E1F-93E2-92EFCEE3169E}"/>
               </a:ext>
             </a:extLst>
           </p:cNvPr>
@@ -17690,7 +17690,7 @@
           <p:cNvPr id="119" name="">
             <a:extLst xmlns:a="http://schemas.openxmlformats.org/drawingml/2006/main">
               <a:ext uri="{FF2B5EF4-FFF2-40B4-BE49-F238E27FC236}">
-                <a16:creationId xmlns:a16="http://schemas.microsoft.com/office/drawing/2014/main" id="{BF210344-4C5B-4960-B15C-B1BDF9AF67AA}"/>
+                <a16:creationId xmlns:a16="http://schemas.microsoft.com/office/drawing/2014/main" id="{2BF54FA3-4B8B-4F43-B9FE-48A61D4E6674}"/>
               </a:ext>
             </a:extLst>
           </p:cNvPr>
@@ -17810,7 +17810,7 @@
           <p:cNvPr id="120" name="">
             <a:extLst xmlns:a="http://schemas.openxmlformats.org/drawingml/2006/main">
               <a:ext uri="{FF2B5EF4-FFF2-40B4-BE49-F238E27FC236}">
-                <a16:creationId xmlns:a16="http://schemas.microsoft.com/office/drawing/2014/main" id="{4E6F9928-4F63-4F72-B896-B617FBDA7492}"/>
+                <a16:creationId xmlns:a16="http://schemas.microsoft.com/office/drawing/2014/main" id="{69843349-9596-4F4F-B322-0968EE02A70D}"/>
               </a:ext>
             </a:extLst>
           </p:cNvPr>
@@ -17930,7 +17930,7 @@
           <p:cNvPr id="121" name="">
             <a:extLst xmlns:a="http://schemas.openxmlformats.org/drawingml/2006/main">
               <a:ext uri="{FF2B5EF4-FFF2-40B4-BE49-F238E27FC236}">
-                <a16:creationId xmlns:a16="http://schemas.microsoft.com/office/drawing/2014/main" id="{B31367C2-A76D-45B2-912F-28CDF6CF9680}"/>
+                <a16:creationId xmlns:a16="http://schemas.microsoft.com/office/drawing/2014/main" id="{DBC7E9BF-2CB3-49B6-B02B-5F2CC827F9C6}"/>
               </a:ext>
             </a:extLst>
           </p:cNvPr>
@@ -18027,7 +18027,7 @@
           <p:cNvPr id="126" name="">
             <a:extLst xmlns:a="http://schemas.openxmlformats.org/drawingml/2006/main">
               <a:ext uri="{FF2B5EF4-FFF2-40B4-BE49-F238E27FC236}">
-                <a16:creationId xmlns:a16="http://schemas.microsoft.com/office/drawing/2014/main" id="{15717825-A1EA-413C-B591-1BE0076461FF}"/>
+                <a16:creationId xmlns:a16="http://schemas.microsoft.com/office/drawing/2014/main" id="{EC83A530-DC83-4CD9-B923-6C5C4C3C7662}"/>
               </a:ext>
             </a:extLst>
           </p:cNvPr>
@@ -18095,7 +18095,7 @@
           <p:cNvPr id="127" name="">
             <a:extLst xmlns:a="http://schemas.openxmlformats.org/drawingml/2006/main">
               <a:ext uri="{FF2B5EF4-FFF2-40B4-BE49-F238E27FC236}">
-                <a16:creationId xmlns:a16="http://schemas.microsoft.com/office/drawing/2014/main" id="{C493ED2F-F924-486B-8EB9-C78E20ED02BF}"/>
+                <a16:creationId xmlns:a16="http://schemas.microsoft.com/office/drawing/2014/main" id="{80B60AE7-F418-4448-B582-5D1DF84BE3EA}"/>
               </a:ext>
             </a:extLst>
           </p:cNvPr>
@@ -18163,7 +18163,7 @@
           <p:cNvPr id="128" name="">
             <a:extLst xmlns:a="http://schemas.openxmlformats.org/drawingml/2006/main">
               <a:ext uri="{FF2B5EF4-FFF2-40B4-BE49-F238E27FC236}">
-                <a16:creationId xmlns:a16="http://schemas.microsoft.com/office/drawing/2014/main" id="{EFD91396-DC76-4464-BF4C-1461A4AA4FAE}"/>
+                <a16:creationId xmlns:a16="http://schemas.microsoft.com/office/drawing/2014/main" id="{E8159620-CFAE-4EC2-9241-B70F0D740E2D}"/>
               </a:ext>
             </a:extLst>
           </p:cNvPr>
@@ -18229,7 +18229,7 @@
     </p:spTree>
     <p:extLst>
       <p:ext uri="{BB962C8B-B14F-4D97-AF65-F5344CB8AC3E}">
-        <p14:creationId xmlns:p14="http://schemas.microsoft.com/office/powerpoint/2010/main" val="1504187242"/>
+        <p14:creationId xmlns:p14="http://schemas.microsoft.com/office/powerpoint/2010/main" val="756605222"/>
       </p:ext>
     </p:extLst>
   </p:cSld>
@@ -18253,7 +18253,7 @@
           <p:cNvPr id="116" name="Google Shape;116;p21">
             <a:extLst xmlns:a="http://schemas.openxmlformats.org/drawingml/2006/main">
               <a:ext uri="{FF2B5EF4-FFF2-40B4-BE49-F238E27FC236}">
-                <a16:creationId xmlns:a16="http://schemas.microsoft.com/office/drawing/2014/main" id="{F773D6F2-5198-48A5-A32C-31DA55C213CF}"/>
+                <a16:creationId xmlns:a16="http://schemas.microsoft.com/office/drawing/2014/main" id="{11486C77-782D-4DAC-9D9F-8250687FA9CA}"/>
               </a:ext>
             </a:extLst>
           </p:cNvPr>
@@ -18263,7 +18263,7 @@
           <p:nvPr/>
         </p:nvPicPr>
         <p:blipFill rotWithShape="1">
-          <a:blip xmlns:r="http://schemas.openxmlformats.org/officeDocument/2006/relationships" xmlns:a="http://schemas.openxmlformats.org/drawingml/2006/main" r:embed="Rdaeb1b478bce4013">
+          <a:blip xmlns:r="http://schemas.openxmlformats.org/officeDocument/2006/relationships" xmlns:a="http://schemas.openxmlformats.org/drawingml/2006/main" r:embed="Ra73029c09153451b">
             <a:alphaModFix/>
           </a:blip>
           <a:srcRect xmlns:a="http://schemas.openxmlformats.org/drawingml/2006/main" l="0" t="0" r="0" b="98001"/>
@@ -18287,7 +18287,7 @@
           <p:cNvPr id="117" name="Google Shape;117;p21">
             <a:extLst xmlns:a="http://schemas.openxmlformats.org/drawingml/2006/main">
               <a:ext uri="{FF2B5EF4-FFF2-40B4-BE49-F238E27FC236}">
-                <a16:creationId xmlns:a16="http://schemas.microsoft.com/office/drawing/2014/main" id="{26A946DD-C5F7-442C-8F23-2C25CE0C80B4}"/>
+                <a16:creationId xmlns:a16="http://schemas.microsoft.com/office/drawing/2014/main" id="{0D30487B-F828-4958-BEDB-B9B76C6EF08A}"/>
               </a:ext>
             </a:extLst>
           </p:cNvPr>
@@ -18297,7 +18297,7 @@
           <p:nvPr/>
         </p:nvPicPr>
         <p:blipFill>
-          <a:blip xmlns:r="http://schemas.openxmlformats.org/officeDocument/2006/relationships" xmlns:a="http://schemas.openxmlformats.org/drawingml/2006/main" r:embed="Rba2581661c06488f">
+          <a:blip xmlns:r="http://schemas.openxmlformats.org/officeDocument/2006/relationships" xmlns:a="http://schemas.openxmlformats.org/drawingml/2006/main" r:embed="R2c002b9857d046cf">
             <a:alphaModFix/>
           </a:blip>
           <a:stretch xmlns:a="http://schemas.openxmlformats.org/drawingml/2006/main">
@@ -18322,7 +18322,7 @@
           <p:cNvPr id="118" name="Google Shape;118;p21">
             <a:extLst xmlns:a="http://schemas.openxmlformats.org/drawingml/2006/main">
               <a:ext uri="{FF2B5EF4-FFF2-40B4-BE49-F238E27FC236}">
-                <a16:creationId xmlns:a16="http://schemas.microsoft.com/office/drawing/2014/main" id="{F87B364C-D82C-4E8F-8C08-D5FCA58B1E25}"/>
+                <a16:creationId xmlns:a16="http://schemas.microsoft.com/office/drawing/2014/main" id="{6139BEFC-95CD-4857-909A-9078D1EE0C6B}"/>
               </a:ext>
             </a:extLst>
           </p:cNvPr>
@@ -18373,7 +18373,7 @@
           <p:cNvPr id="119" name="Google Shape;119;p21">
             <a:extLst xmlns:a="http://schemas.openxmlformats.org/drawingml/2006/main">
               <a:ext uri="{FF2B5EF4-FFF2-40B4-BE49-F238E27FC236}">
-                <a16:creationId xmlns:a16="http://schemas.microsoft.com/office/drawing/2014/main" id="{E91C58AD-4725-45BE-BD6E-51A1D9DAF9F9}"/>
+                <a16:creationId xmlns:a16="http://schemas.microsoft.com/office/drawing/2014/main" id="{E6DD6BAA-D7E4-4AF6-BCAE-8AF44174E783}"/>
               </a:ext>
             </a:extLst>
           </p:cNvPr>
@@ -18453,7 +18453,7 @@
           <p:cNvPr id="120" name="">
             <a:extLst xmlns:a="http://schemas.openxmlformats.org/drawingml/2006/main">
               <a:ext uri="{FF2B5EF4-FFF2-40B4-BE49-F238E27FC236}">
-                <a16:creationId xmlns:a16="http://schemas.microsoft.com/office/drawing/2014/main" id="{DE757A1A-E295-49BB-919C-E5144D5956BB}"/>
+                <a16:creationId xmlns:a16="http://schemas.microsoft.com/office/drawing/2014/main" id="{9B1ED757-0248-427A-86B6-CF2C9F5DBE09}"/>
               </a:ext>
             </a:extLst>
           </p:cNvPr>
@@ -19165,7 +19165,7 @@
           <p:cNvPr id="121" name="">
             <a:extLst xmlns:a="http://schemas.openxmlformats.org/drawingml/2006/main">
               <a:ext uri="{FF2B5EF4-FFF2-40B4-BE49-F238E27FC236}">
-                <a16:creationId xmlns:a16="http://schemas.microsoft.com/office/drawing/2014/main" id="{6595C97E-4E9D-4DD7-B69F-2315501AC429}"/>
+                <a16:creationId xmlns:a16="http://schemas.microsoft.com/office/drawing/2014/main" id="{76F2D533-71F9-43E9-939A-AC5CAF3DEA72}"/>
               </a:ext>
             </a:extLst>
           </p:cNvPr>
@@ -19233,7 +19233,7 @@
           <p:cNvPr id="122" name="">
             <a:extLst xmlns:a="http://schemas.openxmlformats.org/drawingml/2006/main">
               <a:ext uri="{FF2B5EF4-FFF2-40B4-BE49-F238E27FC236}">
-                <a16:creationId xmlns:a16="http://schemas.microsoft.com/office/drawing/2014/main" id="{9F445733-D718-48FF-8433-4A3A27143A38}"/>
+                <a16:creationId xmlns:a16="http://schemas.microsoft.com/office/drawing/2014/main" id="{9AA67CB1-14FB-41B7-8709-EDC4EA633064}"/>
               </a:ext>
             </a:extLst>
           </p:cNvPr>
@@ -19299,7 +19299,7 @@
     </p:spTree>
     <p:extLst>
       <p:ext uri="{BB962C8B-B14F-4D97-AF65-F5344CB8AC3E}">
-        <p14:creationId xmlns:p14="http://schemas.microsoft.com/office/powerpoint/2010/main" val="1242503767"/>
+        <p14:creationId xmlns:p14="http://schemas.microsoft.com/office/powerpoint/2010/main" val="492876361"/>
       </p:ext>
     </p:extLst>
   </p:cSld>

</xml_diff>

<commit_message>
docs: confirm Financial Friday registered team on submission deck
</commit_message>
<xml_diff>
--- a/docs/submission/Financial-Friday-AI-Builder-Cup.pptx
+++ b/docs/submission/Financial-Friday-AI-Builder-Cup.pptx
@@ -2,28 +2,28 @@
 <file path=ppt/presentation.xml><?xml version="1.0" encoding="utf-8"?>
 <p:presentation xmlns:p="http://schemas.openxmlformats.org/presentationml/2006/main">
   <p:sldMasterIdLst>
-    <p:sldMasterId xmlns:r="http://schemas.openxmlformats.org/officeDocument/2006/relationships" id="2147483648" r:id="R1ae051abc48a4154"/>
+    <p:sldMasterId xmlns:r="http://schemas.openxmlformats.org/officeDocument/2006/relationships" id="2147483648" r:id="R30ca9532241842fb"/>
   </p:sldMasterIdLst>
   <p:notesMasterIdLst>
-    <p:notesMasterId xmlns:r="http://schemas.openxmlformats.org/officeDocument/2006/relationships" r:id="R4e17db42df1549ad"/>
+    <p:notesMasterId xmlns:r="http://schemas.openxmlformats.org/officeDocument/2006/relationships" r:id="R3978441f237542db"/>
   </p:notesMasterIdLst>
   <p:sldIdLst>
-    <p:sldId xmlns:r="http://schemas.openxmlformats.org/officeDocument/2006/relationships" id="256" r:id="R24756135275f4fd7"/>
-    <p:sldId xmlns:r="http://schemas.openxmlformats.org/officeDocument/2006/relationships" id="257" r:id="Rae00bf37f76e4b6d"/>
-    <p:sldId xmlns:r="http://schemas.openxmlformats.org/officeDocument/2006/relationships" id="258" r:id="R93a1bfc4661b4a0a"/>
-    <p:sldId xmlns:r="http://schemas.openxmlformats.org/officeDocument/2006/relationships" id="259" r:id="R777ca9feb746403d"/>
-    <p:sldId xmlns:r="http://schemas.openxmlformats.org/officeDocument/2006/relationships" id="260" r:id="R91aba699558e4635"/>
-    <p:sldId xmlns:r="http://schemas.openxmlformats.org/officeDocument/2006/relationships" id="261" r:id="Rf1f003cad7184f01"/>
-    <p:sldId xmlns:r="http://schemas.openxmlformats.org/officeDocument/2006/relationships" id="262" r:id="R3b913e38f9f04a73"/>
-    <p:sldId xmlns:r="http://schemas.openxmlformats.org/officeDocument/2006/relationships" id="263" r:id="R79c37e51261c4c00"/>
-    <p:sldId xmlns:r="http://schemas.openxmlformats.org/officeDocument/2006/relationships" id="264" r:id="R78cd15ae8a6c4103"/>
-    <p:sldId xmlns:r="http://schemas.openxmlformats.org/officeDocument/2006/relationships" id="265" r:id="R205f76b92a6743c4"/>
-    <p:sldId xmlns:r="http://schemas.openxmlformats.org/officeDocument/2006/relationships" id="266" r:id="Rcd713fb32e6e48e9"/>
-    <p:sldId xmlns:r="http://schemas.openxmlformats.org/officeDocument/2006/relationships" id="267" r:id="R038c719cb4b0466b"/>
-    <p:sldId xmlns:r="http://schemas.openxmlformats.org/officeDocument/2006/relationships" id="268" r:id="Ra7354d24469d466b"/>
-    <p:sldId xmlns:r="http://schemas.openxmlformats.org/officeDocument/2006/relationships" id="269" r:id="R49d9032bd98a4878"/>
-    <p:sldId xmlns:r="http://schemas.openxmlformats.org/officeDocument/2006/relationships" id="270" r:id="Rf8d3964442bd4edb"/>
-    <p:sldId xmlns:r="http://schemas.openxmlformats.org/officeDocument/2006/relationships" id="271" r:id="R6412f0c4718042a3"/>
+    <p:sldId xmlns:r="http://schemas.openxmlformats.org/officeDocument/2006/relationships" id="256" r:id="Ra1793bfe826f4e48"/>
+    <p:sldId xmlns:r="http://schemas.openxmlformats.org/officeDocument/2006/relationships" id="257" r:id="Ra05ea0cdeea84051"/>
+    <p:sldId xmlns:r="http://schemas.openxmlformats.org/officeDocument/2006/relationships" id="258" r:id="R982ed47a62154ec2"/>
+    <p:sldId xmlns:r="http://schemas.openxmlformats.org/officeDocument/2006/relationships" id="259" r:id="R26ac24588e0543ba"/>
+    <p:sldId xmlns:r="http://schemas.openxmlformats.org/officeDocument/2006/relationships" id="260" r:id="R93e575f4e1414992"/>
+    <p:sldId xmlns:r="http://schemas.openxmlformats.org/officeDocument/2006/relationships" id="261" r:id="R60f1d8a442114d86"/>
+    <p:sldId xmlns:r="http://schemas.openxmlformats.org/officeDocument/2006/relationships" id="262" r:id="R509f01c7b99e45e2"/>
+    <p:sldId xmlns:r="http://schemas.openxmlformats.org/officeDocument/2006/relationships" id="263" r:id="R7ef04f5a123c4145"/>
+    <p:sldId xmlns:r="http://schemas.openxmlformats.org/officeDocument/2006/relationships" id="264" r:id="R9ceee2a61589458a"/>
+    <p:sldId xmlns:r="http://schemas.openxmlformats.org/officeDocument/2006/relationships" id="265" r:id="R2043f53167734ae4"/>
+    <p:sldId xmlns:r="http://schemas.openxmlformats.org/officeDocument/2006/relationships" id="266" r:id="Rf44c2fb8b97f4745"/>
+    <p:sldId xmlns:r="http://schemas.openxmlformats.org/officeDocument/2006/relationships" id="267" r:id="R5910055ebe5742fe"/>
+    <p:sldId xmlns:r="http://schemas.openxmlformats.org/officeDocument/2006/relationships" id="268" r:id="R49fd2a8ba4b84007"/>
+    <p:sldId xmlns:r="http://schemas.openxmlformats.org/officeDocument/2006/relationships" id="269" r:id="Ra2dea0535f124d0d"/>
+    <p:sldId xmlns:r="http://schemas.openxmlformats.org/officeDocument/2006/relationships" id="270" r:id="R277fc6b9e8034158"/>
+    <p:sldId xmlns:r="http://schemas.openxmlformats.org/officeDocument/2006/relationships" id="271" r:id="Rf8d8eac7ec6e4d1a"/>
   </p:sldIdLst>
   <p:sldSz cx="9144000" cy="5143500"/>
   <p:notesSz cx="6858000" cy="9144000"/>
@@ -734,7 +734,7 @@
               <a:buNone/>
             </a:pPr>
             <a:r>
-              <a:t>Registered team name must match the final Hack2skill roster. Project title and team name are separate.</a:t>
+              <a:t>The participant confirmed the registered team name is Financial Friday on 18 October 2026. Team leader: Santosh Ramesh.</a:t>
             </a:r>
             <a:endParaRPr/>
           </a:p>
@@ -2207,7 +2207,7 @@
           <p:cNvPr id="10" name="Google Shape;10;p2">
             <a:extLst xmlns:a="http://schemas.openxmlformats.org/drawingml/2006/main">
               <a:ext uri="{FF2B5EF4-FFF2-40B4-BE49-F238E27FC236}">
-                <a16:creationId xmlns:a16="http://schemas.microsoft.com/office/drawing/2014/main" id="{1758CB06-150F-4056-AD51-6AAA5E85D174}"/>
+                <a16:creationId xmlns:a16="http://schemas.microsoft.com/office/drawing/2014/main" id="{0CA2A9AD-D440-4EA8-BA5F-D9BEC9272818}"/>
               </a:ext>
             </a:extLst>
           </p:cNvPr>
@@ -2340,7 +2340,7 @@
           <p:cNvPr id="11" name="Google Shape;11;p2">
             <a:extLst xmlns:a="http://schemas.openxmlformats.org/drawingml/2006/main">
               <a:ext uri="{FF2B5EF4-FFF2-40B4-BE49-F238E27FC236}">
-                <a16:creationId xmlns:a16="http://schemas.microsoft.com/office/drawing/2014/main" id="{AADE221E-A460-4A3D-BFA3-9B42D5692169}"/>
+                <a16:creationId xmlns:a16="http://schemas.microsoft.com/office/drawing/2014/main" id="{FEC3CB22-DCCD-497B-A1F4-833A40584E6F}"/>
               </a:ext>
             </a:extLst>
           </p:cNvPr>
@@ -2500,7 +2500,7 @@
           <p:cNvPr id="12" name="Google Shape;12;p2">
             <a:extLst xmlns:a="http://schemas.openxmlformats.org/drawingml/2006/main">
               <a:ext uri="{FF2B5EF4-FFF2-40B4-BE49-F238E27FC236}">
-                <a16:creationId xmlns:a16="http://schemas.microsoft.com/office/drawing/2014/main" id="{20645393-05B5-4455-8452-732AE223EB45}"/>
+                <a16:creationId xmlns:a16="http://schemas.microsoft.com/office/drawing/2014/main" id="{BAB7B8CA-3C62-45C2-A4E6-DD7C2ABF5570}"/>
               </a:ext>
             </a:extLst>
           </p:cNvPr>
@@ -2601,7 +2601,7 @@
           <p:cNvPr id="45" name="Google Shape;45;p11">
             <a:extLst xmlns:a="http://schemas.openxmlformats.org/drawingml/2006/main">
               <a:ext uri="{FF2B5EF4-FFF2-40B4-BE49-F238E27FC236}">
-                <a16:creationId xmlns:a16="http://schemas.microsoft.com/office/drawing/2014/main" id="{1D26E2DE-C260-4A9F-BAC0-56EE4DCE39C5}"/>
+                <a16:creationId xmlns:a16="http://schemas.microsoft.com/office/drawing/2014/main" id="{F30ADC6D-200D-46E2-B193-45D6F8B7AB46}"/>
               </a:ext>
             </a:extLst>
           </p:cNvPr>
@@ -2738,7 +2738,7 @@
           <p:cNvPr id="46" name="Google Shape;46;p11">
             <a:extLst xmlns:a="http://schemas.openxmlformats.org/drawingml/2006/main">
               <a:ext uri="{FF2B5EF4-FFF2-40B4-BE49-F238E27FC236}">
-                <a16:creationId xmlns:a16="http://schemas.microsoft.com/office/drawing/2014/main" id="{87447B44-BBBD-4F15-A204-D2F185186309}"/>
+                <a16:creationId xmlns:a16="http://schemas.microsoft.com/office/drawing/2014/main" id="{CD128C3A-0F0F-42E7-8041-FBD59D292BD2}"/>
               </a:ext>
             </a:extLst>
           </p:cNvPr>
@@ -2871,7 +2871,7 @@
           <p:cNvPr id="47" name="Google Shape;47;p11">
             <a:extLst xmlns:a="http://schemas.openxmlformats.org/drawingml/2006/main">
               <a:ext uri="{FF2B5EF4-FFF2-40B4-BE49-F238E27FC236}">
-                <a16:creationId xmlns:a16="http://schemas.microsoft.com/office/drawing/2014/main" id="{17BCBB2E-D24B-42CE-8250-079D33253769}"/>
+                <a16:creationId xmlns:a16="http://schemas.microsoft.com/office/drawing/2014/main" id="{C7DCC097-7708-4064-85A7-4B2D399AFD8C}"/>
               </a:ext>
             </a:extLst>
           </p:cNvPr>
@@ -2972,7 +2972,7 @@
           <p:cNvPr id="49" name="Google Shape;49;p12">
             <a:extLst xmlns:a="http://schemas.openxmlformats.org/drawingml/2006/main">
               <a:ext uri="{FF2B5EF4-FFF2-40B4-BE49-F238E27FC236}">
-                <a16:creationId xmlns:a16="http://schemas.microsoft.com/office/drawing/2014/main" id="{B3771183-6119-4AAB-91FC-B569980FF395}"/>
+                <a16:creationId xmlns:a16="http://schemas.microsoft.com/office/drawing/2014/main" id="{7EB3DC84-0F65-4B63-A04E-C61261D2D03F}"/>
               </a:ext>
             </a:extLst>
           </p:cNvPr>
@@ -3073,7 +3073,7 @@
           <p:cNvPr id="14" name="Google Shape;14;p3">
             <a:extLst xmlns:a="http://schemas.openxmlformats.org/drawingml/2006/main">
               <a:ext uri="{FF2B5EF4-FFF2-40B4-BE49-F238E27FC236}">
-                <a16:creationId xmlns:a16="http://schemas.microsoft.com/office/drawing/2014/main" id="{7B65CD2D-2CFE-4233-ABD2-DFB9C131FBFB}"/>
+                <a16:creationId xmlns:a16="http://schemas.microsoft.com/office/drawing/2014/main" id="{8C2E5EED-82D4-4688-9A35-022884E520FF}"/>
               </a:ext>
             </a:extLst>
           </p:cNvPr>
@@ -3206,7 +3206,7 @@
           <p:cNvPr id="15" name="Google Shape;15;p3">
             <a:extLst xmlns:a="http://schemas.openxmlformats.org/drawingml/2006/main">
               <a:ext uri="{FF2B5EF4-FFF2-40B4-BE49-F238E27FC236}">
-                <a16:creationId xmlns:a16="http://schemas.microsoft.com/office/drawing/2014/main" id="{9AD4E5EF-B54B-442D-8501-903A770DCFDB}"/>
+                <a16:creationId xmlns:a16="http://schemas.microsoft.com/office/drawing/2014/main" id="{4F76A1FF-4E49-4CA6-A48A-60210AB9994E}"/>
               </a:ext>
             </a:extLst>
           </p:cNvPr>
@@ -3307,7 +3307,7 @@
           <p:cNvPr id="17" name="Google Shape;17;p4">
             <a:extLst xmlns:a="http://schemas.openxmlformats.org/drawingml/2006/main">
               <a:ext uri="{FF2B5EF4-FFF2-40B4-BE49-F238E27FC236}">
-                <a16:creationId xmlns:a16="http://schemas.microsoft.com/office/drawing/2014/main" id="{92FDA42B-3A54-4829-AA78-170BE8A60213}"/>
+                <a16:creationId xmlns:a16="http://schemas.microsoft.com/office/drawing/2014/main" id="{999ECE7C-A7C6-4AAE-8E77-061CE0F847C8}"/>
               </a:ext>
             </a:extLst>
           </p:cNvPr>
@@ -3440,7 +3440,7 @@
           <p:cNvPr id="18" name="Google Shape;18;p4">
             <a:extLst xmlns:a="http://schemas.openxmlformats.org/drawingml/2006/main">
               <a:ext uri="{FF2B5EF4-FFF2-40B4-BE49-F238E27FC236}">
-                <a16:creationId xmlns:a16="http://schemas.microsoft.com/office/drawing/2014/main" id="{ABB5A5B9-5B18-4AFF-8DD8-D7E26176F8A0}"/>
+                <a16:creationId xmlns:a16="http://schemas.microsoft.com/office/drawing/2014/main" id="{8F0C578B-A901-4DBC-9FA8-31A1F35F2AC0}"/>
               </a:ext>
             </a:extLst>
           </p:cNvPr>
@@ -3573,7 +3573,7 @@
           <p:cNvPr id="19" name="Google Shape;19;p4">
             <a:extLst xmlns:a="http://schemas.openxmlformats.org/drawingml/2006/main">
               <a:ext uri="{FF2B5EF4-FFF2-40B4-BE49-F238E27FC236}">
-                <a16:creationId xmlns:a16="http://schemas.microsoft.com/office/drawing/2014/main" id="{3CD27DC8-0758-4DB6-98FD-E540CF29AB24}"/>
+                <a16:creationId xmlns:a16="http://schemas.microsoft.com/office/drawing/2014/main" id="{3AFF421E-5BAD-41E2-BACB-30C4D5EE7BFC}"/>
               </a:ext>
             </a:extLst>
           </p:cNvPr>
@@ -3674,7 +3674,7 @@
           <p:cNvPr id="21" name="Google Shape;21;p5">
             <a:extLst xmlns:a="http://schemas.openxmlformats.org/drawingml/2006/main">
               <a:ext uri="{FF2B5EF4-FFF2-40B4-BE49-F238E27FC236}">
-                <a16:creationId xmlns:a16="http://schemas.microsoft.com/office/drawing/2014/main" id="{BDED9EC1-A381-47A0-AA21-4150D1204940}"/>
+                <a16:creationId xmlns:a16="http://schemas.microsoft.com/office/drawing/2014/main" id="{F98B9857-D9D8-44E1-9102-CF4DD10F2981}"/>
               </a:ext>
             </a:extLst>
           </p:cNvPr>
@@ -3807,7 +3807,7 @@
           <p:cNvPr id="22" name="Google Shape;22;p5">
             <a:extLst xmlns:a="http://schemas.openxmlformats.org/drawingml/2006/main">
               <a:ext uri="{FF2B5EF4-FFF2-40B4-BE49-F238E27FC236}">
-                <a16:creationId xmlns:a16="http://schemas.microsoft.com/office/drawing/2014/main" id="{3556C3D6-DE3A-4844-AACC-3EEFBECF8173}"/>
+                <a16:creationId xmlns:a16="http://schemas.microsoft.com/office/drawing/2014/main" id="{B62DBB57-0CF8-4466-827D-42F5B58A929B}"/>
               </a:ext>
             </a:extLst>
           </p:cNvPr>
@@ -3940,7 +3940,7 @@
           <p:cNvPr id="23" name="Google Shape;23;p5">
             <a:extLst xmlns:a="http://schemas.openxmlformats.org/drawingml/2006/main">
               <a:ext uri="{FF2B5EF4-FFF2-40B4-BE49-F238E27FC236}">
-                <a16:creationId xmlns:a16="http://schemas.microsoft.com/office/drawing/2014/main" id="{D937BE37-28A2-46AD-B9E2-4919AC8199D5}"/>
+                <a16:creationId xmlns:a16="http://schemas.microsoft.com/office/drawing/2014/main" id="{BA2EAA76-6F7A-4805-AC7C-672EA9F4EF4E}"/>
               </a:ext>
             </a:extLst>
           </p:cNvPr>
@@ -4073,7 +4073,7 @@
           <p:cNvPr id="24" name="Google Shape;24;p5">
             <a:extLst xmlns:a="http://schemas.openxmlformats.org/drawingml/2006/main">
               <a:ext uri="{FF2B5EF4-FFF2-40B4-BE49-F238E27FC236}">
-                <a16:creationId xmlns:a16="http://schemas.microsoft.com/office/drawing/2014/main" id="{39A4E475-4FC0-4A74-812F-BCA6A0D470F5}"/>
+                <a16:creationId xmlns:a16="http://schemas.microsoft.com/office/drawing/2014/main" id="{673C49C6-D5B5-401F-8C18-3473CD8F66DC}"/>
               </a:ext>
             </a:extLst>
           </p:cNvPr>
@@ -4174,7 +4174,7 @@
           <p:cNvPr id="26" name="Google Shape;26;p6">
             <a:extLst xmlns:a="http://schemas.openxmlformats.org/drawingml/2006/main">
               <a:ext uri="{FF2B5EF4-FFF2-40B4-BE49-F238E27FC236}">
-                <a16:creationId xmlns:a16="http://schemas.microsoft.com/office/drawing/2014/main" id="{1F882063-9C96-4B2E-907A-48E926BE2FC0}"/>
+                <a16:creationId xmlns:a16="http://schemas.microsoft.com/office/drawing/2014/main" id="{64D8CD1A-6BCC-4013-A2CA-0BF92519C6DC}"/>
               </a:ext>
             </a:extLst>
           </p:cNvPr>
@@ -4307,7 +4307,7 @@
           <p:cNvPr id="27" name="Google Shape;27;p6">
             <a:extLst xmlns:a="http://schemas.openxmlformats.org/drawingml/2006/main">
               <a:ext uri="{FF2B5EF4-FFF2-40B4-BE49-F238E27FC236}">
-                <a16:creationId xmlns:a16="http://schemas.microsoft.com/office/drawing/2014/main" id="{DFC0E5E0-7B42-4B2F-8AB6-A22250EFFA94}"/>
+                <a16:creationId xmlns:a16="http://schemas.microsoft.com/office/drawing/2014/main" id="{61FACBB2-C05F-4C07-BCC4-F9AFB6992A69}"/>
               </a:ext>
             </a:extLst>
           </p:cNvPr>
@@ -4408,7 +4408,7 @@
           <p:cNvPr id="29" name="Google Shape;29;p7">
             <a:extLst xmlns:a="http://schemas.openxmlformats.org/drawingml/2006/main">
               <a:ext uri="{FF2B5EF4-FFF2-40B4-BE49-F238E27FC236}">
-                <a16:creationId xmlns:a16="http://schemas.microsoft.com/office/drawing/2014/main" id="{15123CA7-5256-46EB-A850-437645CFBA01}"/>
+                <a16:creationId xmlns:a16="http://schemas.microsoft.com/office/drawing/2014/main" id="{E4877BBE-E4DF-404F-A66D-89114261F9F9}"/>
               </a:ext>
             </a:extLst>
           </p:cNvPr>
@@ -4541,7 +4541,7 @@
           <p:cNvPr id="30" name="Google Shape;30;p7">
             <a:extLst xmlns:a="http://schemas.openxmlformats.org/drawingml/2006/main">
               <a:ext uri="{FF2B5EF4-FFF2-40B4-BE49-F238E27FC236}">
-                <a16:creationId xmlns:a16="http://schemas.microsoft.com/office/drawing/2014/main" id="{04569416-24E1-4600-83B0-9A4ABE94E4BD}"/>
+                <a16:creationId xmlns:a16="http://schemas.microsoft.com/office/drawing/2014/main" id="{51AB68AB-35DB-449D-990C-15895B807624}"/>
               </a:ext>
             </a:extLst>
           </p:cNvPr>
@@ -4674,7 +4674,7 @@
           <p:cNvPr id="31" name="Google Shape;31;p7">
             <a:extLst xmlns:a="http://schemas.openxmlformats.org/drawingml/2006/main">
               <a:ext uri="{FF2B5EF4-FFF2-40B4-BE49-F238E27FC236}">
-                <a16:creationId xmlns:a16="http://schemas.microsoft.com/office/drawing/2014/main" id="{037248C8-CCA5-4CEA-B4D3-18DB751ACD1A}"/>
+                <a16:creationId xmlns:a16="http://schemas.microsoft.com/office/drawing/2014/main" id="{1B6E6D97-8F2B-466D-AD88-FEE0264894B5}"/>
               </a:ext>
             </a:extLst>
           </p:cNvPr>
@@ -4775,7 +4775,7 @@
           <p:cNvPr id="33" name="Google Shape;33;p8">
             <a:extLst xmlns:a="http://schemas.openxmlformats.org/drawingml/2006/main">
               <a:ext uri="{FF2B5EF4-FFF2-40B4-BE49-F238E27FC236}">
-                <a16:creationId xmlns:a16="http://schemas.microsoft.com/office/drawing/2014/main" id="{E2633E06-753B-4DA3-8D62-07CE0253787E}"/>
+                <a16:creationId xmlns:a16="http://schemas.microsoft.com/office/drawing/2014/main" id="{EEBE3E48-D5E7-4B7C-A5E1-93C0C007368B}"/>
               </a:ext>
             </a:extLst>
           </p:cNvPr>
@@ -4908,7 +4908,7 @@
           <p:cNvPr id="34" name="Google Shape;34;p8">
             <a:extLst xmlns:a="http://schemas.openxmlformats.org/drawingml/2006/main">
               <a:ext uri="{FF2B5EF4-FFF2-40B4-BE49-F238E27FC236}">
-                <a16:creationId xmlns:a16="http://schemas.microsoft.com/office/drawing/2014/main" id="{F1BD41E9-5067-45A8-9D87-C11C0E6D78B7}"/>
+                <a16:creationId xmlns:a16="http://schemas.microsoft.com/office/drawing/2014/main" id="{E1D632D8-D281-411F-9136-42C9995C61B0}"/>
               </a:ext>
             </a:extLst>
           </p:cNvPr>
@@ -5009,7 +5009,7 @@
           <p:cNvPr id="36" name="Google Shape;36;p9">
             <a:extLst xmlns:a="http://schemas.openxmlformats.org/drawingml/2006/main">
               <a:ext uri="{FF2B5EF4-FFF2-40B4-BE49-F238E27FC236}">
-                <a16:creationId xmlns:a16="http://schemas.microsoft.com/office/drawing/2014/main" id="{AB7A6285-A83B-4419-8435-E8627C6F8C4F}"/>
+                <a16:creationId xmlns:a16="http://schemas.microsoft.com/office/drawing/2014/main" id="{5FC6491B-BB84-4B89-9B4C-F8805D635A63}"/>
               </a:ext>
             </a:extLst>
           </p:cNvPr>
@@ -5060,7 +5060,7 @@
           <p:cNvPr id="37" name="Google Shape;37;p9">
             <a:extLst xmlns:a="http://schemas.openxmlformats.org/drawingml/2006/main">
               <a:ext uri="{FF2B5EF4-FFF2-40B4-BE49-F238E27FC236}">
-                <a16:creationId xmlns:a16="http://schemas.microsoft.com/office/drawing/2014/main" id="{B347CCF6-ED9C-4DC6-9AE3-B3A23A2C3317}"/>
+                <a16:creationId xmlns:a16="http://schemas.microsoft.com/office/drawing/2014/main" id="{6B61E147-1041-4374-97D7-58CCA6FF98C3}"/>
               </a:ext>
             </a:extLst>
           </p:cNvPr>
@@ -5193,7 +5193,7 @@
           <p:cNvPr id="38" name="Google Shape;38;p9">
             <a:extLst xmlns:a="http://schemas.openxmlformats.org/drawingml/2006/main">
               <a:ext uri="{FF2B5EF4-FFF2-40B4-BE49-F238E27FC236}">
-                <a16:creationId xmlns:a16="http://schemas.microsoft.com/office/drawing/2014/main" id="{C6555059-27E2-48F2-BCF9-1179A34F04FC}"/>
+                <a16:creationId xmlns:a16="http://schemas.microsoft.com/office/drawing/2014/main" id="{CB829883-3C65-4C8C-98FA-C94B25DEF11A}"/>
               </a:ext>
             </a:extLst>
           </p:cNvPr>
@@ -5353,7 +5353,7 @@
           <p:cNvPr id="39" name="Google Shape;39;p9">
             <a:extLst xmlns:a="http://schemas.openxmlformats.org/drawingml/2006/main">
               <a:ext uri="{FF2B5EF4-FFF2-40B4-BE49-F238E27FC236}">
-                <a16:creationId xmlns:a16="http://schemas.microsoft.com/office/drawing/2014/main" id="{299CC320-FD3E-4A25-8120-DAA1C8F8E3D4}"/>
+                <a16:creationId xmlns:a16="http://schemas.microsoft.com/office/drawing/2014/main" id="{8DDEA0B1-D4FA-49F1-BE04-F9E9CB60057B}"/>
               </a:ext>
             </a:extLst>
           </p:cNvPr>
@@ -5486,7 +5486,7 @@
           <p:cNvPr id="40" name="Google Shape;40;p9">
             <a:extLst xmlns:a="http://schemas.openxmlformats.org/drawingml/2006/main">
               <a:ext uri="{FF2B5EF4-FFF2-40B4-BE49-F238E27FC236}">
-                <a16:creationId xmlns:a16="http://schemas.microsoft.com/office/drawing/2014/main" id="{0EFB2C06-207A-465F-958D-F11957DC3C74}"/>
+                <a16:creationId xmlns:a16="http://schemas.microsoft.com/office/drawing/2014/main" id="{F58EDCFB-97D5-4508-8CD7-45AC3565BC50}"/>
               </a:ext>
             </a:extLst>
           </p:cNvPr>
@@ -5587,7 +5587,7 @@
           <p:cNvPr id="42" name="Google Shape;42;p10">
             <a:extLst xmlns:a="http://schemas.openxmlformats.org/drawingml/2006/main">
               <a:ext uri="{FF2B5EF4-FFF2-40B4-BE49-F238E27FC236}">
-                <a16:creationId xmlns:a16="http://schemas.microsoft.com/office/drawing/2014/main" id="{10494E5A-5F02-4CFC-859A-A6B99C8817D5}"/>
+                <a16:creationId xmlns:a16="http://schemas.microsoft.com/office/drawing/2014/main" id="{AA53D02E-2702-4D30-826F-5D3774E1CA48}"/>
               </a:ext>
             </a:extLst>
           </p:cNvPr>
@@ -5635,7 +5635,7 @@
           <p:cNvPr id="43" name="Google Shape;43;p10">
             <a:extLst xmlns:a="http://schemas.openxmlformats.org/drawingml/2006/main">
               <a:ext uri="{FF2B5EF4-FFF2-40B4-BE49-F238E27FC236}">
-                <a16:creationId xmlns:a16="http://schemas.microsoft.com/office/drawing/2014/main" id="{FECDD505-7A8D-4B73-815E-84280C762962}"/>
+                <a16:creationId xmlns:a16="http://schemas.microsoft.com/office/drawing/2014/main" id="{C102DDC7-D794-4C78-AA9B-FC578A1FA4C6}"/>
               </a:ext>
             </a:extLst>
           </p:cNvPr>
@@ -5743,7 +5743,7 @@
           <p:cNvPr id="6" name="Google Shape;6;p1">
             <a:extLst xmlns:a="http://schemas.openxmlformats.org/drawingml/2006/main">
               <a:ext uri="{FF2B5EF4-FFF2-40B4-BE49-F238E27FC236}">
-                <a16:creationId xmlns:a16="http://schemas.microsoft.com/office/drawing/2014/main" id="{732F8306-F31E-4657-905D-20F3518A8805}"/>
+                <a16:creationId xmlns:a16="http://schemas.microsoft.com/office/drawing/2014/main" id="{DF75EA1A-224D-45F7-9BA8-921E106100B4}"/>
               </a:ext>
             </a:extLst>
           </p:cNvPr>
@@ -5943,7 +5943,7 @@
           <p:cNvPr id="7" name="Google Shape;7;p1">
             <a:extLst xmlns:a="http://schemas.openxmlformats.org/drawingml/2006/main">
               <a:ext uri="{FF2B5EF4-FFF2-40B4-BE49-F238E27FC236}">
-                <a16:creationId xmlns:a16="http://schemas.microsoft.com/office/drawing/2014/main" id="{FF1849E6-67EF-4FE3-B011-36C6CCFFBEA8}"/>
+                <a16:creationId xmlns:a16="http://schemas.microsoft.com/office/drawing/2014/main" id="{8A3A21A6-B12E-4E4C-B639-6996099C7D02}"/>
               </a:ext>
             </a:extLst>
           </p:cNvPr>
@@ -6170,7 +6170,7 @@
           <p:cNvPr id="8" name="Google Shape;8;p1">
             <a:extLst xmlns:a="http://schemas.openxmlformats.org/drawingml/2006/main">
               <a:ext uri="{FF2B5EF4-FFF2-40B4-BE49-F238E27FC236}">
-                <a16:creationId xmlns:a16="http://schemas.microsoft.com/office/drawing/2014/main" id="{1FE367D2-E7C6-4040-94F0-62A9E6E6BDB9}"/>
+                <a16:creationId xmlns:a16="http://schemas.microsoft.com/office/drawing/2014/main" id="{D92EE535-8E20-4D90-A404-D3F46F7C177E}"/>
               </a:ext>
             </a:extLst>
           </p:cNvPr>
@@ -6293,17 +6293,17 @@
   </p:cSld>
   <p:clrMap bg1="lt1" tx1="dk1" bg2="dk2" tx2="lt2" accent1="accent1" accent2="accent2" accent3="accent3" accent4="accent4" accent5="accent5" accent6="accent6" hlink="hlink" folHlink="folHlink"/>
   <p:sldLayoutIdLst>
-    <p:sldLayoutId xmlns:r="http://schemas.openxmlformats.org/officeDocument/2006/relationships" id="2147483649" r:id="R5680108837bb400e"/>
-    <p:sldLayoutId xmlns:r="http://schemas.openxmlformats.org/officeDocument/2006/relationships" id="2147483650" r:id="R06132917945a43aa"/>
-    <p:sldLayoutId xmlns:r="http://schemas.openxmlformats.org/officeDocument/2006/relationships" id="2147483651" r:id="R0146455d819f4cdb"/>
-    <p:sldLayoutId xmlns:r="http://schemas.openxmlformats.org/officeDocument/2006/relationships" id="2147483652" r:id="R5800a0357c474e9e"/>
-    <p:sldLayoutId xmlns:r="http://schemas.openxmlformats.org/officeDocument/2006/relationships" id="2147483653" r:id="R183b5e80cb6149d0"/>
-    <p:sldLayoutId xmlns:r="http://schemas.openxmlformats.org/officeDocument/2006/relationships" id="2147483654" r:id="R0968c25d588c4dd6"/>
-    <p:sldLayoutId xmlns:r="http://schemas.openxmlformats.org/officeDocument/2006/relationships" id="2147483655" r:id="Re443237a18284355"/>
-    <p:sldLayoutId xmlns:r="http://schemas.openxmlformats.org/officeDocument/2006/relationships" id="2147483656" r:id="R764be296915a4024"/>
-    <p:sldLayoutId xmlns:r="http://schemas.openxmlformats.org/officeDocument/2006/relationships" id="2147483657" r:id="Rdf4966de340b41d4"/>
-    <p:sldLayoutId xmlns:r="http://schemas.openxmlformats.org/officeDocument/2006/relationships" id="2147483658" r:id="Ra165bb629aad46a1"/>
-    <p:sldLayoutId xmlns:r="http://schemas.openxmlformats.org/officeDocument/2006/relationships" id="2147483659" r:id="R51795fccd3234c88"/>
+    <p:sldLayoutId xmlns:r="http://schemas.openxmlformats.org/officeDocument/2006/relationships" id="2147483649" r:id="R459b7f50c7c94561"/>
+    <p:sldLayoutId xmlns:r="http://schemas.openxmlformats.org/officeDocument/2006/relationships" id="2147483650" r:id="R8f979d1ffee44d1c"/>
+    <p:sldLayoutId xmlns:r="http://schemas.openxmlformats.org/officeDocument/2006/relationships" id="2147483651" r:id="R6977e779a9704d80"/>
+    <p:sldLayoutId xmlns:r="http://schemas.openxmlformats.org/officeDocument/2006/relationships" id="2147483652" r:id="R2be4adaab2e94f3d"/>
+    <p:sldLayoutId xmlns:r="http://schemas.openxmlformats.org/officeDocument/2006/relationships" id="2147483653" r:id="R3872dfb428454cbf"/>
+    <p:sldLayoutId xmlns:r="http://schemas.openxmlformats.org/officeDocument/2006/relationships" id="2147483654" r:id="R9559fb38b5954a58"/>
+    <p:sldLayoutId xmlns:r="http://schemas.openxmlformats.org/officeDocument/2006/relationships" id="2147483655" r:id="R15dbe34aa4fb4372"/>
+    <p:sldLayoutId xmlns:r="http://schemas.openxmlformats.org/officeDocument/2006/relationships" id="2147483656" r:id="R43432462b2c84c8a"/>
+    <p:sldLayoutId xmlns:r="http://schemas.openxmlformats.org/officeDocument/2006/relationships" id="2147483657" r:id="Rfb6cad50f6e740ba"/>
+    <p:sldLayoutId xmlns:r="http://schemas.openxmlformats.org/officeDocument/2006/relationships" id="2147483658" r:id="Rd9a0b42b9a104f3f"/>
+    <p:sldLayoutId xmlns:r="http://schemas.openxmlformats.org/officeDocument/2006/relationships" id="2147483659" r:id="Rc8efc8d0f1c04afd"/>
   </p:sldLayoutIdLst>
   <p:hf sldNum="0" hdr="0" ftr="0" dt="0"/>
   <p:txStyles>
@@ -7250,7 +7250,7 @@
           <p:cNvPr id="54" name="Google Shape;54;p13">
             <a:extLst xmlns:a="http://schemas.openxmlformats.org/drawingml/2006/main">
               <a:ext uri="{FF2B5EF4-FFF2-40B4-BE49-F238E27FC236}">
-                <a16:creationId xmlns:a16="http://schemas.microsoft.com/office/drawing/2014/main" id="{B4B81E3E-C538-4580-8A05-111E6473B697}"/>
+                <a16:creationId xmlns:a16="http://schemas.microsoft.com/office/drawing/2014/main" id="{2151B4DE-F6BA-4F9F-8367-A83BE11F43F2}"/>
               </a:ext>
             </a:extLst>
           </p:cNvPr>
@@ -7337,7 +7337,7 @@
                 <a:ea typeface="Google Sans Flex Medium"/>
                 <a:cs typeface="Google Sans Flex Medium"/>
               </a:rPr>
-              <a:t>Team name: Vaultkeepers</a:t>
+              <a:t>Team name: Financial Friday</a:t>
             </a:r>
           </a:p>
           <a:p xmlns:a="http://schemas.openxmlformats.org/drawingml/2006/main">
@@ -7422,7 +7422,7 @@
           <p:cNvPr id="55" name="Google Shape;55;p13">
             <a:extLst xmlns:a="http://schemas.openxmlformats.org/drawingml/2006/main">
               <a:ext uri="{FF2B5EF4-FFF2-40B4-BE49-F238E27FC236}">
-                <a16:creationId xmlns:a16="http://schemas.microsoft.com/office/drawing/2014/main" id="{7F2AD657-8E9E-4B74-9D74-9FEBA8A29B1A}"/>
+                <a16:creationId xmlns:a16="http://schemas.microsoft.com/office/drawing/2014/main" id="{20A5751A-B9DB-4476-B13B-9C314D2E502B}"/>
               </a:ext>
             </a:extLst>
           </p:cNvPr>
@@ -7432,7 +7432,7 @@
           <p:nvPr/>
         </p:nvPicPr>
         <p:blipFill>
-          <a:blip xmlns:r="http://schemas.openxmlformats.org/officeDocument/2006/relationships" xmlns:a="http://schemas.openxmlformats.org/drawingml/2006/main" r:embed="R8acad5baa6c24dc3">
+          <a:blip xmlns:r="http://schemas.openxmlformats.org/officeDocument/2006/relationships" xmlns:a="http://schemas.openxmlformats.org/drawingml/2006/main" r:embed="R7f2624cebe07427b">
             <a:alphaModFix/>
           </a:blip>
           <a:stretch xmlns:a="http://schemas.openxmlformats.org/drawingml/2006/main">
@@ -7457,7 +7457,7 @@
           <p:cNvPr id="56" name="Google Shape;56;p13">
             <a:extLst xmlns:a="http://schemas.openxmlformats.org/drawingml/2006/main">
               <a:ext uri="{FF2B5EF4-FFF2-40B4-BE49-F238E27FC236}">
-                <a16:creationId xmlns:a16="http://schemas.microsoft.com/office/drawing/2014/main" id="{E31463E0-43C2-4AB2-96F2-B491C58A61B9}"/>
+                <a16:creationId xmlns:a16="http://schemas.microsoft.com/office/drawing/2014/main" id="{DE98F546-CABC-4AF1-9263-DA2190265E7A}"/>
               </a:ext>
             </a:extLst>
           </p:cNvPr>
@@ -7467,7 +7467,7 @@
           <p:nvPr/>
         </p:nvPicPr>
         <p:blipFill rotWithShape="1">
-          <a:blip xmlns:r="http://schemas.openxmlformats.org/officeDocument/2006/relationships" xmlns:a="http://schemas.openxmlformats.org/drawingml/2006/main" r:embed="R2b3961188cb64d1d">
+          <a:blip xmlns:r="http://schemas.openxmlformats.org/officeDocument/2006/relationships" xmlns:a="http://schemas.openxmlformats.org/drawingml/2006/main" r:embed="R71abdf664c6d465f">
             <a:alphaModFix/>
           </a:blip>
           <a:srcRect xmlns:a="http://schemas.openxmlformats.org/drawingml/2006/main" l="0" t="0" r="0" b="98001"/>
@@ -7489,7 +7489,7 @@
     </p:spTree>
     <p:extLst>
       <p:ext uri="{BB962C8B-B14F-4D97-AF65-F5344CB8AC3E}">
-        <p14:creationId xmlns:p14="http://schemas.microsoft.com/office/powerpoint/2010/main" val="340458854"/>
+        <p14:creationId xmlns:p14="http://schemas.microsoft.com/office/powerpoint/2010/main" val="1412226029"/>
       </p:ext>
     </p:extLst>
   </p:cSld>
@@ -7513,7 +7513,7 @@
           <p:cNvPr id="124" name="Google Shape;124;p22">
             <a:extLst xmlns:a="http://schemas.openxmlformats.org/drawingml/2006/main">
               <a:ext uri="{FF2B5EF4-FFF2-40B4-BE49-F238E27FC236}">
-                <a16:creationId xmlns:a16="http://schemas.microsoft.com/office/drawing/2014/main" id="{61C952EB-7DEC-43A9-A069-703C8748C9B8}"/>
+                <a16:creationId xmlns:a16="http://schemas.microsoft.com/office/drawing/2014/main" id="{D6FD5009-6F0C-43CB-AAE8-FB54374E4A9D}"/>
               </a:ext>
             </a:extLst>
           </p:cNvPr>
@@ -7523,7 +7523,7 @@
           <p:nvPr/>
         </p:nvPicPr>
         <p:blipFill rotWithShape="1">
-          <a:blip xmlns:r="http://schemas.openxmlformats.org/officeDocument/2006/relationships" xmlns:a="http://schemas.openxmlformats.org/drawingml/2006/main" r:embed="R7b44e44cd16e417e">
+          <a:blip xmlns:r="http://schemas.openxmlformats.org/officeDocument/2006/relationships" xmlns:a="http://schemas.openxmlformats.org/drawingml/2006/main" r:embed="Ra0fcc29461504962">
             <a:alphaModFix/>
           </a:blip>
           <a:srcRect xmlns:a="http://schemas.openxmlformats.org/drawingml/2006/main" l="0" t="0" r="0" b="98001"/>
@@ -7547,7 +7547,7 @@
           <p:cNvPr id="125" name="Google Shape;125;p22">
             <a:extLst xmlns:a="http://schemas.openxmlformats.org/drawingml/2006/main">
               <a:ext uri="{FF2B5EF4-FFF2-40B4-BE49-F238E27FC236}">
-                <a16:creationId xmlns:a16="http://schemas.microsoft.com/office/drawing/2014/main" id="{2E8F0EF7-E3B8-49C8-93CA-D8B9E022C958}"/>
+                <a16:creationId xmlns:a16="http://schemas.microsoft.com/office/drawing/2014/main" id="{AB9807BB-E0A3-49F9-83CF-D8BA4F81A8AE}"/>
               </a:ext>
             </a:extLst>
           </p:cNvPr>
@@ -7557,7 +7557,7 @@
           <p:nvPr/>
         </p:nvPicPr>
         <p:blipFill>
-          <a:blip xmlns:r="http://schemas.openxmlformats.org/officeDocument/2006/relationships" xmlns:a="http://schemas.openxmlformats.org/drawingml/2006/main" r:embed="R727707cacceb482d">
+          <a:blip xmlns:r="http://schemas.openxmlformats.org/officeDocument/2006/relationships" xmlns:a="http://schemas.openxmlformats.org/drawingml/2006/main" r:embed="R52bc8e77a8534c1d">
             <a:alphaModFix/>
           </a:blip>
           <a:stretch xmlns:a="http://schemas.openxmlformats.org/drawingml/2006/main">
@@ -7582,7 +7582,7 @@
           <p:cNvPr id="126" name="Google Shape;126;p22">
             <a:extLst xmlns:a="http://schemas.openxmlformats.org/drawingml/2006/main">
               <a:ext uri="{FF2B5EF4-FFF2-40B4-BE49-F238E27FC236}">
-                <a16:creationId xmlns:a16="http://schemas.microsoft.com/office/drawing/2014/main" id="{C3100673-016B-4220-ADC4-817CD5F8F8B9}"/>
+                <a16:creationId xmlns:a16="http://schemas.microsoft.com/office/drawing/2014/main" id="{6B1191D0-35C5-48D6-879A-9126905A1B56}"/>
               </a:ext>
             </a:extLst>
           </p:cNvPr>
@@ -7633,7 +7633,7 @@
           <p:cNvPr id="127" name="Google Shape;127;p22">
             <a:extLst xmlns:a="http://schemas.openxmlformats.org/drawingml/2006/main">
               <a:ext uri="{FF2B5EF4-FFF2-40B4-BE49-F238E27FC236}">
-                <a16:creationId xmlns:a16="http://schemas.microsoft.com/office/drawing/2014/main" id="{29575BFC-FA60-4280-BF88-839E267F8042}"/>
+                <a16:creationId xmlns:a16="http://schemas.microsoft.com/office/drawing/2014/main" id="{163CC10D-D01E-4B53-A646-0F2E54F2E1AB}"/>
               </a:ext>
             </a:extLst>
           </p:cNvPr>
@@ -7713,7 +7713,7 @@
           <p:cNvPr id="128" name="">
             <a:extLst xmlns:a="http://schemas.openxmlformats.org/drawingml/2006/main">
               <a:ext uri="{FF2B5EF4-FFF2-40B4-BE49-F238E27FC236}">
-                <a16:creationId xmlns:a16="http://schemas.microsoft.com/office/drawing/2014/main" id="{33D8BF22-964C-4711-8815-FF5DAF9452EB}"/>
+                <a16:creationId xmlns:a16="http://schemas.microsoft.com/office/drawing/2014/main" id="{A9689603-EBB2-433C-B9D7-3700BEF7F302}"/>
               </a:ext>
             </a:extLst>
           </p:cNvPr>
@@ -7781,7 +7781,7 @@
           <p:cNvPr id="129" name="">
             <a:extLst xmlns:a="http://schemas.openxmlformats.org/drawingml/2006/main">
               <a:ext uri="{FF2B5EF4-FFF2-40B4-BE49-F238E27FC236}">
-                <a16:creationId xmlns:a16="http://schemas.microsoft.com/office/drawing/2014/main" id="{ED42E26D-8084-4E5A-9358-8534D84ABC03}"/>
+                <a16:creationId xmlns:a16="http://schemas.microsoft.com/office/drawing/2014/main" id="{4E0ED5FB-C4EC-49F4-98F9-D06EC1957799}"/>
               </a:ext>
             </a:extLst>
           </p:cNvPr>
@@ -8241,7 +8241,7 @@
           <p:cNvPr id="130" name="">
             <a:extLst xmlns:a="http://schemas.openxmlformats.org/drawingml/2006/main">
               <a:ext uri="{FF2B5EF4-FFF2-40B4-BE49-F238E27FC236}">
-                <a16:creationId xmlns:a16="http://schemas.microsoft.com/office/drawing/2014/main" id="{E76C481A-E726-41F9-AF57-36E719B3A738}"/>
+                <a16:creationId xmlns:a16="http://schemas.microsoft.com/office/drawing/2014/main" id="{18C6C3CB-6BDC-45DC-BF65-EFBF34A5D850}"/>
               </a:ext>
             </a:extLst>
           </p:cNvPr>
@@ -8309,7 +8309,7 @@
           <p:cNvPr id="131" name="">
             <a:extLst xmlns:a="http://schemas.openxmlformats.org/drawingml/2006/main">
               <a:ext uri="{FF2B5EF4-FFF2-40B4-BE49-F238E27FC236}">
-                <a16:creationId xmlns:a16="http://schemas.microsoft.com/office/drawing/2014/main" id="{E9FB4108-82C3-4B60-A309-A9F1EB3AB393}"/>
+                <a16:creationId xmlns:a16="http://schemas.microsoft.com/office/drawing/2014/main" id="{E1411EA3-0901-41B8-A772-F5F08E3E6792}"/>
               </a:ext>
             </a:extLst>
           </p:cNvPr>
@@ -8377,7 +8377,7 @@
           <p:cNvPr id="132" name="">
             <a:extLst xmlns:a="http://schemas.openxmlformats.org/drawingml/2006/main">
               <a:ext uri="{FF2B5EF4-FFF2-40B4-BE49-F238E27FC236}">
-                <a16:creationId xmlns:a16="http://schemas.microsoft.com/office/drawing/2014/main" id="{51294504-8C20-4F12-A411-81B9749C94C8}"/>
+                <a16:creationId xmlns:a16="http://schemas.microsoft.com/office/drawing/2014/main" id="{FA10EBB5-C8BF-4ED2-A22B-3EB78DEAF13E}"/>
               </a:ext>
             </a:extLst>
           </p:cNvPr>
@@ -8443,7 +8443,7 @@
     </p:spTree>
     <p:extLst>
       <p:ext uri="{BB962C8B-B14F-4D97-AF65-F5344CB8AC3E}">
-        <p14:creationId xmlns:p14="http://schemas.microsoft.com/office/powerpoint/2010/main" val="1670269351"/>
+        <p14:creationId xmlns:p14="http://schemas.microsoft.com/office/powerpoint/2010/main" val="1641385748"/>
       </p:ext>
     </p:extLst>
   </p:cSld>
@@ -8467,7 +8467,7 @@
           <p:cNvPr id="132" name="Google Shape;132;p23">
             <a:extLst xmlns:a="http://schemas.openxmlformats.org/drawingml/2006/main">
               <a:ext uri="{FF2B5EF4-FFF2-40B4-BE49-F238E27FC236}">
-                <a16:creationId xmlns:a16="http://schemas.microsoft.com/office/drawing/2014/main" id="{BFCD118E-FC71-4F5F-A876-E723B9954B9B}"/>
+                <a16:creationId xmlns:a16="http://schemas.microsoft.com/office/drawing/2014/main" id="{45F0E9E2-0DF2-4FCD-A1BC-6687CA894647}"/>
               </a:ext>
             </a:extLst>
           </p:cNvPr>
@@ -8477,7 +8477,7 @@
           <p:nvPr/>
         </p:nvPicPr>
         <p:blipFill rotWithShape="1">
-          <a:blip xmlns:r="http://schemas.openxmlformats.org/officeDocument/2006/relationships" xmlns:a="http://schemas.openxmlformats.org/drawingml/2006/main" r:embed="Rb084f2bb1d6841f2">
+          <a:blip xmlns:r="http://schemas.openxmlformats.org/officeDocument/2006/relationships" xmlns:a="http://schemas.openxmlformats.org/drawingml/2006/main" r:embed="R8cac053ac4d54e1d">
             <a:alphaModFix/>
           </a:blip>
           <a:srcRect xmlns:a="http://schemas.openxmlformats.org/drawingml/2006/main" l="0" t="0" r="0" b="98001"/>
@@ -8501,7 +8501,7 @@
           <p:cNvPr id="133" name="Google Shape;133;p23">
             <a:extLst xmlns:a="http://schemas.openxmlformats.org/drawingml/2006/main">
               <a:ext uri="{FF2B5EF4-FFF2-40B4-BE49-F238E27FC236}">
-                <a16:creationId xmlns:a16="http://schemas.microsoft.com/office/drawing/2014/main" id="{31396A44-0E78-4DA6-A316-45B004A0D07D}"/>
+                <a16:creationId xmlns:a16="http://schemas.microsoft.com/office/drawing/2014/main" id="{C19458C5-175B-403F-8714-826AE4022C8E}"/>
               </a:ext>
             </a:extLst>
           </p:cNvPr>
@@ -8511,7 +8511,7 @@
           <p:nvPr/>
         </p:nvPicPr>
         <p:blipFill>
-          <a:blip xmlns:r="http://schemas.openxmlformats.org/officeDocument/2006/relationships" xmlns:a="http://schemas.openxmlformats.org/drawingml/2006/main" r:embed="R143d0a1e6e2a4b25">
+          <a:blip xmlns:r="http://schemas.openxmlformats.org/officeDocument/2006/relationships" xmlns:a="http://schemas.openxmlformats.org/drawingml/2006/main" r:embed="Rd447b685717243b0">
             <a:alphaModFix/>
           </a:blip>
           <a:stretch xmlns:a="http://schemas.openxmlformats.org/drawingml/2006/main">
@@ -8536,7 +8536,7 @@
           <p:cNvPr id="134" name="Google Shape;134;p23">
             <a:extLst xmlns:a="http://schemas.openxmlformats.org/drawingml/2006/main">
               <a:ext uri="{FF2B5EF4-FFF2-40B4-BE49-F238E27FC236}">
-                <a16:creationId xmlns:a16="http://schemas.microsoft.com/office/drawing/2014/main" id="{EFD92CEF-9F3E-4669-9C52-6F893E9E808F}"/>
+                <a16:creationId xmlns:a16="http://schemas.microsoft.com/office/drawing/2014/main" id="{E1D82BBD-D9B8-4EFA-8A4B-43677D2A073C}"/>
               </a:ext>
             </a:extLst>
           </p:cNvPr>
@@ -8587,7 +8587,7 @@
           <p:cNvPr id="135" name="Google Shape;135;p23">
             <a:extLst xmlns:a="http://schemas.openxmlformats.org/drawingml/2006/main">
               <a:ext uri="{FF2B5EF4-FFF2-40B4-BE49-F238E27FC236}">
-                <a16:creationId xmlns:a16="http://schemas.microsoft.com/office/drawing/2014/main" id="{21A04D2B-0C70-4008-ACB0-4CC37A504095}"/>
+                <a16:creationId xmlns:a16="http://schemas.microsoft.com/office/drawing/2014/main" id="{01FD61CD-314A-41C9-9572-1BC6AD2E78AE}"/>
               </a:ext>
             </a:extLst>
           </p:cNvPr>
@@ -8667,7 +8667,7 @@
           <p:cNvPr id="136" name="">
             <a:extLst xmlns:a="http://schemas.openxmlformats.org/drawingml/2006/main">
               <a:ext uri="{FF2B5EF4-FFF2-40B4-BE49-F238E27FC236}">
-                <a16:creationId xmlns:a16="http://schemas.microsoft.com/office/drawing/2014/main" id="{494FC534-4068-47EF-B454-C6F743F552D2}"/>
+                <a16:creationId xmlns:a16="http://schemas.microsoft.com/office/drawing/2014/main" id="{D26072D0-18E2-443A-98CD-4EBD11DE8852}"/>
               </a:ext>
             </a:extLst>
           </p:cNvPr>
@@ -8677,7 +8677,7 @@
           <p:nvPr/>
         </p:nvPicPr>
         <p:blipFill>
-          <a:blip xmlns:r="http://schemas.openxmlformats.org/officeDocument/2006/relationships" xmlns:a="http://schemas.openxmlformats.org/drawingml/2006/main" r:embed="Rf3dc652c5b9b42c0"/>
+          <a:blip xmlns:r="http://schemas.openxmlformats.org/officeDocument/2006/relationships" xmlns:a="http://schemas.openxmlformats.org/drawingml/2006/main" r:embed="R4e376ef04e3b4015"/>
           <a:srcRect xmlns:a="http://schemas.openxmlformats.org/drawingml/2006/main" l="0" t="24800" r="0" b="43000"/>
           <a:stretch xmlns:a="http://schemas.openxmlformats.org/drawingml/2006/main"/>
         </p:blipFill>
@@ -8696,7 +8696,7 @@
           <p:cNvPr id="137" name="">
             <a:extLst xmlns:a="http://schemas.openxmlformats.org/drawingml/2006/main">
               <a:ext uri="{FF2B5EF4-FFF2-40B4-BE49-F238E27FC236}">
-                <a16:creationId xmlns:a16="http://schemas.microsoft.com/office/drawing/2014/main" id="{6193978F-6133-4C80-B8BD-D712FC89FBE5}"/>
+                <a16:creationId xmlns:a16="http://schemas.microsoft.com/office/drawing/2014/main" id="{1CA5F642-1022-4A0D-8603-E5B7001D02B5}"/>
               </a:ext>
             </a:extLst>
           </p:cNvPr>
@@ -8764,7 +8764,7 @@
           <p:cNvPr id="138" name="">
             <a:extLst xmlns:a="http://schemas.openxmlformats.org/drawingml/2006/main">
               <a:ext uri="{FF2B5EF4-FFF2-40B4-BE49-F238E27FC236}">
-                <a16:creationId xmlns:a16="http://schemas.microsoft.com/office/drawing/2014/main" id="{B51E215E-2B5B-4CE9-B331-0A351DEE9840}"/>
+                <a16:creationId xmlns:a16="http://schemas.microsoft.com/office/drawing/2014/main" id="{3B73CE53-804C-4646-89E9-4E54E5FA4F67}"/>
               </a:ext>
             </a:extLst>
           </p:cNvPr>
@@ -9224,7 +9224,7 @@
           <p:cNvPr id="139" name="">
             <a:extLst xmlns:a="http://schemas.openxmlformats.org/drawingml/2006/main">
               <a:ext uri="{FF2B5EF4-FFF2-40B4-BE49-F238E27FC236}">
-                <a16:creationId xmlns:a16="http://schemas.microsoft.com/office/drawing/2014/main" id="{A23A34BC-2B83-4624-9E7D-8A3AD0CD7832}"/>
+                <a16:creationId xmlns:a16="http://schemas.microsoft.com/office/drawing/2014/main" id="{880B0699-50BA-418D-A6E5-2FD788732C2D}"/>
               </a:ext>
             </a:extLst>
           </p:cNvPr>
@@ -9292,7 +9292,7 @@
           <p:cNvPr id="140" name="">
             <a:extLst xmlns:a="http://schemas.openxmlformats.org/drawingml/2006/main">
               <a:ext uri="{FF2B5EF4-FFF2-40B4-BE49-F238E27FC236}">
-                <a16:creationId xmlns:a16="http://schemas.microsoft.com/office/drawing/2014/main" id="{AA8A8179-4BF9-4351-AD81-53DCBB259BD6}"/>
+                <a16:creationId xmlns:a16="http://schemas.microsoft.com/office/drawing/2014/main" id="{D0A512BD-6580-4157-AC22-B270E96BC276}"/>
               </a:ext>
             </a:extLst>
           </p:cNvPr>
@@ -9360,7 +9360,7 @@
           <p:cNvPr id="141" name="">
             <a:extLst xmlns:a="http://schemas.openxmlformats.org/drawingml/2006/main">
               <a:ext uri="{FF2B5EF4-FFF2-40B4-BE49-F238E27FC236}">
-                <a16:creationId xmlns:a16="http://schemas.microsoft.com/office/drawing/2014/main" id="{163109CA-A258-4F15-813E-4CDF156FA81F}"/>
+                <a16:creationId xmlns:a16="http://schemas.microsoft.com/office/drawing/2014/main" id="{40FB6546-7581-4FBF-828A-D77002D6315C}"/>
               </a:ext>
             </a:extLst>
           </p:cNvPr>
@@ -9426,7 +9426,7 @@
     </p:spTree>
     <p:extLst>
       <p:ext uri="{BB962C8B-B14F-4D97-AF65-F5344CB8AC3E}">
-        <p14:creationId xmlns:p14="http://schemas.microsoft.com/office/powerpoint/2010/main" val="414888396"/>
+        <p14:creationId xmlns:p14="http://schemas.microsoft.com/office/powerpoint/2010/main" val="409184978"/>
       </p:ext>
     </p:extLst>
   </p:cSld>
@@ -9450,7 +9450,7 @@
           <p:cNvPr id="140" name="Google Shape;140;p24">
             <a:extLst xmlns:a="http://schemas.openxmlformats.org/drawingml/2006/main">
               <a:ext uri="{FF2B5EF4-FFF2-40B4-BE49-F238E27FC236}">
-                <a16:creationId xmlns:a16="http://schemas.microsoft.com/office/drawing/2014/main" id="{631B9865-2170-4F84-A092-D6EF51629149}"/>
+                <a16:creationId xmlns:a16="http://schemas.microsoft.com/office/drawing/2014/main" id="{57D048EA-E34F-4809-825A-1200F384817E}"/>
               </a:ext>
             </a:extLst>
           </p:cNvPr>
@@ -9460,7 +9460,7 @@
           <p:nvPr/>
         </p:nvPicPr>
         <p:blipFill rotWithShape="1">
-          <a:blip xmlns:r="http://schemas.openxmlformats.org/officeDocument/2006/relationships" xmlns:a="http://schemas.openxmlformats.org/drawingml/2006/main" r:embed="R3c1ba07653ac4e43">
+          <a:blip xmlns:r="http://schemas.openxmlformats.org/officeDocument/2006/relationships" xmlns:a="http://schemas.openxmlformats.org/drawingml/2006/main" r:embed="R6d74679e305c40c8">
             <a:alphaModFix/>
           </a:blip>
           <a:srcRect xmlns:a="http://schemas.openxmlformats.org/drawingml/2006/main" l="0" t="0" r="0" b="98001"/>
@@ -9484,7 +9484,7 @@
           <p:cNvPr id="141" name="Google Shape;141;p24">
             <a:extLst xmlns:a="http://schemas.openxmlformats.org/drawingml/2006/main">
               <a:ext uri="{FF2B5EF4-FFF2-40B4-BE49-F238E27FC236}">
-                <a16:creationId xmlns:a16="http://schemas.microsoft.com/office/drawing/2014/main" id="{B7200179-C3D7-470A-9BEE-5851B3DABD6A}"/>
+                <a16:creationId xmlns:a16="http://schemas.microsoft.com/office/drawing/2014/main" id="{E7E57574-1C6A-4978-A13F-E4B06818EA94}"/>
               </a:ext>
             </a:extLst>
           </p:cNvPr>
@@ -9494,7 +9494,7 @@
           <p:nvPr/>
         </p:nvPicPr>
         <p:blipFill>
-          <a:blip xmlns:r="http://schemas.openxmlformats.org/officeDocument/2006/relationships" xmlns:a="http://schemas.openxmlformats.org/drawingml/2006/main" r:embed="R1ee6bbc52a234c7d">
+          <a:blip xmlns:r="http://schemas.openxmlformats.org/officeDocument/2006/relationships" xmlns:a="http://schemas.openxmlformats.org/drawingml/2006/main" r:embed="Raaff32627c6f4dee">
             <a:alphaModFix/>
           </a:blip>
           <a:stretch xmlns:a="http://schemas.openxmlformats.org/drawingml/2006/main">
@@ -9519,7 +9519,7 @@
           <p:cNvPr id="142" name="Google Shape;142;p24">
             <a:extLst xmlns:a="http://schemas.openxmlformats.org/drawingml/2006/main">
               <a:ext uri="{FF2B5EF4-FFF2-40B4-BE49-F238E27FC236}">
-                <a16:creationId xmlns:a16="http://schemas.microsoft.com/office/drawing/2014/main" id="{80138F10-D7C8-448A-9B4E-B0DA99B8D577}"/>
+                <a16:creationId xmlns:a16="http://schemas.microsoft.com/office/drawing/2014/main" id="{064C8B81-7822-4752-BA1E-3805C5F678C1}"/>
               </a:ext>
             </a:extLst>
           </p:cNvPr>
@@ -9570,7 +9570,7 @@
           <p:cNvPr id="143" name="Google Shape;143;p24">
             <a:extLst xmlns:a="http://schemas.openxmlformats.org/drawingml/2006/main">
               <a:ext uri="{FF2B5EF4-FFF2-40B4-BE49-F238E27FC236}">
-                <a16:creationId xmlns:a16="http://schemas.microsoft.com/office/drawing/2014/main" id="{9D989415-2ECD-461B-9582-18744E364E35}"/>
+                <a16:creationId xmlns:a16="http://schemas.microsoft.com/office/drawing/2014/main" id="{76CF7DA1-C3CF-4B32-9E2A-802BE0913B0D}"/>
               </a:ext>
             </a:extLst>
           </p:cNvPr>
@@ -9650,7 +9650,7 @@
           <p:cNvPr id="144" name="">
             <a:extLst xmlns:a="http://schemas.openxmlformats.org/drawingml/2006/main">
               <a:ext uri="{FF2B5EF4-FFF2-40B4-BE49-F238E27FC236}">
-                <a16:creationId xmlns:a16="http://schemas.microsoft.com/office/drawing/2014/main" id="{5E384E1B-6F1E-4BF0-83E1-5EF07CA8E026}"/>
+                <a16:creationId xmlns:a16="http://schemas.microsoft.com/office/drawing/2014/main" id="{AAF791FA-CB47-4713-9E2A-04A7B604CD18}"/>
               </a:ext>
             </a:extLst>
           </p:cNvPr>
@@ -10194,7 +10194,7 @@
           <p:cNvPr id="145" name="">
             <a:extLst xmlns:a="http://schemas.openxmlformats.org/drawingml/2006/main">
               <a:ext uri="{FF2B5EF4-FFF2-40B4-BE49-F238E27FC236}">
-                <a16:creationId xmlns:a16="http://schemas.microsoft.com/office/drawing/2014/main" id="{102E74DB-7DF8-4A0D-984C-BA0415604DB2}"/>
+                <a16:creationId xmlns:a16="http://schemas.microsoft.com/office/drawing/2014/main" id="{F0E9AAC6-62EA-4F31-9B73-B2CB659DDA47}"/>
               </a:ext>
             </a:extLst>
           </p:cNvPr>
@@ -10262,7 +10262,7 @@
           <p:cNvPr id="146" name="">
             <a:extLst xmlns:a="http://schemas.openxmlformats.org/drawingml/2006/main">
               <a:ext uri="{FF2B5EF4-FFF2-40B4-BE49-F238E27FC236}">
-                <a16:creationId xmlns:a16="http://schemas.microsoft.com/office/drawing/2014/main" id="{BCC17936-609D-4B4F-A0FA-F4BEDAA62FA3}"/>
+                <a16:creationId xmlns:a16="http://schemas.microsoft.com/office/drawing/2014/main" id="{624178D1-6283-4CC7-8310-1F1CEE3DFC15}"/>
               </a:ext>
             </a:extLst>
           </p:cNvPr>
@@ -10330,7 +10330,7 @@
           <p:cNvPr id="147" name="">
             <a:extLst xmlns:a="http://schemas.openxmlformats.org/drawingml/2006/main">
               <a:ext uri="{FF2B5EF4-FFF2-40B4-BE49-F238E27FC236}">
-                <a16:creationId xmlns:a16="http://schemas.microsoft.com/office/drawing/2014/main" id="{0FE11053-50DF-49E3-AEA8-8BCD94B95D33}"/>
+                <a16:creationId xmlns:a16="http://schemas.microsoft.com/office/drawing/2014/main" id="{465B0975-BF16-4095-AC96-3DCA683FD97F}"/>
               </a:ext>
             </a:extLst>
           </p:cNvPr>
@@ -10396,7 +10396,7 @@
     </p:spTree>
     <p:extLst>
       <p:ext uri="{BB962C8B-B14F-4D97-AF65-F5344CB8AC3E}">
-        <p14:creationId xmlns:p14="http://schemas.microsoft.com/office/powerpoint/2010/main" val="571021746"/>
+        <p14:creationId xmlns:p14="http://schemas.microsoft.com/office/powerpoint/2010/main" val="1381515863"/>
       </p:ext>
     </p:extLst>
   </p:cSld>
@@ -10420,7 +10420,7 @@
           <p:cNvPr id="148" name="Google Shape;148;p25">
             <a:extLst xmlns:a="http://schemas.openxmlformats.org/drawingml/2006/main">
               <a:ext uri="{FF2B5EF4-FFF2-40B4-BE49-F238E27FC236}">
-                <a16:creationId xmlns:a16="http://schemas.microsoft.com/office/drawing/2014/main" id="{C6173731-C4D1-4173-A786-642E316D03CC}"/>
+                <a16:creationId xmlns:a16="http://schemas.microsoft.com/office/drawing/2014/main" id="{DF31ABDE-0F04-4DD1-AF96-96F265CB31F9}"/>
               </a:ext>
             </a:extLst>
           </p:cNvPr>
@@ -10430,7 +10430,7 @@
           <p:nvPr/>
         </p:nvPicPr>
         <p:blipFill rotWithShape="1">
-          <a:blip xmlns:r="http://schemas.openxmlformats.org/officeDocument/2006/relationships" xmlns:a="http://schemas.openxmlformats.org/drawingml/2006/main" r:embed="R7a6e21f3a53a4498">
+          <a:blip xmlns:r="http://schemas.openxmlformats.org/officeDocument/2006/relationships" xmlns:a="http://schemas.openxmlformats.org/drawingml/2006/main" r:embed="Rd2d6c5c060bd40f4">
             <a:alphaModFix/>
           </a:blip>
           <a:srcRect xmlns:a="http://schemas.openxmlformats.org/drawingml/2006/main" l="0" t="0" r="0" b="98001"/>
@@ -10454,7 +10454,7 @@
           <p:cNvPr id="149" name="Google Shape;149;p25">
             <a:extLst xmlns:a="http://schemas.openxmlformats.org/drawingml/2006/main">
               <a:ext uri="{FF2B5EF4-FFF2-40B4-BE49-F238E27FC236}">
-                <a16:creationId xmlns:a16="http://schemas.microsoft.com/office/drawing/2014/main" id="{9D5060C5-5CC3-48FE-B350-5BF36463EA71}"/>
+                <a16:creationId xmlns:a16="http://schemas.microsoft.com/office/drawing/2014/main" id="{0B3BC27F-D51B-4C7D-8E3A-280A08EC13FD}"/>
               </a:ext>
             </a:extLst>
           </p:cNvPr>
@@ -10464,7 +10464,7 @@
           <p:nvPr/>
         </p:nvPicPr>
         <p:blipFill>
-          <a:blip xmlns:r="http://schemas.openxmlformats.org/officeDocument/2006/relationships" xmlns:a="http://schemas.openxmlformats.org/drawingml/2006/main" r:embed="R84c633dc7a3b4017">
+          <a:blip xmlns:r="http://schemas.openxmlformats.org/officeDocument/2006/relationships" xmlns:a="http://schemas.openxmlformats.org/drawingml/2006/main" r:embed="R7e2b63c49ec848b4">
             <a:alphaModFix/>
           </a:blip>
           <a:stretch xmlns:a="http://schemas.openxmlformats.org/drawingml/2006/main">
@@ -10489,7 +10489,7 @@
           <p:cNvPr id="150" name="Google Shape;150;p25">
             <a:extLst xmlns:a="http://schemas.openxmlformats.org/drawingml/2006/main">
               <a:ext uri="{FF2B5EF4-FFF2-40B4-BE49-F238E27FC236}">
-                <a16:creationId xmlns:a16="http://schemas.microsoft.com/office/drawing/2014/main" id="{8D035A79-20A5-4EC4-A017-B869D77C491B}"/>
+                <a16:creationId xmlns:a16="http://schemas.microsoft.com/office/drawing/2014/main" id="{21B2D497-FAF8-4F0B-B519-41F178DA3ACF}"/>
               </a:ext>
             </a:extLst>
           </p:cNvPr>
@@ -10540,7 +10540,7 @@
           <p:cNvPr id="151" name="Google Shape;151;p25">
             <a:extLst xmlns:a="http://schemas.openxmlformats.org/drawingml/2006/main">
               <a:ext uri="{FF2B5EF4-FFF2-40B4-BE49-F238E27FC236}">
-                <a16:creationId xmlns:a16="http://schemas.microsoft.com/office/drawing/2014/main" id="{46841582-4BFA-4586-AD01-0758C9A1E6C6}"/>
+                <a16:creationId xmlns:a16="http://schemas.microsoft.com/office/drawing/2014/main" id="{F78E9426-F84B-4395-8501-6BE0BF61BA93}"/>
               </a:ext>
             </a:extLst>
           </p:cNvPr>
@@ -10620,7 +10620,7 @@
           <p:cNvPr id="152" name="">
             <a:extLst xmlns:a="http://schemas.openxmlformats.org/drawingml/2006/main">
               <a:ext uri="{FF2B5EF4-FFF2-40B4-BE49-F238E27FC236}">
-                <a16:creationId xmlns:a16="http://schemas.microsoft.com/office/drawing/2014/main" id="{53748010-464F-447A-87E0-A6ACA4955931}"/>
+                <a16:creationId xmlns:a16="http://schemas.microsoft.com/office/drawing/2014/main" id="{307183FB-5A8A-421C-BF55-F5883AB6AF15}"/>
               </a:ext>
             </a:extLst>
           </p:cNvPr>
@@ -10688,7 +10688,7 @@
           <p:cNvPr id="153" name="">
             <a:extLst xmlns:a="http://schemas.openxmlformats.org/drawingml/2006/main">
               <a:ext uri="{FF2B5EF4-FFF2-40B4-BE49-F238E27FC236}">
-                <a16:creationId xmlns:a16="http://schemas.microsoft.com/office/drawing/2014/main" id="{56873F9D-27FA-4E73-86A4-C940D55972D4}"/>
+                <a16:creationId xmlns:a16="http://schemas.microsoft.com/office/drawing/2014/main" id="{D755AA5F-412D-422F-B9C3-867DB4A5BC10}"/>
               </a:ext>
             </a:extLst>
           </p:cNvPr>
@@ -10841,7 +10841,7 @@
           <p:cNvPr id="154" name="">
             <a:extLst xmlns:a="http://schemas.openxmlformats.org/drawingml/2006/main">
               <a:ext uri="{FF2B5EF4-FFF2-40B4-BE49-F238E27FC236}">
-                <a16:creationId xmlns:a16="http://schemas.microsoft.com/office/drawing/2014/main" id="{CBB37EBB-FAE9-4126-95E6-00E159798FED}"/>
+                <a16:creationId xmlns:a16="http://schemas.microsoft.com/office/drawing/2014/main" id="{EDFEF283-1DCB-41EB-A453-F0F6DB1461B3}"/>
               </a:ext>
             </a:extLst>
           </p:cNvPr>
@@ -10909,7 +10909,7 @@
           <p:cNvPr id="155" name="">
             <a:extLst xmlns:a="http://schemas.openxmlformats.org/drawingml/2006/main">
               <a:ext uri="{FF2B5EF4-FFF2-40B4-BE49-F238E27FC236}">
-                <a16:creationId xmlns:a16="http://schemas.microsoft.com/office/drawing/2014/main" id="{BEA7FFA6-A1C0-475D-B5F3-2271F6CAB6CF}"/>
+                <a16:creationId xmlns:a16="http://schemas.microsoft.com/office/drawing/2014/main" id="{2E030D5D-C619-41D2-A3DF-D7A49385E3C2}"/>
               </a:ext>
             </a:extLst>
           </p:cNvPr>
@@ -11062,7 +11062,7 @@
           <p:cNvPr id="156" name="">
             <a:extLst xmlns:a="http://schemas.openxmlformats.org/drawingml/2006/main">
               <a:ext uri="{FF2B5EF4-FFF2-40B4-BE49-F238E27FC236}">
-                <a16:creationId xmlns:a16="http://schemas.microsoft.com/office/drawing/2014/main" id="{98258C4C-E9A0-4E84-8F05-DE9B2A2F9851}"/>
+                <a16:creationId xmlns:a16="http://schemas.microsoft.com/office/drawing/2014/main" id="{FE935E09-ED56-4C85-88B4-48BDEB42A61C}"/>
               </a:ext>
             </a:extLst>
           </p:cNvPr>
@@ -11130,7 +11130,7 @@
           <p:cNvPr id="157" name="">
             <a:extLst xmlns:a="http://schemas.openxmlformats.org/drawingml/2006/main">
               <a:ext uri="{FF2B5EF4-FFF2-40B4-BE49-F238E27FC236}">
-                <a16:creationId xmlns:a16="http://schemas.microsoft.com/office/drawing/2014/main" id="{1B579689-6F9C-4689-BA0A-C80905D7044F}"/>
+                <a16:creationId xmlns:a16="http://schemas.microsoft.com/office/drawing/2014/main" id="{47E2FF54-6CF1-4A55-BEF3-263AA59868B7}"/>
               </a:ext>
             </a:extLst>
           </p:cNvPr>
@@ -11196,7 +11196,7 @@
     </p:spTree>
     <p:extLst>
       <p:ext uri="{BB962C8B-B14F-4D97-AF65-F5344CB8AC3E}">
-        <p14:creationId xmlns:p14="http://schemas.microsoft.com/office/powerpoint/2010/main" val="1130231027"/>
+        <p14:creationId xmlns:p14="http://schemas.microsoft.com/office/powerpoint/2010/main" val="1977107326"/>
       </p:ext>
     </p:extLst>
   </p:cSld>
@@ -11220,7 +11220,7 @@
           <p:cNvPr id="156" name="Google Shape;156;p26">
             <a:extLst xmlns:a="http://schemas.openxmlformats.org/drawingml/2006/main">
               <a:ext uri="{FF2B5EF4-FFF2-40B4-BE49-F238E27FC236}">
-                <a16:creationId xmlns:a16="http://schemas.microsoft.com/office/drawing/2014/main" id="{E2FF7D86-CEC8-450E-9C44-EA1E9F347B55}"/>
+                <a16:creationId xmlns:a16="http://schemas.microsoft.com/office/drawing/2014/main" id="{3BF0D86F-2429-4875-829E-AD1850691B5F}"/>
               </a:ext>
             </a:extLst>
           </p:cNvPr>
@@ -11230,7 +11230,7 @@
           <p:nvPr/>
         </p:nvPicPr>
         <p:blipFill rotWithShape="1">
-          <a:blip xmlns:r="http://schemas.openxmlformats.org/officeDocument/2006/relationships" xmlns:a="http://schemas.openxmlformats.org/drawingml/2006/main" r:embed="R303dbce5123444e6">
+          <a:blip xmlns:r="http://schemas.openxmlformats.org/officeDocument/2006/relationships" xmlns:a="http://schemas.openxmlformats.org/drawingml/2006/main" r:embed="R5ae899fe85634200">
             <a:alphaModFix/>
           </a:blip>
           <a:srcRect xmlns:a="http://schemas.openxmlformats.org/drawingml/2006/main" l="0" t="0" r="0" b="98001"/>
@@ -11254,7 +11254,7 @@
           <p:cNvPr id="157" name="Google Shape;157;p26">
             <a:extLst xmlns:a="http://schemas.openxmlformats.org/drawingml/2006/main">
               <a:ext uri="{FF2B5EF4-FFF2-40B4-BE49-F238E27FC236}">
-                <a16:creationId xmlns:a16="http://schemas.microsoft.com/office/drawing/2014/main" id="{DF2CC578-2739-46E0-A31E-4552F75F098F}"/>
+                <a16:creationId xmlns:a16="http://schemas.microsoft.com/office/drawing/2014/main" id="{B1064089-37CE-44FE-B06A-0C01DC1DFFF1}"/>
               </a:ext>
             </a:extLst>
           </p:cNvPr>
@@ -11264,7 +11264,7 @@
           <p:nvPr/>
         </p:nvPicPr>
         <p:blipFill>
-          <a:blip xmlns:r="http://schemas.openxmlformats.org/officeDocument/2006/relationships" xmlns:a="http://schemas.openxmlformats.org/drawingml/2006/main" r:embed="R81e721b813ee4e40">
+          <a:blip xmlns:r="http://schemas.openxmlformats.org/officeDocument/2006/relationships" xmlns:a="http://schemas.openxmlformats.org/drawingml/2006/main" r:embed="R94a16cfdd70c4506">
             <a:alphaModFix/>
           </a:blip>
           <a:stretch xmlns:a="http://schemas.openxmlformats.org/drawingml/2006/main">
@@ -11289,7 +11289,7 @@
           <p:cNvPr id="158" name="Google Shape;158;p26">
             <a:extLst xmlns:a="http://schemas.openxmlformats.org/drawingml/2006/main">
               <a:ext uri="{FF2B5EF4-FFF2-40B4-BE49-F238E27FC236}">
-                <a16:creationId xmlns:a16="http://schemas.microsoft.com/office/drawing/2014/main" id="{F09F1BF4-FE46-4293-AA38-51827FF5A89B}"/>
+                <a16:creationId xmlns:a16="http://schemas.microsoft.com/office/drawing/2014/main" id="{550FFD8E-4DA0-490D-A65C-DB6E861E57DE}"/>
               </a:ext>
             </a:extLst>
           </p:cNvPr>
@@ -11340,7 +11340,7 @@
           <p:cNvPr id="159" name="Google Shape;159;p26">
             <a:extLst xmlns:a="http://schemas.openxmlformats.org/drawingml/2006/main">
               <a:ext uri="{FF2B5EF4-FFF2-40B4-BE49-F238E27FC236}">
-                <a16:creationId xmlns:a16="http://schemas.microsoft.com/office/drawing/2014/main" id="{A2E3EDD8-8843-4479-8888-1879123C5D73}"/>
+                <a16:creationId xmlns:a16="http://schemas.microsoft.com/office/drawing/2014/main" id="{2F1070D6-F34B-4547-B63D-B583EB65A054}"/>
               </a:ext>
             </a:extLst>
           </p:cNvPr>
@@ -11420,7 +11420,7 @@
           <p:cNvPr id="160" name="">
             <a:extLst xmlns:a="http://schemas.openxmlformats.org/drawingml/2006/main">
               <a:ext uri="{FF2B5EF4-FFF2-40B4-BE49-F238E27FC236}">
-                <a16:creationId xmlns:a16="http://schemas.microsoft.com/office/drawing/2014/main" id="{FF6C172D-B170-4C46-8EDD-9898157BB869}"/>
+                <a16:creationId xmlns:a16="http://schemas.microsoft.com/office/drawing/2014/main" id="{B2702061-D8C7-4637-9691-D903404E2755}"/>
               </a:ext>
             </a:extLst>
           </p:cNvPr>
@@ -11488,7 +11488,7 @@
           <p:cNvPr id="161" name="">
             <a:extLst xmlns:a="http://schemas.openxmlformats.org/drawingml/2006/main">
               <a:ext uri="{FF2B5EF4-FFF2-40B4-BE49-F238E27FC236}">
-                <a16:creationId xmlns:a16="http://schemas.microsoft.com/office/drawing/2014/main" id="{D27D8559-2ACF-4BAF-A641-2598E5F943CA}"/>
+                <a16:creationId xmlns:a16="http://schemas.microsoft.com/office/drawing/2014/main" id="{62146A69-D61C-4968-BEA0-1F8380B043FF}"/>
               </a:ext>
             </a:extLst>
           </p:cNvPr>
@@ -11545,7 +11545,7 @@
                 <a:latin typeface="Google Sans Flex"/>
                 <a:ea typeface="Google Sans Flex"/>
                 <a:cs typeface="Google Sans Flex"/>
-                <a:hlinkClick xmlns:r="http://schemas.openxmlformats.org/officeDocument/2006/relationships" r:id="R1d4cbcca4fa64a36"/>
+                <a:hlinkClick xmlns:r="http://schemas.openxmlformats.org/officeDocument/2006/relationships" r:id="R48f3017f3fe64a02"/>
               </a:rPr>
               <a:t>https://github.com/Santxsh27/financial-friday</a:t>
             </a:r>
@@ -11557,7 +11557,7 @@
           <p:cNvPr id="162" name="">
             <a:extLst xmlns:a="http://schemas.openxmlformats.org/drawingml/2006/main">
               <a:ext uri="{FF2B5EF4-FFF2-40B4-BE49-F238E27FC236}">
-                <a16:creationId xmlns:a16="http://schemas.microsoft.com/office/drawing/2014/main" id="{4C3E7940-D3EF-4305-A9D0-95228DB7FB40}"/>
+                <a16:creationId xmlns:a16="http://schemas.microsoft.com/office/drawing/2014/main" id="{A0E7DF03-1EA8-47C4-ACF8-81F76F49AC27}"/>
               </a:ext>
             </a:extLst>
           </p:cNvPr>
@@ -11625,7 +11625,7 @@
           <p:cNvPr id="163" name="">
             <a:extLst xmlns:a="http://schemas.openxmlformats.org/drawingml/2006/main">
               <a:ext uri="{FF2B5EF4-FFF2-40B4-BE49-F238E27FC236}">
-                <a16:creationId xmlns:a16="http://schemas.microsoft.com/office/drawing/2014/main" id="{00EA653B-604F-4469-824B-D1EE118AC63A}"/>
+                <a16:creationId xmlns:a16="http://schemas.microsoft.com/office/drawing/2014/main" id="{423FB522-9398-4E4D-9964-B0C011FF7F7B}"/>
               </a:ext>
             </a:extLst>
           </p:cNvPr>
@@ -11682,7 +11682,7 @@
                 <a:latin typeface="Google Sans Flex"/>
                 <a:ea typeface="Google Sans Flex"/>
                 <a:cs typeface="Google Sans Flex"/>
-                <a:hlinkClick xmlns:r="http://schemas.openxmlformats.org/officeDocument/2006/relationships" r:id="R28ffb8c99a0e4635"/>
+                <a:hlinkClick xmlns:r="http://schemas.openxmlformats.org/officeDocument/2006/relationships" r:id="R9ca480c311aa46bd"/>
               </a:rPr>
               <a:t>https://financial-friday-web-171681243260.asia-south1.run.app/#home</a:t>
             </a:r>
@@ -11694,7 +11694,7 @@
           <p:cNvPr id="164" name="">
             <a:extLst xmlns:a="http://schemas.openxmlformats.org/drawingml/2006/main">
               <a:ext uri="{FF2B5EF4-FFF2-40B4-BE49-F238E27FC236}">
-                <a16:creationId xmlns:a16="http://schemas.microsoft.com/office/drawing/2014/main" id="{FA58D611-0DDB-48A9-ACBA-3FEE050A7F51}"/>
+                <a16:creationId xmlns:a16="http://schemas.microsoft.com/office/drawing/2014/main" id="{890B5A18-6460-4E5E-B9B2-C1C9B3ADAE77}"/>
               </a:ext>
             </a:extLst>
           </p:cNvPr>
@@ -11762,7 +11762,7 @@
           <p:cNvPr id="165" name="">
             <a:extLst xmlns:a="http://schemas.openxmlformats.org/drawingml/2006/main">
               <a:ext uri="{FF2B5EF4-FFF2-40B4-BE49-F238E27FC236}">
-                <a16:creationId xmlns:a16="http://schemas.microsoft.com/office/drawing/2014/main" id="{E826195E-DCA8-41EA-BC1E-C38046C5EE41}"/>
+                <a16:creationId xmlns:a16="http://schemas.microsoft.com/office/drawing/2014/main" id="{11039F06-D29C-4825-B5A1-93637BE152F7}"/>
               </a:ext>
             </a:extLst>
           </p:cNvPr>
@@ -11830,7 +11830,7 @@
           <p:cNvPr id="166" name="">
             <a:extLst xmlns:a="http://schemas.openxmlformats.org/drawingml/2006/main">
               <a:ext uri="{FF2B5EF4-FFF2-40B4-BE49-F238E27FC236}">
-                <a16:creationId xmlns:a16="http://schemas.microsoft.com/office/drawing/2014/main" id="{43D3166C-406D-420C-B202-418E5FE92B24}"/>
+                <a16:creationId xmlns:a16="http://schemas.microsoft.com/office/drawing/2014/main" id="{FF47A1FC-C78E-47FC-8596-AB838B16C75B}"/>
               </a:ext>
             </a:extLst>
           </p:cNvPr>
@@ -11898,7 +11898,7 @@
           <p:cNvPr id="167" name="">
             <a:extLst xmlns:a="http://schemas.openxmlformats.org/drawingml/2006/main">
               <a:ext uri="{FF2B5EF4-FFF2-40B4-BE49-F238E27FC236}">
-                <a16:creationId xmlns:a16="http://schemas.microsoft.com/office/drawing/2014/main" id="{196F54B7-ABD8-4572-A760-505709EAF346}"/>
+                <a16:creationId xmlns:a16="http://schemas.microsoft.com/office/drawing/2014/main" id="{BC39B49E-7319-4537-802A-BEE5B0FB1BA4}"/>
               </a:ext>
             </a:extLst>
           </p:cNvPr>
@@ -11955,7 +11955,7 @@
                 <a:latin typeface="Google Sans Flex"/>
                 <a:ea typeface="Google Sans Flex"/>
                 <a:cs typeface="Google Sans Flex"/>
-                <a:hlinkClick xmlns:r="http://schemas.openxmlformats.org/officeDocument/2006/relationships" r:id="R1620c48a98744e60"/>
+                <a:hlinkClick xmlns:r="http://schemas.openxmlformats.org/officeDocument/2006/relationships" r:id="R3afacadde2d74474"/>
               </a:rPr>
               <a:t>https://financial-friday-web-171681243260.asia-south1.run.app/assets/friday-judge-guide.html</a:t>
             </a:r>
@@ -11967,7 +11967,7 @@
           <p:cNvPr id="168" name="">
             <a:extLst xmlns:a="http://schemas.openxmlformats.org/drawingml/2006/main">
               <a:ext uri="{FF2B5EF4-FFF2-40B4-BE49-F238E27FC236}">
-                <a16:creationId xmlns:a16="http://schemas.microsoft.com/office/drawing/2014/main" id="{D4469A65-09BF-4170-B889-6BF19D7EC61E}"/>
+                <a16:creationId xmlns:a16="http://schemas.microsoft.com/office/drawing/2014/main" id="{25E09A97-75ED-461B-9D87-2EEA82B60F29}"/>
               </a:ext>
             </a:extLst>
           </p:cNvPr>
@@ -12035,7 +12035,7 @@
           <p:cNvPr id="169" name="">
             <a:extLst xmlns:a="http://schemas.openxmlformats.org/drawingml/2006/main">
               <a:ext uri="{FF2B5EF4-FFF2-40B4-BE49-F238E27FC236}">
-                <a16:creationId xmlns:a16="http://schemas.microsoft.com/office/drawing/2014/main" id="{9C94EE7B-6E1D-4462-A85F-9C23A6586FAB}"/>
+                <a16:creationId xmlns:a16="http://schemas.microsoft.com/office/drawing/2014/main" id="{0E330252-F1D7-402D-804E-7215A98244AC}"/>
               </a:ext>
             </a:extLst>
           </p:cNvPr>
@@ -12101,7 +12101,7 @@
     </p:spTree>
     <p:extLst>
       <p:ext uri="{BB962C8B-B14F-4D97-AF65-F5344CB8AC3E}">
-        <p14:creationId xmlns:p14="http://schemas.microsoft.com/office/powerpoint/2010/main" val="2091065402"/>
+        <p14:creationId xmlns:p14="http://schemas.microsoft.com/office/powerpoint/2010/main" val="435024508"/>
       </p:ext>
     </p:extLst>
   </p:cSld>
@@ -12125,7 +12125,7 @@
           <p:cNvPr id="164" name="Google Shape;164;p27">
             <a:extLst xmlns:a="http://schemas.openxmlformats.org/drawingml/2006/main">
               <a:ext uri="{FF2B5EF4-FFF2-40B4-BE49-F238E27FC236}">
-                <a16:creationId xmlns:a16="http://schemas.microsoft.com/office/drawing/2014/main" id="{C51A70C1-D037-4CE3-B950-777D85439DBC}"/>
+                <a16:creationId xmlns:a16="http://schemas.microsoft.com/office/drawing/2014/main" id="{3DD7B040-1741-4D44-838C-CD4E6CF2038F}"/>
               </a:ext>
             </a:extLst>
           </p:cNvPr>
@@ -12135,7 +12135,7 @@
           <p:nvPr/>
         </p:nvPicPr>
         <p:blipFill rotWithShape="1">
-          <a:blip xmlns:r="http://schemas.openxmlformats.org/officeDocument/2006/relationships" xmlns:a="http://schemas.openxmlformats.org/drawingml/2006/main" r:embed="R2582dbfa8033429e">
+          <a:blip xmlns:r="http://schemas.openxmlformats.org/officeDocument/2006/relationships" xmlns:a="http://schemas.openxmlformats.org/drawingml/2006/main" r:embed="R193d631400854009">
             <a:alphaModFix/>
           </a:blip>
           <a:srcRect xmlns:a="http://schemas.openxmlformats.org/drawingml/2006/main" l="0" t="0" r="0" b="98001"/>
@@ -12159,7 +12159,7 @@
           <p:cNvPr id="165" name="Google Shape;165;p27">
             <a:extLst xmlns:a="http://schemas.openxmlformats.org/drawingml/2006/main">
               <a:ext uri="{FF2B5EF4-FFF2-40B4-BE49-F238E27FC236}">
-                <a16:creationId xmlns:a16="http://schemas.microsoft.com/office/drawing/2014/main" id="{8F9A72DA-E9AC-40C3-A094-B77756D1C8C5}"/>
+                <a16:creationId xmlns:a16="http://schemas.microsoft.com/office/drawing/2014/main" id="{AFE66EED-DEDF-46EF-BFF9-DF38AC5318EC}"/>
               </a:ext>
             </a:extLst>
           </p:cNvPr>
@@ -12169,7 +12169,7 @@
           <p:nvPr/>
         </p:nvPicPr>
         <p:blipFill>
-          <a:blip xmlns:r="http://schemas.openxmlformats.org/officeDocument/2006/relationships" xmlns:a="http://schemas.openxmlformats.org/drawingml/2006/main" r:embed="R5ec8f29d6ba1422c">
+          <a:blip xmlns:r="http://schemas.openxmlformats.org/officeDocument/2006/relationships" xmlns:a="http://schemas.openxmlformats.org/drawingml/2006/main" r:embed="R6f38c54d47be4502">
             <a:alphaModFix/>
           </a:blip>
           <a:stretch xmlns:a="http://schemas.openxmlformats.org/drawingml/2006/main">
@@ -12194,7 +12194,7 @@
           <p:cNvPr id="166" name="Google Shape;166;p27">
             <a:extLst xmlns:a="http://schemas.openxmlformats.org/drawingml/2006/main">
               <a:ext uri="{FF2B5EF4-FFF2-40B4-BE49-F238E27FC236}">
-                <a16:creationId xmlns:a16="http://schemas.microsoft.com/office/drawing/2014/main" id="{3F180C7E-F074-4B3D-AB2A-C09A93EE9F52}"/>
+                <a16:creationId xmlns:a16="http://schemas.microsoft.com/office/drawing/2014/main" id="{5D3886C3-059A-49C3-86C3-D539972B7951}"/>
               </a:ext>
             </a:extLst>
           </p:cNvPr>
@@ -12245,7 +12245,7 @@
           <p:cNvPr id="167" name="">
             <a:extLst xmlns:a="http://schemas.openxmlformats.org/drawingml/2006/main">
               <a:ext uri="{FF2B5EF4-FFF2-40B4-BE49-F238E27FC236}">
-                <a16:creationId xmlns:a16="http://schemas.microsoft.com/office/drawing/2014/main" id="{0FA86A03-5C5C-4A38-A6B8-6F5404B8098E}"/>
+                <a16:creationId xmlns:a16="http://schemas.microsoft.com/office/drawing/2014/main" id="{67BE98D3-80E2-4C98-9F9D-07691DD9F7F9}"/>
               </a:ext>
             </a:extLst>
           </p:cNvPr>
@@ -12313,7 +12313,7 @@
           <p:cNvPr id="168" name="">
             <a:extLst xmlns:a="http://schemas.openxmlformats.org/drawingml/2006/main">
               <a:ext uri="{FF2B5EF4-FFF2-40B4-BE49-F238E27FC236}">
-                <a16:creationId xmlns:a16="http://schemas.microsoft.com/office/drawing/2014/main" id="{3CB5AF3A-F54D-46CD-9F26-B04648836F72}"/>
+                <a16:creationId xmlns:a16="http://schemas.microsoft.com/office/drawing/2014/main" id="{72DF6094-93E2-4F86-8051-424F3CB415A8}"/>
               </a:ext>
             </a:extLst>
           </p:cNvPr>
@@ -12381,7 +12381,7 @@
           <p:cNvPr id="169" name="">
             <a:extLst xmlns:a="http://schemas.openxmlformats.org/drawingml/2006/main">
               <a:ext uri="{FF2B5EF4-FFF2-40B4-BE49-F238E27FC236}">
-                <a16:creationId xmlns:a16="http://schemas.microsoft.com/office/drawing/2014/main" id="{1DAFBA21-658D-4DF5-8777-160DAADF436D}"/>
+                <a16:creationId xmlns:a16="http://schemas.microsoft.com/office/drawing/2014/main" id="{8B9F2F72-0FE2-49A5-92F2-CB6750AE3689}"/>
               </a:ext>
             </a:extLst>
           </p:cNvPr>
@@ -12561,7 +12561,7 @@
           <p:cNvPr id="170" name="">
             <a:extLst xmlns:a="http://schemas.openxmlformats.org/drawingml/2006/main">
               <a:ext uri="{FF2B5EF4-FFF2-40B4-BE49-F238E27FC236}">
-                <a16:creationId xmlns:a16="http://schemas.microsoft.com/office/drawing/2014/main" id="{538E2AE4-2C08-4880-A99E-E2C2F3489F9B}"/>
+                <a16:creationId xmlns:a16="http://schemas.microsoft.com/office/drawing/2014/main" id="{A09A087F-C3E7-44B2-9095-8D431FEC8E92}"/>
               </a:ext>
             </a:extLst>
           </p:cNvPr>
@@ -12629,7 +12629,7 @@
           <p:cNvPr id="171" name="">
             <a:extLst xmlns:a="http://schemas.openxmlformats.org/drawingml/2006/main">
               <a:ext uri="{FF2B5EF4-FFF2-40B4-BE49-F238E27FC236}">
-                <a16:creationId xmlns:a16="http://schemas.microsoft.com/office/drawing/2014/main" id="{D84FC1D6-3DBA-41C0-B46D-BF95612DCEFD}"/>
+                <a16:creationId xmlns:a16="http://schemas.microsoft.com/office/drawing/2014/main" id="{40841DEB-0F99-4E5B-B93C-A92727DD846E}"/>
               </a:ext>
             </a:extLst>
           </p:cNvPr>
@@ -12697,7 +12697,7 @@
           <p:cNvPr id="172" name="">
             <a:extLst xmlns:a="http://schemas.openxmlformats.org/drawingml/2006/main">
               <a:ext uri="{FF2B5EF4-FFF2-40B4-BE49-F238E27FC236}">
-                <a16:creationId xmlns:a16="http://schemas.microsoft.com/office/drawing/2014/main" id="{8F90A1A9-B961-494E-8FC4-B93E19947137}"/>
+                <a16:creationId xmlns:a16="http://schemas.microsoft.com/office/drawing/2014/main" id="{45ED82C2-91BD-491B-A5A1-FD00FE5C5ECA}"/>
               </a:ext>
             </a:extLst>
           </p:cNvPr>
@@ -12763,7 +12763,7 @@
     </p:spTree>
     <p:extLst>
       <p:ext uri="{BB962C8B-B14F-4D97-AF65-F5344CB8AC3E}">
-        <p14:creationId xmlns:p14="http://schemas.microsoft.com/office/powerpoint/2010/main" val="703109419"/>
+        <p14:creationId xmlns:p14="http://schemas.microsoft.com/office/powerpoint/2010/main" val="234754243"/>
       </p:ext>
     </p:extLst>
   </p:cSld>
@@ -12787,7 +12787,7 @@
           <p:cNvPr id="171" name="Google Shape;171;p28">
             <a:extLst xmlns:a="http://schemas.openxmlformats.org/drawingml/2006/main">
               <a:ext uri="{FF2B5EF4-FFF2-40B4-BE49-F238E27FC236}">
-                <a16:creationId xmlns:a16="http://schemas.microsoft.com/office/drawing/2014/main" id="{E57721DC-82F9-4348-B8B2-3FD0BBA590B9}"/>
+                <a16:creationId xmlns:a16="http://schemas.microsoft.com/office/drawing/2014/main" id="{BB604C01-ADF1-438B-B35A-514AE0FF16D8}"/>
               </a:ext>
             </a:extLst>
           </p:cNvPr>
@@ -12797,7 +12797,7 @@
           <p:nvPr/>
         </p:nvPicPr>
         <p:blipFill rotWithShape="1">
-          <a:blip xmlns:r="http://schemas.openxmlformats.org/officeDocument/2006/relationships" xmlns:a="http://schemas.openxmlformats.org/drawingml/2006/main" r:embed="R064cc2191d6145c1">
+          <a:blip xmlns:r="http://schemas.openxmlformats.org/officeDocument/2006/relationships" xmlns:a="http://schemas.openxmlformats.org/drawingml/2006/main" r:embed="R7c7d62de1ab6402c">
             <a:alphaModFix/>
           </a:blip>
           <a:srcRect xmlns:a="http://schemas.openxmlformats.org/drawingml/2006/main" l="0" t="0" r="0" b="98001"/>
@@ -12821,7 +12821,7 @@
           <p:cNvPr id="172" name="Google Shape;172;p28">
             <a:extLst xmlns:a="http://schemas.openxmlformats.org/drawingml/2006/main">
               <a:ext uri="{FF2B5EF4-FFF2-40B4-BE49-F238E27FC236}">
-                <a16:creationId xmlns:a16="http://schemas.microsoft.com/office/drawing/2014/main" id="{428509F7-DB81-4991-B8E0-E841E9C427B3}"/>
+                <a16:creationId xmlns:a16="http://schemas.microsoft.com/office/drawing/2014/main" id="{2E630C5D-A089-4563-824D-8F4D005FB421}"/>
               </a:ext>
             </a:extLst>
           </p:cNvPr>
@@ -12831,7 +12831,7 @@
           <p:nvPr/>
         </p:nvPicPr>
         <p:blipFill>
-          <a:blip xmlns:r="http://schemas.openxmlformats.org/officeDocument/2006/relationships" xmlns:a="http://schemas.openxmlformats.org/drawingml/2006/main" r:embed="R328a6aa6e43f41d2">
+          <a:blip xmlns:r="http://schemas.openxmlformats.org/officeDocument/2006/relationships" xmlns:a="http://schemas.openxmlformats.org/drawingml/2006/main" r:embed="R614ae2802297410e">
             <a:alphaModFix/>
           </a:blip>
           <a:stretch xmlns:a="http://schemas.openxmlformats.org/drawingml/2006/main">
@@ -12854,7 +12854,7 @@
     </p:spTree>
     <p:extLst>
       <p:ext uri="{BB962C8B-B14F-4D97-AF65-F5344CB8AC3E}">
-        <p14:creationId xmlns:p14="http://schemas.microsoft.com/office/powerpoint/2010/main" val="1650439861"/>
+        <p14:creationId xmlns:p14="http://schemas.microsoft.com/office/powerpoint/2010/main" val="1832177520"/>
       </p:ext>
     </p:extLst>
   </p:cSld>
@@ -12878,7 +12878,7 @@
           <p:cNvPr id="61" name="Google Shape;61;p14">
             <a:extLst xmlns:a="http://schemas.openxmlformats.org/drawingml/2006/main">
               <a:ext uri="{FF2B5EF4-FFF2-40B4-BE49-F238E27FC236}">
-                <a16:creationId xmlns:a16="http://schemas.microsoft.com/office/drawing/2014/main" id="{5BB6A2CD-A25D-4216-8E47-4218AE6659B9}"/>
+                <a16:creationId xmlns:a16="http://schemas.microsoft.com/office/drawing/2014/main" id="{D64BB5AC-351B-4B07-8AB3-6B0423FF9DE9}"/>
               </a:ext>
             </a:extLst>
           </p:cNvPr>
@@ -12888,7 +12888,7 @@
           <p:nvPr/>
         </p:nvPicPr>
         <p:blipFill rotWithShape="1">
-          <a:blip xmlns:r="http://schemas.openxmlformats.org/officeDocument/2006/relationships" xmlns:a="http://schemas.openxmlformats.org/drawingml/2006/main" r:embed="R1b15c1c0dea645ae">
+          <a:blip xmlns:r="http://schemas.openxmlformats.org/officeDocument/2006/relationships" xmlns:a="http://schemas.openxmlformats.org/drawingml/2006/main" r:embed="Rc156c4ebc1854e3e">
             <a:alphaModFix/>
           </a:blip>
           <a:srcRect xmlns:a="http://schemas.openxmlformats.org/drawingml/2006/main" l="0" t="0" r="0" b="98001"/>
@@ -12912,7 +12912,7 @@
           <p:cNvPr id="62" name="Google Shape;62;p14">
             <a:extLst xmlns:a="http://schemas.openxmlformats.org/drawingml/2006/main">
               <a:ext uri="{FF2B5EF4-FFF2-40B4-BE49-F238E27FC236}">
-                <a16:creationId xmlns:a16="http://schemas.microsoft.com/office/drawing/2014/main" id="{D4E1ACDA-513E-468D-AFDB-8AFAD56B6FEF}"/>
+                <a16:creationId xmlns:a16="http://schemas.microsoft.com/office/drawing/2014/main" id="{096EA0DD-0EF8-4CD5-8A20-9137E270C22F}"/>
               </a:ext>
             </a:extLst>
           </p:cNvPr>
@@ -12963,7 +12963,7 @@
           <p:cNvPr id="63" name="Google Shape;63;p14">
             <a:extLst xmlns:a="http://schemas.openxmlformats.org/drawingml/2006/main">
               <a:ext uri="{FF2B5EF4-FFF2-40B4-BE49-F238E27FC236}">
-                <a16:creationId xmlns:a16="http://schemas.microsoft.com/office/drawing/2014/main" id="{6F7DAA71-CF54-488C-AFEA-2D9310D842A7}"/>
+                <a16:creationId xmlns:a16="http://schemas.microsoft.com/office/drawing/2014/main" id="{6ABB7602-A141-4CD4-8DC3-D4F2A8EB9A4A}"/>
               </a:ext>
             </a:extLst>
           </p:cNvPr>
@@ -13091,7 +13091,7 @@
           <p:cNvPr id="64" name="Google Shape;64;p14">
             <a:extLst xmlns:a="http://schemas.openxmlformats.org/drawingml/2006/main">
               <a:ext uri="{FF2B5EF4-FFF2-40B4-BE49-F238E27FC236}">
-                <a16:creationId xmlns:a16="http://schemas.microsoft.com/office/drawing/2014/main" id="{3C4BC159-F875-47C7-99B4-3B73AA9323B8}"/>
+                <a16:creationId xmlns:a16="http://schemas.microsoft.com/office/drawing/2014/main" id="{C7F91E4E-E0FF-4973-BF08-B51D1CC545F4}"/>
               </a:ext>
             </a:extLst>
           </p:cNvPr>
@@ -13101,7 +13101,7 @@
           <p:nvPr/>
         </p:nvPicPr>
         <p:blipFill>
-          <a:blip xmlns:r="http://schemas.openxmlformats.org/officeDocument/2006/relationships" xmlns:a="http://schemas.openxmlformats.org/drawingml/2006/main" r:embed="Rc5b5a64f090248c0">
+          <a:blip xmlns:r="http://schemas.openxmlformats.org/officeDocument/2006/relationships" xmlns:a="http://schemas.openxmlformats.org/drawingml/2006/main" r:embed="R76b3066cba87476d">
             <a:alphaModFix/>
           </a:blip>
           <a:stretch xmlns:a="http://schemas.openxmlformats.org/drawingml/2006/main">
@@ -13131,7 +13131,7 @@
     </p:spTree>
     <p:extLst>
       <p:ext uri="{BB962C8B-B14F-4D97-AF65-F5344CB8AC3E}">
-        <p14:creationId xmlns:p14="http://schemas.microsoft.com/office/powerpoint/2010/main" val="1570871567"/>
+        <p14:creationId xmlns:p14="http://schemas.microsoft.com/office/powerpoint/2010/main" val="428674270"/>
       </p:ext>
     </p:extLst>
   </p:cSld>
@@ -13155,7 +13155,7 @@
           <p:cNvPr id="69" name="Google Shape;69;p15">
             <a:extLst xmlns:a="http://schemas.openxmlformats.org/drawingml/2006/main">
               <a:ext uri="{FF2B5EF4-FFF2-40B4-BE49-F238E27FC236}">
-                <a16:creationId xmlns:a16="http://schemas.microsoft.com/office/drawing/2014/main" id="{1426E7A7-D38B-42C0-9716-90E78086A597}"/>
+                <a16:creationId xmlns:a16="http://schemas.microsoft.com/office/drawing/2014/main" id="{6DE20F31-8ED6-4BCC-AA55-BA293828C931}"/>
               </a:ext>
             </a:extLst>
           </p:cNvPr>
@@ -13165,7 +13165,7 @@
           <p:nvPr/>
         </p:nvPicPr>
         <p:blipFill>
-          <a:blip xmlns:r="http://schemas.openxmlformats.org/officeDocument/2006/relationships" xmlns:a="http://schemas.openxmlformats.org/drawingml/2006/main" r:embed="Re9ef2acb7e6f48d5">
+          <a:blip xmlns:r="http://schemas.openxmlformats.org/officeDocument/2006/relationships" xmlns:a="http://schemas.openxmlformats.org/drawingml/2006/main" r:embed="Rfbc90121c8134291">
             <a:alphaModFix/>
           </a:blip>
           <a:stretch xmlns:a="http://schemas.openxmlformats.org/drawingml/2006/main">
@@ -13190,7 +13190,7 @@
           <p:cNvPr id="70" name="Google Shape;70;p15">
             <a:extLst xmlns:a="http://schemas.openxmlformats.org/drawingml/2006/main">
               <a:ext uri="{FF2B5EF4-FFF2-40B4-BE49-F238E27FC236}">
-                <a16:creationId xmlns:a16="http://schemas.microsoft.com/office/drawing/2014/main" id="{0D377E49-BF76-4F6B-85EC-085754B243A3}"/>
+                <a16:creationId xmlns:a16="http://schemas.microsoft.com/office/drawing/2014/main" id="{F76B714D-D1B5-46F9-8370-A661A594AAF9}"/>
               </a:ext>
             </a:extLst>
           </p:cNvPr>
@@ -13241,7 +13241,7 @@
           <p:cNvPr id="71" name="Google Shape;71;p15">
             <a:extLst xmlns:a="http://schemas.openxmlformats.org/drawingml/2006/main">
               <a:ext uri="{FF2B5EF4-FFF2-40B4-BE49-F238E27FC236}">
-                <a16:creationId xmlns:a16="http://schemas.microsoft.com/office/drawing/2014/main" id="{B24CDA3D-528F-4843-B405-DDFE0FDBB6EA}"/>
+                <a16:creationId xmlns:a16="http://schemas.microsoft.com/office/drawing/2014/main" id="{1A541959-0BBB-4E54-90FF-F6F91A8D8521}"/>
               </a:ext>
             </a:extLst>
           </p:cNvPr>
@@ -13321,7 +13321,7 @@
           <p:cNvPr id="72" name="">
             <a:extLst xmlns:a="http://schemas.openxmlformats.org/drawingml/2006/main">
               <a:ext uri="{FF2B5EF4-FFF2-40B4-BE49-F238E27FC236}">
-                <a16:creationId xmlns:a16="http://schemas.microsoft.com/office/drawing/2014/main" id="{ED55FB5C-0A96-4747-BDE8-00888B73EAC7}"/>
+                <a16:creationId xmlns:a16="http://schemas.microsoft.com/office/drawing/2014/main" id="{DAE7EADC-5811-49D7-B47F-3F3C35E978D1}"/>
               </a:ext>
             </a:extLst>
           </p:cNvPr>
@@ -13389,7 +13389,7 @@
           <p:cNvPr id="73" name="">
             <a:extLst xmlns:a="http://schemas.openxmlformats.org/drawingml/2006/main">
               <a:ext uri="{FF2B5EF4-FFF2-40B4-BE49-F238E27FC236}">
-                <a16:creationId xmlns:a16="http://schemas.microsoft.com/office/drawing/2014/main" id="{FC8EACAC-85B5-4DF3-80DB-783668CFF506}"/>
+                <a16:creationId xmlns:a16="http://schemas.microsoft.com/office/drawing/2014/main" id="{0DC57B15-AB94-446E-9B30-3A706D83E826}"/>
               </a:ext>
             </a:extLst>
           </p:cNvPr>
@@ -13457,7 +13457,7 @@
           <p:cNvPr id="74" name="">
             <a:extLst xmlns:a="http://schemas.openxmlformats.org/drawingml/2006/main">
               <a:ext uri="{FF2B5EF4-FFF2-40B4-BE49-F238E27FC236}">
-                <a16:creationId xmlns:a16="http://schemas.microsoft.com/office/drawing/2014/main" id="{2A38490E-604D-4D54-82DE-B3CAB4342008}"/>
+                <a16:creationId xmlns:a16="http://schemas.microsoft.com/office/drawing/2014/main" id="{3599A344-19AC-4B31-8F6D-FECDEB63B99C}"/>
               </a:ext>
             </a:extLst>
           </p:cNvPr>
@@ -13525,7 +13525,7 @@
           <p:cNvPr id="75" name="">
             <a:extLst xmlns:a="http://schemas.openxmlformats.org/drawingml/2006/main">
               <a:ext uri="{FF2B5EF4-FFF2-40B4-BE49-F238E27FC236}">
-                <a16:creationId xmlns:a16="http://schemas.microsoft.com/office/drawing/2014/main" id="{8FFB0A61-5899-4146-94EB-0037443F6070}"/>
+                <a16:creationId xmlns:a16="http://schemas.microsoft.com/office/drawing/2014/main" id="{8DD4CFBF-C8BC-41A6-8DDC-B04577D97708}"/>
               </a:ext>
             </a:extLst>
           </p:cNvPr>
@@ -13593,7 +13593,7 @@
           <p:cNvPr id="76" name="">
             <a:extLst xmlns:a="http://schemas.openxmlformats.org/drawingml/2006/main">
               <a:ext uri="{FF2B5EF4-FFF2-40B4-BE49-F238E27FC236}">
-                <a16:creationId xmlns:a16="http://schemas.microsoft.com/office/drawing/2014/main" id="{00A4AD23-7AB7-44C0-BD04-15CBAC41BC65}"/>
+                <a16:creationId xmlns:a16="http://schemas.microsoft.com/office/drawing/2014/main" id="{2455EAD5-ADB8-4823-A2B9-C263320FC7D7}"/>
               </a:ext>
             </a:extLst>
           </p:cNvPr>
@@ -13603,7 +13603,7 @@
           <p:nvPr/>
         </p:nvPicPr>
         <p:blipFill>
-          <a:blip xmlns:r="http://schemas.openxmlformats.org/officeDocument/2006/relationships" xmlns:a="http://schemas.openxmlformats.org/drawingml/2006/main" r:embed="R6d3dadb7f30c47b8"/>
+          <a:blip xmlns:r="http://schemas.openxmlformats.org/officeDocument/2006/relationships" xmlns:a="http://schemas.openxmlformats.org/drawingml/2006/main" r:embed="Rfe5b66c1787e440b"/>
           <a:stretch xmlns:a="http://schemas.openxmlformats.org/drawingml/2006/main"/>
         </p:blipFill>
         <p:spPr>
@@ -13621,7 +13621,7 @@
           <p:cNvPr id="77" name="">
             <a:extLst xmlns:a="http://schemas.openxmlformats.org/drawingml/2006/main">
               <a:ext uri="{FF2B5EF4-FFF2-40B4-BE49-F238E27FC236}">
-                <a16:creationId xmlns:a16="http://schemas.microsoft.com/office/drawing/2014/main" id="{33328776-8203-4CFE-BC75-E71124E1DE30}"/>
+                <a16:creationId xmlns:a16="http://schemas.microsoft.com/office/drawing/2014/main" id="{329AAB9D-61B1-4D05-A82F-403E976E0600}"/>
               </a:ext>
             </a:extLst>
           </p:cNvPr>
@@ -13689,7 +13689,7 @@
           <p:cNvPr id="78" name="">
             <a:extLst xmlns:a="http://schemas.openxmlformats.org/drawingml/2006/main">
               <a:ext uri="{FF2B5EF4-FFF2-40B4-BE49-F238E27FC236}">
-                <a16:creationId xmlns:a16="http://schemas.microsoft.com/office/drawing/2014/main" id="{599DECA1-E6DF-498F-979D-259874ABC68B}"/>
+                <a16:creationId xmlns:a16="http://schemas.microsoft.com/office/drawing/2014/main" id="{ADF4C071-2C19-4E42-A941-20D4FEE772CF}"/>
               </a:ext>
             </a:extLst>
           </p:cNvPr>
@@ -13755,7 +13755,7 @@
     </p:spTree>
     <p:extLst>
       <p:ext uri="{BB962C8B-B14F-4D97-AF65-F5344CB8AC3E}">
-        <p14:creationId xmlns:p14="http://schemas.microsoft.com/office/powerpoint/2010/main" val="636371927"/>
+        <p14:creationId xmlns:p14="http://schemas.microsoft.com/office/powerpoint/2010/main" val="1433517616"/>
       </p:ext>
     </p:extLst>
   </p:cSld>
@@ -13779,7 +13779,7 @@
           <p:cNvPr id="76" name="Google Shape;76;p16">
             <a:extLst xmlns:a="http://schemas.openxmlformats.org/drawingml/2006/main">
               <a:ext uri="{FF2B5EF4-FFF2-40B4-BE49-F238E27FC236}">
-                <a16:creationId xmlns:a16="http://schemas.microsoft.com/office/drawing/2014/main" id="{5D53FE96-0D59-4D84-918F-39FE53329632}"/>
+                <a16:creationId xmlns:a16="http://schemas.microsoft.com/office/drawing/2014/main" id="{F51D850F-4E55-427F-BBE5-F1E5CD3F443E}"/>
               </a:ext>
             </a:extLst>
           </p:cNvPr>
@@ -13789,7 +13789,7 @@
           <p:nvPr/>
         </p:nvPicPr>
         <p:blipFill rotWithShape="1">
-          <a:blip xmlns:r="http://schemas.openxmlformats.org/officeDocument/2006/relationships" xmlns:a="http://schemas.openxmlformats.org/drawingml/2006/main" r:embed="R45a648da2b1d4aae">
+          <a:blip xmlns:r="http://schemas.openxmlformats.org/officeDocument/2006/relationships" xmlns:a="http://schemas.openxmlformats.org/drawingml/2006/main" r:embed="Rc84d9b0583c74447">
             <a:alphaModFix/>
           </a:blip>
           <a:srcRect xmlns:a="http://schemas.openxmlformats.org/drawingml/2006/main" l="0" t="0" r="0" b="98001"/>
@@ -13813,7 +13813,7 @@
           <p:cNvPr id="77" name="Google Shape;77;p16">
             <a:extLst xmlns:a="http://schemas.openxmlformats.org/drawingml/2006/main">
               <a:ext uri="{FF2B5EF4-FFF2-40B4-BE49-F238E27FC236}">
-                <a16:creationId xmlns:a16="http://schemas.microsoft.com/office/drawing/2014/main" id="{CB976E37-26EF-44E6-BCC5-39329E7B3E03}"/>
+                <a16:creationId xmlns:a16="http://schemas.microsoft.com/office/drawing/2014/main" id="{43AAB0CB-C0A2-4E9E-9930-7D9679D38188}"/>
               </a:ext>
             </a:extLst>
           </p:cNvPr>
@@ -13823,7 +13823,7 @@
           <p:nvPr/>
         </p:nvPicPr>
         <p:blipFill>
-          <a:blip xmlns:r="http://schemas.openxmlformats.org/officeDocument/2006/relationships" xmlns:a="http://schemas.openxmlformats.org/drawingml/2006/main" r:embed="Rc371b0b000274c64">
+          <a:blip xmlns:r="http://schemas.openxmlformats.org/officeDocument/2006/relationships" xmlns:a="http://schemas.openxmlformats.org/drawingml/2006/main" r:embed="Rcea386a5c27e468a">
             <a:alphaModFix/>
           </a:blip>
           <a:stretch xmlns:a="http://schemas.openxmlformats.org/drawingml/2006/main">
@@ -13848,7 +13848,7 @@
           <p:cNvPr id="78" name="Google Shape;78;p16">
             <a:extLst xmlns:a="http://schemas.openxmlformats.org/drawingml/2006/main">
               <a:ext uri="{FF2B5EF4-FFF2-40B4-BE49-F238E27FC236}">
-                <a16:creationId xmlns:a16="http://schemas.microsoft.com/office/drawing/2014/main" id="{E2546498-CC3B-4081-9E23-20CFFB757AB1}"/>
+                <a16:creationId xmlns:a16="http://schemas.microsoft.com/office/drawing/2014/main" id="{09DD59E8-2256-4A21-B5A7-C1FF73C51517}"/>
               </a:ext>
             </a:extLst>
           </p:cNvPr>
@@ -13899,7 +13899,7 @@
           <p:cNvPr id="79" name="Google Shape;79;p16">
             <a:extLst xmlns:a="http://schemas.openxmlformats.org/drawingml/2006/main">
               <a:ext uri="{FF2B5EF4-FFF2-40B4-BE49-F238E27FC236}">
-                <a16:creationId xmlns:a16="http://schemas.microsoft.com/office/drawing/2014/main" id="{F77454C5-A27B-4ABB-82B2-29AFA7C42B7A}"/>
+                <a16:creationId xmlns:a16="http://schemas.microsoft.com/office/drawing/2014/main" id="{40C10B6F-2C42-4D19-9ABB-D1137FD45EB2}"/>
               </a:ext>
             </a:extLst>
           </p:cNvPr>
@@ -13979,7 +13979,7 @@
           <p:cNvPr id="80" name="">
             <a:extLst xmlns:a="http://schemas.openxmlformats.org/drawingml/2006/main">
               <a:ext uri="{FF2B5EF4-FFF2-40B4-BE49-F238E27FC236}">
-                <a16:creationId xmlns:a16="http://schemas.microsoft.com/office/drawing/2014/main" id="{8AE59DF3-8E73-49A5-94F5-7876A0CA3CE1}"/>
+                <a16:creationId xmlns:a16="http://schemas.microsoft.com/office/drawing/2014/main" id="{4BD95317-7CBF-4D7B-9826-3AB4863B1AAB}"/>
               </a:ext>
             </a:extLst>
           </p:cNvPr>
@@ -14047,7 +14047,7 @@
           <p:cNvPr id="81" name="">
             <a:extLst xmlns:a="http://schemas.openxmlformats.org/drawingml/2006/main">
               <a:ext uri="{FF2B5EF4-FFF2-40B4-BE49-F238E27FC236}">
-                <a16:creationId xmlns:a16="http://schemas.microsoft.com/office/drawing/2014/main" id="{53154058-E2C7-4AC5-A404-6BBF31810033}"/>
+                <a16:creationId xmlns:a16="http://schemas.microsoft.com/office/drawing/2014/main" id="{F4E41496-0CF9-489C-8980-AE1DFFDA1B03}"/>
               </a:ext>
             </a:extLst>
           </p:cNvPr>
@@ -14115,7 +14115,7 @@
           <p:cNvPr id="82" name="">
             <a:extLst xmlns:a="http://schemas.openxmlformats.org/drawingml/2006/main">
               <a:ext uri="{FF2B5EF4-FFF2-40B4-BE49-F238E27FC236}">
-                <a16:creationId xmlns:a16="http://schemas.microsoft.com/office/drawing/2014/main" id="{2586F22F-9950-40B9-8570-BE05ECC34E79}"/>
+                <a16:creationId xmlns:a16="http://schemas.microsoft.com/office/drawing/2014/main" id="{F24D3DD4-8D3B-44CD-B2E8-2459501D55C0}"/>
               </a:ext>
             </a:extLst>
           </p:cNvPr>
@@ -14183,7 +14183,7 @@
           <p:cNvPr id="83" name="">
             <a:extLst xmlns:a="http://schemas.openxmlformats.org/drawingml/2006/main">
               <a:ext uri="{FF2B5EF4-FFF2-40B4-BE49-F238E27FC236}">
-                <a16:creationId xmlns:a16="http://schemas.microsoft.com/office/drawing/2014/main" id="{1CA47DC0-06A2-456F-BD42-663554553622}"/>
+                <a16:creationId xmlns:a16="http://schemas.microsoft.com/office/drawing/2014/main" id="{04CF9C5D-401F-478A-B204-BEE1757FD54F}"/>
               </a:ext>
             </a:extLst>
           </p:cNvPr>
@@ -14251,7 +14251,7 @@
           <p:cNvPr id="84" name="">
             <a:extLst xmlns:a="http://schemas.openxmlformats.org/drawingml/2006/main">
               <a:ext uri="{FF2B5EF4-FFF2-40B4-BE49-F238E27FC236}">
-                <a16:creationId xmlns:a16="http://schemas.microsoft.com/office/drawing/2014/main" id="{84ED998D-A6B6-4038-A621-D9D0C8E66D2D}"/>
+                <a16:creationId xmlns:a16="http://schemas.microsoft.com/office/drawing/2014/main" id="{0564CE18-28FB-4CF3-91DE-E537166041C5}"/>
               </a:ext>
             </a:extLst>
           </p:cNvPr>
@@ -14319,7 +14319,7 @@
           <p:cNvPr id="85" name="">
             <a:extLst xmlns:a="http://schemas.openxmlformats.org/drawingml/2006/main">
               <a:ext uri="{FF2B5EF4-FFF2-40B4-BE49-F238E27FC236}">
-                <a16:creationId xmlns:a16="http://schemas.microsoft.com/office/drawing/2014/main" id="{6AB62C5F-11CE-482D-A38D-417866636A97}"/>
+                <a16:creationId xmlns:a16="http://schemas.microsoft.com/office/drawing/2014/main" id="{5E5DE043-EE0D-4A4F-AD62-CBFDAABEB44F}"/>
               </a:ext>
             </a:extLst>
           </p:cNvPr>
@@ -14387,7 +14387,7 @@
           <p:cNvPr id="86" name="">
             <a:extLst xmlns:a="http://schemas.openxmlformats.org/drawingml/2006/main">
               <a:ext uri="{FF2B5EF4-FFF2-40B4-BE49-F238E27FC236}">
-                <a16:creationId xmlns:a16="http://schemas.microsoft.com/office/drawing/2014/main" id="{7401B158-D13C-4171-8F24-485E7A1148BC}"/>
+                <a16:creationId xmlns:a16="http://schemas.microsoft.com/office/drawing/2014/main" id="{9A2B0AE6-4038-4FDC-9045-F816E599AA99}"/>
               </a:ext>
             </a:extLst>
           </p:cNvPr>
@@ -14455,7 +14455,7 @@
           <p:cNvPr id="87" name="">
             <a:extLst xmlns:a="http://schemas.openxmlformats.org/drawingml/2006/main">
               <a:ext uri="{FF2B5EF4-FFF2-40B4-BE49-F238E27FC236}">
-                <a16:creationId xmlns:a16="http://schemas.microsoft.com/office/drawing/2014/main" id="{6FFB844F-3F93-4ED8-8DDF-CCE3C5C3952F}"/>
+                <a16:creationId xmlns:a16="http://schemas.microsoft.com/office/drawing/2014/main" id="{C05B1633-CBAE-4B9A-ABD4-49302D092856}"/>
               </a:ext>
             </a:extLst>
           </p:cNvPr>
@@ -14521,7 +14521,7 @@
     </p:spTree>
     <p:extLst>
       <p:ext uri="{BB962C8B-B14F-4D97-AF65-F5344CB8AC3E}">
-        <p14:creationId xmlns:p14="http://schemas.microsoft.com/office/powerpoint/2010/main" val="957823106"/>
+        <p14:creationId xmlns:p14="http://schemas.microsoft.com/office/powerpoint/2010/main" val="502935201"/>
       </p:ext>
     </p:extLst>
   </p:cSld>
@@ -14545,7 +14545,7 @@
           <p:cNvPr id="84" name="Google Shape;84;p17">
             <a:extLst xmlns:a="http://schemas.openxmlformats.org/drawingml/2006/main">
               <a:ext uri="{FF2B5EF4-FFF2-40B4-BE49-F238E27FC236}">
-                <a16:creationId xmlns:a16="http://schemas.microsoft.com/office/drawing/2014/main" id="{B12103D1-F48E-42BF-8624-3B72678032BF}"/>
+                <a16:creationId xmlns:a16="http://schemas.microsoft.com/office/drawing/2014/main" id="{6FF60019-BC16-492A-B882-86DDA8891AF1}"/>
               </a:ext>
             </a:extLst>
           </p:cNvPr>
@@ -14555,7 +14555,7 @@
           <p:nvPr/>
         </p:nvPicPr>
         <p:blipFill rotWithShape="1">
-          <a:blip xmlns:r="http://schemas.openxmlformats.org/officeDocument/2006/relationships" xmlns:a="http://schemas.openxmlformats.org/drawingml/2006/main" r:embed="R93f053c542d140d9">
+          <a:blip xmlns:r="http://schemas.openxmlformats.org/officeDocument/2006/relationships" xmlns:a="http://schemas.openxmlformats.org/drawingml/2006/main" r:embed="R0514b65b39614550">
             <a:alphaModFix/>
           </a:blip>
           <a:srcRect xmlns:a="http://schemas.openxmlformats.org/drawingml/2006/main" l="0" t="0" r="0" b="98001"/>
@@ -14579,7 +14579,7 @@
           <p:cNvPr id="85" name="Google Shape;85;p17">
             <a:extLst xmlns:a="http://schemas.openxmlformats.org/drawingml/2006/main">
               <a:ext uri="{FF2B5EF4-FFF2-40B4-BE49-F238E27FC236}">
-                <a16:creationId xmlns:a16="http://schemas.microsoft.com/office/drawing/2014/main" id="{268D2047-A4AC-46EA-804B-94490973B020}"/>
+                <a16:creationId xmlns:a16="http://schemas.microsoft.com/office/drawing/2014/main" id="{F1A01E14-88C7-4F34-94AB-C0CA91CDE737}"/>
               </a:ext>
             </a:extLst>
           </p:cNvPr>
@@ -14589,7 +14589,7 @@
           <p:nvPr/>
         </p:nvPicPr>
         <p:blipFill>
-          <a:blip xmlns:r="http://schemas.openxmlformats.org/officeDocument/2006/relationships" xmlns:a="http://schemas.openxmlformats.org/drawingml/2006/main" r:embed="Rde6d4b1af24f43fc">
+          <a:blip xmlns:r="http://schemas.openxmlformats.org/officeDocument/2006/relationships" xmlns:a="http://schemas.openxmlformats.org/drawingml/2006/main" r:embed="R12c67f9e05ac42e2">
             <a:alphaModFix/>
           </a:blip>
           <a:stretch xmlns:a="http://schemas.openxmlformats.org/drawingml/2006/main">
@@ -14614,7 +14614,7 @@
           <p:cNvPr id="86" name="Google Shape;86;p17">
             <a:extLst xmlns:a="http://schemas.openxmlformats.org/drawingml/2006/main">
               <a:ext uri="{FF2B5EF4-FFF2-40B4-BE49-F238E27FC236}">
-                <a16:creationId xmlns:a16="http://schemas.microsoft.com/office/drawing/2014/main" id="{B920BDBC-E86C-455C-8892-674CE0CAAAF2}"/>
+                <a16:creationId xmlns:a16="http://schemas.microsoft.com/office/drawing/2014/main" id="{B0AF72F6-7B9B-450C-A918-658227F8BC7C}"/>
               </a:ext>
             </a:extLst>
           </p:cNvPr>
@@ -14665,7 +14665,7 @@
           <p:cNvPr id="87" name="Google Shape;87;p17">
             <a:extLst xmlns:a="http://schemas.openxmlformats.org/drawingml/2006/main">
               <a:ext uri="{FF2B5EF4-FFF2-40B4-BE49-F238E27FC236}">
-                <a16:creationId xmlns:a16="http://schemas.microsoft.com/office/drawing/2014/main" id="{F6DC0EFE-E193-42EE-99B2-3C4BAB84B710}"/>
+                <a16:creationId xmlns:a16="http://schemas.microsoft.com/office/drawing/2014/main" id="{022CB3D9-726B-4E03-88C5-D309097A9035}"/>
               </a:ext>
             </a:extLst>
           </p:cNvPr>
@@ -14745,7 +14745,7 @@
           <p:cNvPr id="88" name="">
             <a:extLst xmlns:a="http://schemas.openxmlformats.org/drawingml/2006/main">
               <a:ext uri="{FF2B5EF4-FFF2-40B4-BE49-F238E27FC236}">
-                <a16:creationId xmlns:a16="http://schemas.microsoft.com/office/drawing/2014/main" id="{8B2EC7BC-60EB-4FC0-B979-E8D5CD2E2B56}"/>
+                <a16:creationId xmlns:a16="http://schemas.microsoft.com/office/drawing/2014/main" id="{2997EE02-1F25-4C11-BBCB-F668E5A453E8}"/>
               </a:ext>
             </a:extLst>
           </p:cNvPr>
@@ -14952,7 +14952,7 @@
           <p:cNvPr id="89" name="">
             <a:extLst xmlns:a="http://schemas.openxmlformats.org/drawingml/2006/main">
               <a:ext uri="{FF2B5EF4-FFF2-40B4-BE49-F238E27FC236}">
-                <a16:creationId xmlns:a16="http://schemas.microsoft.com/office/drawing/2014/main" id="{79FD3A7B-968A-42AC-933F-D4C89D724305}"/>
+                <a16:creationId xmlns:a16="http://schemas.microsoft.com/office/drawing/2014/main" id="{98C8D240-F6D1-47AA-938A-54ECAC91D65A}"/>
               </a:ext>
             </a:extLst>
           </p:cNvPr>
@@ -15020,7 +15020,7 @@
           <p:cNvPr id="90" name="">
             <a:extLst xmlns:a="http://schemas.openxmlformats.org/drawingml/2006/main">
               <a:ext uri="{FF2B5EF4-FFF2-40B4-BE49-F238E27FC236}">
-                <a16:creationId xmlns:a16="http://schemas.microsoft.com/office/drawing/2014/main" id="{DC73607D-B563-4BDB-8115-2D146F9B3D46}"/>
+                <a16:creationId xmlns:a16="http://schemas.microsoft.com/office/drawing/2014/main" id="{05D11918-BCD1-4721-A439-D70A627E8515}"/>
               </a:ext>
             </a:extLst>
           </p:cNvPr>
@@ -15086,7 +15086,7 @@
     </p:spTree>
     <p:extLst>
       <p:ext uri="{BB962C8B-B14F-4D97-AF65-F5344CB8AC3E}">
-        <p14:creationId xmlns:p14="http://schemas.microsoft.com/office/powerpoint/2010/main" val="479200512"/>
+        <p14:creationId xmlns:p14="http://schemas.microsoft.com/office/powerpoint/2010/main" val="304517301"/>
       </p:ext>
     </p:extLst>
   </p:cSld>
@@ -15110,7 +15110,7 @@
           <p:cNvPr id="106" name="">
             <a:extLst xmlns:a="http://schemas.openxmlformats.org/drawingml/2006/main">
               <a:ext uri="{FF2B5EF4-FFF2-40B4-BE49-F238E27FC236}">
-                <a16:creationId xmlns:a16="http://schemas.microsoft.com/office/drawing/2014/main" id="{76437B3A-5C22-4250-8757-CEBA4CCFDC26}"/>
+                <a16:creationId xmlns:a16="http://schemas.microsoft.com/office/drawing/2014/main" id="{769C32C2-4511-4F13-A80C-F57798E6C8BB}"/>
               </a:ext>
             </a:extLst>
           </p:cNvPr>
@@ -15141,7 +15141,7 @@
           <p:cNvPr id="105" name="">
             <a:extLst xmlns:a="http://schemas.openxmlformats.org/drawingml/2006/main">
               <a:ext uri="{FF2B5EF4-FFF2-40B4-BE49-F238E27FC236}">
-                <a16:creationId xmlns:a16="http://schemas.microsoft.com/office/drawing/2014/main" id="{4015AF4E-59B0-4068-A809-034BD52BB910}"/>
+                <a16:creationId xmlns:a16="http://schemas.microsoft.com/office/drawing/2014/main" id="{D4313A8E-97BF-4C1E-AA03-1EDFD362C81C}"/>
               </a:ext>
             </a:extLst>
           </p:cNvPr>
@@ -15172,7 +15172,7 @@
           <p:cNvPr id="104" name="">
             <a:extLst xmlns:a="http://schemas.openxmlformats.org/drawingml/2006/main">
               <a:ext uri="{FF2B5EF4-FFF2-40B4-BE49-F238E27FC236}">
-                <a16:creationId xmlns:a16="http://schemas.microsoft.com/office/drawing/2014/main" id="{704057E8-0847-4E27-8E69-A7D4FE67DC99}"/>
+                <a16:creationId xmlns:a16="http://schemas.microsoft.com/office/drawing/2014/main" id="{3990C402-4E64-4AA6-8927-560BF5EFAEFD}"/>
               </a:ext>
             </a:extLst>
           </p:cNvPr>
@@ -15203,7 +15203,7 @@
           <p:cNvPr id="100" name="">
             <a:extLst xmlns:a="http://schemas.openxmlformats.org/drawingml/2006/main">
               <a:ext uri="{FF2B5EF4-FFF2-40B4-BE49-F238E27FC236}">
-                <a16:creationId xmlns:a16="http://schemas.microsoft.com/office/drawing/2014/main" id="{F0136D48-FCF0-4030-AA2F-1B9BB8F9984A}"/>
+                <a16:creationId xmlns:a16="http://schemas.microsoft.com/office/drawing/2014/main" id="{9CBB09C7-B228-4775-BA3A-A90BCC3B041E}"/>
               </a:ext>
             </a:extLst>
           </p:cNvPr>
@@ -15234,7 +15234,7 @@
           <p:cNvPr id="99" name="">
             <a:extLst xmlns:a="http://schemas.openxmlformats.org/drawingml/2006/main">
               <a:ext uri="{FF2B5EF4-FFF2-40B4-BE49-F238E27FC236}">
-                <a16:creationId xmlns:a16="http://schemas.microsoft.com/office/drawing/2014/main" id="{54634E5D-B765-4D09-8E64-9CDE32318FEF}"/>
+                <a16:creationId xmlns:a16="http://schemas.microsoft.com/office/drawing/2014/main" id="{5F4FEACA-3349-4C91-939D-DE5095E69E2E}"/>
               </a:ext>
             </a:extLst>
           </p:cNvPr>
@@ -15265,7 +15265,7 @@
           <p:cNvPr id="92" name="Google Shape;92;p18">
             <a:extLst xmlns:a="http://schemas.openxmlformats.org/drawingml/2006/main">
               <a:ext uri="{FF2B5EF4-FFF2-40B4-BE49-F238E27FC236}">
-                <a16:creationId xmlns:a16="http://schemas.microsoft.com/office/drawing/2014/main" id="{6374B89F-2666-42DE-BD7A-0C9F9C1AF73A}"/>
+                <a16:creationId xmlns:a16="http://schemas.microsoft.com/office/drawing/2014/main" id="{E73D4098-5306-4BCC-9EAA-FF9230BFC94C}"/>
               </a:ext>
             </a:extLst>
           </p:cNvPr>
@@ -15275,7 +15275,7 @@
           <p:nvPr/>
         </p:nvPicPr>
         <p:blipFill rotWithShape="1">
-          <a:blip xmlns:r="http://schemas.openxmlformats.org/officeDocument/2006/relationships" xmlns:a="http://schemas.openxmlformats.org/drawingml/2006/main" r:embed="Re8d93fb4f0d04567">
+          <a:blip xmlns:r="http://schemas.openxmlformats.org/officeDocument/2006/relationships" xmlns:a="http://schemas.openxmlformats.org/drawingml/2006/main" r:embed="R7def2edac81147c6">
             <a:alphaModFix/>
           </a:blip>
           <a:srcRect xmlns:a="http://schemas.openxmlformats.org/drawingml/2006/main" l="0" t="0" r="0" b="98001"/>
@@ -15299,7 +15299,7 @@
           <p:cNvPr id="93" name="Google Shape;93;p18">
             <a:extLst xmlns:a="http://schemas.openxmlformats.org/drawingml/2006/main">
               <a:ext uri="{FF2B5EF4-FFF2-40B4-BE49-F238E27FC236}">
-                <a16:creationId xmlns:a16="http://schemas.microsoft.com/office/drawing/2014/main" id="{7A450C0C-DDC5-4479-B576-8DCD8F7BF18F}"/>
+                <a16:creationId xmlns:a16="http://schemas.microsoft.com/office/drawing/2014/main" id="{49697C2B-70B3-4ADA-939E-24C5E74A0326}"/>
               </a:ext>
             </a:extLst>
           </p:cNvPr>
@@ -15309,7 +15309,7 @@
           <p:nvPr/>
         </p:nvPicPr>
         <p:blipFill>
-          <a:blip xmlns:r="http://schemas.openxmlformats.org/officeDocument/2006/relationships" xmlns:a="http://schemas.openxmlformats.org/drawingml/2006/main" r:embed="Rcfb6a3a4d7ea4a0e">
+          <a:blip xmlns:r="http://schemas.openxmlformats.org/officeDocument/2006/relationships" xmlns:a="http://schemas.openxmlformats.org/drawingml/2006/main" r:embed="Rb3d764708820472f">
             <a:alphaModFix/>
           </a:blip>
           <a:stretch xmlns:a="http://schemas.openxmlformats.org/drawingml/2006/main">
@@ -15334,7 +15334,7 @@
           <p:cNvPr id="94" name="Google Shape;94;p18">
             <a:extLst xmlns:a="http://schemas.openxmlformats.org/drawingml/2006/main">
               <a:ext uri="{FF2B5EF4-FFF2-40B4-BE49-F238E27FC236}">
-                <a16:creationId xmlns:a16="http://schemas.microsoft.com/office/drawing/2014/main" id="{A364FF9F-995B-47CB-B2C0-C2A6B47D507F}"/>
+                <a16:creationId xmlns:a16="http://schemas.microsoft.com/office/drawing/2014/main" id="{3F24488D-B97C-4987-9277-0825237EA7AA}"/>
               </a:ext>
             </a:extLst>
           </p:cNvPr>
@@ -15385,7 +15385,7 @@
           <p:cNvPr id="95" name="Google Shape;95;p18">
             <a:extLst xmlns:a="http://schemas.openxmlformats.org/drawingml/2006/main">
               <a:ext uri="{FF2B5EF4-FFF2-40B4-BE49-F238E27FC236}">
-                <a16:creationId xmlns:a16="http://schemas.microsoft.com/office/drawing/2014/main" id="{5B2C53DB-98E5-46E8-B39E-0C71ECA9A6A5}"/>
+                <a16:creationId xmlns:a16="http://schemas.microsoft.com/office/drawing/2014/main" id="{D42FFE40-B808-40EC-9F19-01CEC1F8BF8B}"/>
               </a:ext>
             </a:extLst>
           </p:cNvPr>
@@ -15465,7 +15465,7 @@
           <p:cNvPr id="96" name="">
             <a:extLst xmlns:a="http://schemas.openxmlformats.org/drawingml/2006/main">
               <a:ext uri="{FF2B5EF4-FFF2-40B4-BE49-F238E27FC236}">
-                <a16:creationId xmlns:a16="http://schemas.microsoft.com/office/drawing/2014/main" id="{86C1406B-DB60-4358-AB22-54B8B031E45C}"/>
+                <a16:creationId xmlns:a16="http://schemas.microsoft.com/office/drawing/2014/main" id="{7034BEBD-64D8-4304-AA51-17A7F44064E5}"/>
               </a:ext>
             </a:extLst>
           </p:cNvPr>
@@ -15562,7 +15562,7 @@
           <p:cNvPr id="97" name="">
             <a:extLst xmlns:a="http://schemas.openxmlformats.org/drawingml/2006/main">
               <a:ext uri="{FF2B5EF4-FFF2-40B4-BE49-F238E27FC236}">
-                <a16:creationId xmlns:a16="http://schemas.microsoft.com/office/drawing/2014/main" id="{2E665448-D8A7-4CBA-9A92-6BF39F726FFB}"/>
+                <a16:creationId xmlns:a16="http://schemas.microsoft.com/office/drawing/2014/main" id="{3335569C-252A-4DCC-A8D7-FF58D556D5B0}"/>
               </a:ext>
             </a:extLst>
           </p:cNvPr>
@@ -15659,7 +15659,7 @@
           <p:cNvPr id="98" name="">
             <a:extLst xmlns:a="http://schemas.openxmlformats.org/drawingml/2006/main">
               <a:ext uri="{FF2B5EF4-FFF2-40B4-BE49-F238E27FC236}">
-                <a16:creationId xmlns:a16="http://schemas.microsoft.com/office/drawing/2014/main" id="{046D3BEB-1247-4A83-AC5F-7834FE78C0FB}"/>
+                <a16:creationId xmlns:a16="http://schemas.microsoft.com/office/drawing/2014/main" id="{660DB7C8-546E-473B-B69A-48E7974C2AC9}"/>
               </a:ext>
             </a:extLst>
           </p:cNvPr>
@@ -15756,7 +15756,7 @@
           <p:cNvPr id="101" name="">
             <a:extLst xmlns:a="http://schemas.openxmlformats.org/drawingml/2006/main">
               <a:ext uri="{FF2B5EF4-FFF2-40B4-BE49-F238E27FC236}">
-                <a16:creationId xmlns:a16="http://schemas.microsoft.com/office/drawing/2014/main" id="{B3E76024-2FA5-42EC-9906-06A0AF715B4E}"/>
+                <a16:creationId xmlns:a16="http://schemas.microsoft.com/office/drawing/2014/main" id="{8B2FD4B2-B236-496D-8EB5-D6AACD1F1DDC}"/>
               </a:ext>
             </a:extLst>
           </p:cNvPr>
@@ -15853,7 +15853,7 @@
           <p:cNvPr id="102" name="">
             <a:extLst xmlns:a="http://schemas.openxmlformats.org/drawingml/2006/main">
               <a:ext uri="{FF2B5EF4-FFF2-40B4-BE49-F238E27FC236}">
-                <a16:creationId xmlns:a16="http://schemas.microsoft.com/office/drawing/2014/main" id="{E936DF11-7F51-4934-B52D-DD58DE5FE93C}"/>
+                <a16:creationId xmlns:a16="http://schemas.microsoft.com/office/drawing/2014/main" id="{7F73CDD8-979B-4C4A-905A-974CF32CA583}"/>
               </a:ext>
             </a:extLst>
           </p:cNvPr>
@@ -15950,7 +15950,7 @@
           <p:cNvPr id="103" name="">
             <a:extLst xmlns:a="http://schemas.openxmlformats.org/drawingml/2006/main">
               <a:ext uri="{FF2B5EF4-FFF2-40B4-BE49-F238E27FC236}">
-                <a16:creationId xmlns:a16="http://schemas.microsoft.com/office/drawing/2014/main" id="{69ED51A0-20A6-495E-930C-C25FF883C62A}"/>
+                <a16:creationId xmlns:a16="http://schemas.microsoft.com/office/drawing/2014/main" id="{19AFC58F-D95F-4EAD-9C6B-5C3278A843D6}"/>
               </a:ext>
             </a:extLst>
           </p:cNvPr>
@@ -16047,7 +16047,7 @@
           <p:cNvPr id="107" name="">
             <a:extLst xmlns:a="http://schemas.openxmlformats.org/drawingml/2006/main">
               <a:ext uri="{FF2B5EF4-FFF2-40B4-BE49-F238E27FC236}">
-                <a16:creationId xmlns:a16="http://schemas.microsoft.com/office/drawing/2014/main" id="{60D716CD-60D4-449D-B9F2-E543EA9B14E3}"/>
+                <a16:creationId xmlns:a16="http://schemas.microsoft.com/office/drawing/2014/main" id="{332C296B-E3D4-424F-9936-7D904A94682C}"/>
               </a:ext>
             </a:extLst>
           </p:cNvPr>
@@ -16115,7 +16115,7 @@
           <p:cNvPr id="108" name="">
             <a:extLst xmlns:a="http://schemas.openxmlformats.org/drawingml/2006/main">
               <a:ext uri="{FF2B5EF4-FFF2-40B4-BE49-F238E27FC236}">
-                <a16:creationId xmlns:a16="http://schemas.microsoft.com/office/drawing/2014/main" id="{F783736D-7BA4-4FE5-A603-793B8EB430D4}"/>
+                <a16:creationId xmlns:a16="http://schemas.microsoft.com/office/drawing/2014/main" id="{9A0F2C5A-1696-42F4-800A-0B379573D866}"/>
               </a:ext>
             </a:extLst>
           </p:cNvPr>
@@ -16183,7 +16183,7 @@
           <p:cNvPr id="109" name="">
             <a:extLst xmlns:a="http://schemas.openxmlformats.org/drawingml/2006/main">
               <a:ext uri="{FF2B5EF4-FFF2-40B4-BE49-F238E27FC236}">
-                <a16:creationId xmlns:a16="http://schemas.microsoft.com/office/drawing/2014/main" id="{76F3000C-A1F3-49F2-B646-F07FBDA64E23}"/>
+                <a16:creationId xmlns:a16="http://schemas.microsoft.com/office/drawing/2014/main" id="{F5917CB2-FC5D-4B77-A2BA-8749C7CC1CB3}"/>
               </a:ext>
             </a:extLst>
           </p:cNvPr>
@@ -16249,7 +16249,7 @@
     </p:spTree>
     <p:extLst>
       <p:ext uri="{BB962C8B-B14F-4D97-AF65-F5344CB8AC3E}">
-        <p14:creationId xmlns:p14="http://schemas.microsoft.com/office/powerpoint/2010/main" val="713666589"/>
+        <p14:creationId xmlns:p14="http://schemas.microsoft.com/office/powerpoint/2010/main" val="1799457480"/>
       </p:ext>
     </p:extLst>
   </p:cSld>
@@ -16273,7 +16273,7 @@
           <p:cNvPr id="100" name="Google Shape;100;p19">
             <a:extLst xmlns:a="http://schemas.openxmlformats.org/drawingml/2006/main">
               <a:ext uri="{FF2B5EF4-FFF2-40B4-BE49-F238E27FC236}">
-                <a16:creationId xmlns:a16="http://schemas.microsoft.com/office/drawing/2014/main" id="{32DCD319-0B1D-4F4F-81F3-4F9A04E6B780}"/>
+                <a16:creationId xmlns:a16="http://schemas.microsoft.com/office/drawing/2014/main" id="{9A42581E-4C44-406A-994B-8031B6002388}"/>
               </a:ext>
             </a:extLst>
           </p:cNvPr>
@@ -16283,7 +16283,7 @@
           <p:nvPr/>
         </p:nvPicPr>
         <p:blipFill rotWithShape="1">
-          <a:blip xmlns:r="http://schemas.openxmlformats.org/officeDocument/2006/relationships" xmlns:a="http://schemas.openxmlformats.org/drawingml/2006/main" r:embed="Rc9199b30bea74473">
+          <a:blip xmlns:r="http://schemas.openxmlformats.org/officeDocument/2006/relationships" xmlns:a="http://schemas.openxmlformats.org/drawingml/2006/main" r:embed="R43d69dc84de34095">
             <a:alphaModFix/>
           </a:blip>
           <a:srcRect xmlns:a="http://schemas.openxmlformats.org/drawingml/2006/main" l="0" t="0" r="0" b="98001"/>
@@ -16307,7 +16307,7 @@
           <p:cNvPr id="101" name="Google Shape;101;p19">
             <a:extLst xmlns:a="http://schemas.openxmlformats.org/drawingml/2006/main">
               <a:ext uri="{FF2B5EF4-FFF2-40B4-BE49-F238E27FC236}">
-                <a16:creationId xmlns:a16="http://schemas.microsoft.com/office/drawing/2014/main" id="{8850692B-EBED-4DF9-BF02-B16C04B1B272}"/>
+                <a16:creationId xmlns:a16="http://schemas.microsoft.com/office/drawing/2014/main" id="{5E53EC82-3F84-4FC3-83CF-D123CA4252DB}"/>
               </a:ext>
             </a:extLst>
           </p:cNvPr>
@@ -16317,7 +16317,7 @@
           <p:nvPr/>
         </p:nvPicPr>
         <p:blipFill>
-          <a:blip xmlns:r="http://schemas.openxmlformats.org/officeDocument/2006/relationships" xmlns:a="http://schemas.openxmlformats.org/drawingml/2006/main" r:embed="R0abd3fb2b8044464">
+          <a:blip xmlns:r="http://schemas.openxmlformats.org/officeDocument/2006/relationships" xmlns:a="http://schemas.openxmlformats.org/drawingml/2006/main" r:embed="R88f16454233a4bbe">
             <a:alphaModFix/>
           </a:blip>
           <a:stretch xmlns:a="http://schemas.openxmlformats.org/drawingml/2006/main">
@@ -16342,7 +16342,7 @@
           <p:cNvPr id="102" name="Google Shape;102;p19">
             <a:extLst xmlns:a="http://schemas.openxmlformats.org/drawingml/2006/main">
               <a:ext uri="{FF2B5EF4-FFF2-40B4-BE49-F238E27FC236}">
-                <a16:creationId xmlns:a16="http://schemas.microsoft.com/office/drawing/2014/main" id="{90B0237D-DBCE-4B5C-839D-0D7295E0EF73}"/>
+                <a16:creationId xmlns:a16="http://schemas.microsoft.com/office/drawing/2014/main" id="{5446FB73-B4B6-41B4-8700-C29252BE3874}"/>
               </a:ext>
             </a:extLst>
           </p:cNvPr>
@@ -16393,7 +16393,7 @@
           <p:cNvPr id="103" name="Google Shape;103;p19">
             <a:extLst xmlns:a="http://schemas.openxmlformats.org/drawingml/2006/main">
               <a:ext uri="{FF2B5EF4-FFF2-40B4-BE49-F238E27FC236}">
-                <a16:creationId xmlns:a16="http://schemas.microsoft.com/office/drawing/2014/main" id="{7B3D0481-102F-4BE8-B55F-7CDF1D714CEF}"/>
+                <a16:creationId xmlns:a16="http://schemas.microsoft.com/office/drawing/2014/main" id="{B854AE00-6EE5-45E3-BE74-C04C457471C5}"/>
               </a:ext>
             </a:extLst>
           </p:cNvPr>
@@ -16473,7 +16473,7 @@
           <p:cNvPr id="104" name="">
             <a:extLst xmlns:a="http://schemas.openxmlformats.org/drawingml/2006/main">
               <a:ext uri="{FF2B5EF4-FFF2-40B4-BE49-F238E27FC236}">
-                <a16:creationId xmlns:a16="http://schemas.microsoft.com/office/drawing/2014/main" id="{39B9767D-24BE-44A9-8B23-174FEF902588}"/>
+                <a16:creationId xmlns:a16="http://schemas.microsoft.com/office/drawing/2014/main" id="{05896BF9-C04B-49B9-BA49-B96B8832B5CB}"/>
               </a:ext>
             </a:extLst>
           </p:cNvPr>
@@ -16483,7 +16483,7 @@
           <p:nvPr/>
         </p:nvPicPr>
         <p:blipFill>
-          <a:blip xmlns:r="http://schemas.openxmlformats.org/officeDocument/2006/relationships" xmlns:a="http://schemas.openxmlformats.org/drawingml/2006/main" r:embed="R9d32dfc9d59c428a"/>
+          <a:blip xmlns:r="http://schemas.openxmlformats.org/officeDocument/2006/relationships" xmlns:a="http://schemas.openxmlformats.org/drawingml/2006/main" r:embed="R4916768acfc5440d"/>
           <a:stretch xmlns:a="http://schemas.openxmlformats.org/drawingml/2006/main"/>
         </p:blipFill>
         <p:spPr>
@@ -16501,7 +16501,7 @@
           <p:cNvPr id="105" name="">
             <a:extLst xmlns:a="http://schemas.openxmlformats.org/drawingml/2006/main">
               <a:ext uri="{FF2B5EF4-FFF2-40B4-BE49-F238E27FC236}">
-                <a16:creationId xmlns:a16="http://schemas.microsoft.com/office/drawing/2014/main" id="{2E27D9F6-52D3-4DC2-B098-CAB4B64F5CA7}"/>
+                <a16:creationId xmlns:a16="http://schemas.microsoft.com/office/drawing/2014/main" id="{2EF5BEED-A39B-4B16-9DD3-58196E6FD759}"/>
               </a:ext>
             </a:extLst>
           </p:cNvPr>
@@ -16569,7 +16569,7 @@
           <p:cNvPr id="106" name="">
             <a:extLst xmlns:a="http://schemas.openxmlformats.org/drawingml/2006/main">
               <a:ext uri="{FF2B5EF4-FFF2-40B4-BE49-F238E27FC236}">
-                <a16:creationId xmlns:a16="http://schemas.microsoft.com/office/drawing/2014/main" id="{9469365F-6766-419F-9DFC-F0A8F72DCCA8}"/>
+                <a16:creationId xmlns:a16="http://schemas.microsoft.com/office/drawing/2014/main" id="{3FF75DED-6A7C-4925-BD0A-2226D7C8A5D0}"/>
               </a:ext>
             </a:extLst>
           </p:cNvPr>
@@ -16721,7 +16721,7 @@
           <p:cNvPr id="107" name="">
             <a:extLst xmlns:a="http://schemas.openxmlformats.org/drawingml/2006/main">
               <a:ext uri="{FF2B5EF4-FFF2-40B4-BE49-F238E27FC236}">
-                <a16:creationId xmlns:a16="http://schemas.microsoft.com/office/drawing/2014/main" id="{7B51C273-0F7F-44F1-BB36-AB45473AB487}"/>
+                <a16:creationId xmlns:a16="http://schemas.microsoft.com/office/drawing/2014/main" id="{799F1F5D-0F8F-4909-A98A-58AFF7B5ED0F}"/>
               </a:ext>
             </a:extLst>
           </p:cNvPr>
@@ -16789,7 +16789,7 @@
           <p:cNvPr id="108" name="">
             <a:extLst xmlns:a="http://schemas.openxmlformats.org/drawingml/2006/main">
               <a:ext uri="{FF2B5EF4-FFF2-40B4-BE49-F238E27FC236}">
-                <a16:creationId xmlns:a16="http://schemas.microsoft.com/office/drawing/2014/main" id="{2B9947B3-80EE-415D-BF1A-EE6C3796DAE6}"/>
+                <a16:creationId xmlns:a16="http://schemas.microsoft.com/office/drawing/2014/main" id="{2DBC849D-8501-4208-A557-EB2C80FC0323}"/>
               </a:ext>
             </a:extLst>
           </p:cNvPr>
@@ -16855,7 +16855,7 @@
     </p:spTree>
     <p:extLst>
       <p:ext uri="{BB962C8B-B14F-4D97-AF65-F5344CB8AC3E}">
-        <p14:creationId xmlns:p14="http://schemas.microsoft.com/office/powerpoint/2010/main" val="350163269"/>
+        <p14:creationId xmlns:p14="http://schemas.microsoft.com/office/powerpoint/2010/main" val="863270291"/>
       </p:ext>
     </p:extLst>
   </p:cSld>
@@ -16879,7 +16879,7 @@
           <p:cNvPr id="125" name="">
             <a:extLst xmlns:a="http://schemas.openxmlformats.org/drawingml/2006/main">
               <a:ext uri="{FF2B5EF4-FFF2-40B4-BE49-F238E27FC236}">
-                <a16:creationId xmlns:a16="http://schemas.microsoft.com/office/drawing/2014/main" id="{433B329A-A5E0-4CA9-B0AB-46D180A50EFE}"/>
+                <a16:creationId xmlns:a16="http://schemas.microsoft.com/office/drawing/2014/main" id="{43D95C17-5D0A-4E50-A5F6-711B244A4092}"/>
               </a:ext>
             </a:extLst>
           </p:cNvPr>
@@ -16913,7 +16913,7 @@
           <p:cNvPr id="124" name="">
             <a:extLst xmlns:a="http://schemas.openxmlformats.org/drawingml/2006/main">
               <a:ext uri="{FF2B5EF4-FFF2-40B4-BE49-F238E27FC236}">
-                <a16:creationId xmlns:a16="http://schemas.microsoft.com/office/drawing/2014/main" id="{AC793B18-F3A0-4972-A7DA-416508B4F247}"/>
+                <a16:creationId xmlns:a16="http://schemas.microsoft.com/office/drawing/2014/main" id="{7EFACA40-1FF5-4803-A1F3-54D3F29BAD4B}"/>
               </a:ext>
             </a:extLst>
           </p:cNvPr>
@@ -16944,7 +16944,7 @@
           <p:cNvPr id="123" name="">
             <a:extLst xmlns:a="http://schemas.openxmlformats.org/drawingml/2006/main">
               <a:ext uri="{FF2B5EF4-FFF2-40B4-BE49-F238E27FC236}">
-                <a16:creationId xmlns:a16="http://schemas.microsoft.com/office/drawing/2014/main" id="{958D85FF-5BAD-4078-AA3C-33D6BB853163}"/>
+                <a16:creationId xmlns:a16="http://schemas.microsoft.com/office/drawing/2014/main" id="{CA236E1C-5035-45DC-B6D2-90A46A1A9B99}"/>
               </a:ext>
             </a:extLst>
           </p:cNvPr>
@@ -16975,7 +16975,7 @@
           <p:cNvPr id="122" name="">
             <a:extLst xmlns:a="http://schemas.openxmlformats.org/drawingml/2006/main">
               <a:ext uri="{FF2B5EF4-FFF2-40B4-BE49-F238E27FC236}">
-                <a16:creationId xmlns:a16="http://schemas.microsoft.com/office/drawing/2014/main" id="{353C8088-8298-4ED6-B397-8633DA568B95}"/>
+                <a16:creationId xmlns:a16="http://schemas.microsoft.com/office/drawing/2014/main" id="{940DC67A-9518-45F2-A1BE-F57E0FAA864A}"/>
               </a:ext>
             </a:extLst>
           </p:cNvPr>
@@ -17009,7 +17009,7 @@
           <p:cNvPr id="118" name="">
             <a:extLst xmlns:a="http://schemas.openxmlformats.org/drawingml/2006/main">
               <a:ext uri="{FF2B5EF4-FFF2-40B4-BE49-F238E27FC236}">
-                <a16:creationId xmlns:a16="http://schemas.microsoft.com/office/drawing/2014/main" id="{7E071093-9B93-4528-90D0-8A1568F07083}"/>
+                <a16:creationId xmlns:a16="http://schemas.microsoft.com/office/drawing/2014/main" id="{9D7553B8-2397-4F7F-9A6C-E563F3A86CDC}"/>
               </a:ext>
             </a:extLst>
           </p:cNvPr>
@@ -17040,7 +17040,7 @@
           <p:cNvPr id="117" name="">
             <a:extLst xmlns:a="http://schemas.openxmlformats.org/drawingml/2006/main">
               <a:ext uri="{FF2B5EF4-FFF2-40B4-BE49-F238E27FC236}">
-                <a16:creationId xmlns:a16="http://schemas.microsoft.com/office/drawing/2014/main" id="{F6F9ACDB-64A5-443D-8519-45764C748642}"/>
+                <a16:creationId xmlns:a16="http://schemas.microsoft.com/office/drawing/2014/main" id="{D3F1D16E-F984-440F-BE7C-8EC236B3688C}"/>
               </a:ext>
             </a:extLst>
           </p:cNvPr>
@@ -17071,7 +17071,7 @@
           <p:cNvPr id="116" name="">
             <a:extLst xmlns:a="http://schemas.openxmlformats.org/drawingml/2006/main">
               <a:ext uri="{FF2B5EF4-FFF2-40B4-BE49-F238E27FC236}">
-                <a16:creationId xmlns:a16="http://schemas.microsoft.com/office/drawing/2014/main" id="{66EAA9CC-9322-4BBF-A9F6-EF24B9C3F2D7}"/>
+                <a16:creationId xmlns:a16="http://schemas.microsoft.com/office/drawing/2014/main" id="{AF480456-56AC-4B46-8621-9FBEB20B6F1B}"/>
               </a:ext>
             </a:extLst>
           </p:cNvPr>
@@ -17102,7 +17102,7 @@
           <p:cNvPr id="108" name="Google Shape;108;p20">
             <a:extLst xmlns:a="http://schemas.openxmlformats.org/drawingml/2006/main">
               <a:ext uri="{FF2B5EF4-FFF2-40B4-BE49-F238E27FC236}">
-                <a16:creationId xmlns:a16="http://schemas.microsoft.com/office/drawing/2014/main" id="{BD39418E-B33E-4063-B34B-90EE0CAFADA2}"/>
+                <a16:creationId xmlns:a16="http://schemas.microsoft.com/office/drawing/2014/main" id="{CBADD947-5C40-4B35-9EBD-6AAF451486D6}"/>
               </a:ext>
             </a:extLst>
           </p:cNvPr>
@@ -17112,7 +17112,7 @@
           <p:nvPr/>
         </p:nvPicPr>
         <p:blipFill rotWithShape="1">
-          <a:blip xmlns:r="http://schemas.openxmlformats.org/officeDocument/2006/relationships" xmlns:a="http://schemas.openxmlformats.org/drawingml/2006/main" r:embed="R1270fe895fe44e86">
+          <a:blip xmlns:r="http://schemas.openxmlformats.org/officeDocument/2006/relationships" xmlns:a="http://schemas.openxmlformats.org/drawingml/2006/main" r:embed="R5da3a388c4114e91">
             <a:alphaModFix/>
           </a:blip>
           <a:srcRect xmlns:a="http://schemas.openxmlformats.org/drawingml/2006/main" l="0" t="0" r="0" b="98001"/>
@@ -17136,7 +17136,7 @@
           <p:cNvPr id="109" name="Google Shape;109;p20">
             <a:extLst xmlns:a="http://schemas.openxmlformats.org/drawingml/2006/main">
               <a:ext uri="{FF2B5EF4-FFF2-40B4-BE49-F238E27FC236}">
-                <a16:creationId xmlns:a16="http://schemas.microsoft.com/office/drawing/2014/main" id="{04D1B119-528D-41F5-8310-302154AF323A}"/>
+                <a16:creationId xmlns:a16="http://schemas.microsoft.com/office/drawing/2014/main" id="{5AB2E04C-F0A6-4170-B11F-21A7E36EABAF}"/>
               </a:ext>
             </a:extLst>
           </p:cNvPr>
@@ -17146,7 +17146,7 @@
           <p:nvPr/>
         </p:nvPicPr>
         <p:blipFill>
-          <a:blip xmlns:r="http://schemas.openxmlformats.org/officeDocument/2006/relationships" xmlns:a="http://schemas.openxmlformats.org/drawingml/2006/main" r:embed="Re53e21999c404bfa">
+          <a:blip xmlns:r="http://schemas.openxmlformats.org/officeDocument/2006/relationships" xmlns:a="http://schemas.openxmlformats.org/drawingml/2006/main" r:embed="Re72df47393ff4f76">
             <a:alphaModFix/>
           </a:blip>
           <a:stretch xmlns:a="http://schemas.openxmlformats.org/drawingml/2006/main">
@@ -17171,7 +17171,7 @@
           <p:cNvPr id="110" name="Google Shape;110;p20">
             <a:extLst xmlns:a="http://schemas.openxmlformats.org/drawingml/2006/main">
               <a:ext uri="{FF2B5EF4-FFF2-40B4-BE49-F238E27FC236}">
-                <a16:creationId xmlns:a16="http://schemas.microsoft.com/office/drawing/2014/main" id="{37AD664D-A18A-44DE-B321-818B02F36C4F}"/>
+                <a16:creationId xmlns:a16="http://schemas.microsoft.com/office/drawing/2014/main" id="{03AEA563-2284-46CA-971E-E41FAD7E290B}"/>
               </a:ext>
             </a:extLst>
           </p:cNvPr>
@@ -17222,7 +17222,7 @@
           <p:cNvPr id="111" name="Google Shape;111;p20">
             <a:extLst xmlns:a="http://schemas.openxmlformats.org/drawingml/2006/main">
               <a:ext uri="{FF2B5EF4-FFF2-40B4-BE49-F238E27FC236}">
-                <a16:creationId xmlns:a16="http://schemas.microsoft.com/office/drawing/2014/main" id="{7622DAC3-3EDB-4B0A-93AB-D9FBE5CBA98B}"/>
+                <a16:creationId xmlns:a16="http://schemas.microsoft.com/office/drawing/2014/main" id="{B1261BD0-A73B-4733-AD7F-E7BA325D47F0}"/>
               </a:ext>
             </a:extLst>
           </p:cNvPr>
@@ -17302,7 +17302,7 @@
           <p:cNvPr id="112" name="">
             <a:extLst xmlns:a="http://schemas.openxmlformats.org/drawingml/2006/main">
               <a:ext uri="{FF2B5EF4-FFF2-40B4-BE49-F238E27FC236}">
-                <a16:creationId xmlns:a16="http://schemas.microsoft.com/office/drawing/2014/main" id="{FA830FB4-7466-4FD2-9618-A38A84961086}"/>
+                <a16:creationId xmlns:a16="http://schemas.microsoft.com/office/drawing/2014/main" id="{5166D599-12D6-435C-8FD2-76149AA823ED}"/>
               </a:ext>
             </a:extLst>
           </p:cNvPr>
@@ -17399,7 +17399,7 @@
           <p:cNvPr id="113" name="">
             <a:extLst xmlns:a="http://schemas.openxmlformats.org/drawingml/2006/main">
               <a:ext uri="{FF2B5EF4-FFF2-40B4-BE49-F238E27FC236}">
-                <a16:creationId xmlns:a16="http://schemas.microsoft.com/office/drawing/2014/main" id="{CE98D94F-D783-4D33-9885-CEB5C91B1FBF}"/>
+                <a16:creationId xmlns:a16="http://schemas.microsoft.com/office/drawing/2014/main" id="{F4DA7F3A-B5D0-45C9-A4D6-3E927381AB10}"/>
               </a:ext>
             </a:extLst>
           </p:cNvPr>
@@ -17496,7 +17496,7 @@
           <p:cNvPr id="114" name="">
             <a:extLst xmlns:a="http://schemas.openxmlformats.org/drawingml/2006/main">
               <a:ext uri="{FF2B5EF4-FFF2-40B4-BE49-F238E27FC236}">
-                <a16:creationId xmlns:a16="http://schemas.microsoft.com/office/drawing/2014/main" id="{BCEB5575-4DEF-46F8-BD7E-B1E9ED008DD1}"/>
+                <a16:creationId xmlns:a16="http://schemas.microsoft.com/office/drawing/2014/main" id="{3EAD5307-9B06-4F35-A96C-BA2FC790B719}"/>
               </a:ext>
             </a:extLst>
           </p:cNvPr>
@@ -17593,7 +17593,7 @@
           <p:cNvPr id="115" name="">
             <a:extLst xmlns:a="http://schemas.openxmlformats.org/drawingml/2006/main">
               <a:ext uri="{FF2B5EF4-FFF2-40B4-BE49-F238E27FC236}">
-                <a16:creationId xmlns:a16="http://schemas.microsoft.com/office/drawing/2014/main" id="{22815A0A-5CC5-4E1F-93E2-92EFCEE3169E}"/>
+                <a16:creationId xmlns:a16="http://schemas.microsoft.com/office/drawing/2014/main" id="{4098D117-98FB-4386-A6B0-5027D2AB3519}"/>
               </a:ext>
             </a:extLst>
           </p:cNvPr>
@@ -17690,7 +17690,7 @@
           <p:cNvPr id="119" name="">
             <a:extLst xmlns:a="http://schemas.openxmlformats.org/drawingml/2006/main">
               <a:ext uri="{FF2B5EF4-FFF2-40B4-BE49-F238E27FC236}">
-                <a16:creationId xmlns:a16="http://schemas.microsoft.com/office/drawing/2014/main" id="{2BF54FA3-4B8B-4F43-B9FE-48A61D4E6674}"/>
+                <a16:creationId xmlns:a16="http://schemas.microsoft.com/office/drawing/2014/main" id="{2269AE51-DF78-431D-A900-A98A3503A96B}"/>
               </a:ext>
             </a:extLst>
           </p:cNvPr>
@@ -17810,7 +17810,7 @@
           <p:cNvPr id="120" name="">
             <a:extLst xmlns:a="http://schemas.openxmlformats.org/drawingml/2006/main">
               <a:ext uri="{FF2B5EF4-FFF2-40B4-BE49-F238E27FC236}">
-                <a16:creationId xmlns:a16="http://schemas.microsoft.com/office/drawing/2014/main" id="{69843349-9596-4F4F-B322-0968EE02A70D}"/>
+                <a16:creationId xmlns:a16="http://schemas.microsoft.com/office/drawing/2014/main" id="{0C9B22E9-6D83-472F-88CF-C7256E81B28F}"/>
               </a:ext>
             </a:extLst>
           </p:cNvPr>
@@ -17930,7 +17930,7 @@
           <p:cNvPr id="121" name="">
             <a:extLst xmlns:a="http://schemas.openxmlformats.org/drawingml/2006/main">
               <a:ext uri="{FF2B5EF4-FFF2-40B4-BE49-F238E27FC236}">
-                <a16:creationId xmlns:a16="http://schemas.microsoft.com/office/drawing/2014/main" id="{DBC7E9BF-2CB3-49B6-B02B-5F2CC827F9C6}"/>
+                <a16:creationId xmlns:a16="http://schemas.microsoft.com/office/drawing/2014/main" id="{DC2B915E-25AB-40E5-8003-CC1D711439C9}"/>
               </a:ext>
             </a:extLst>
           </p:cNvPr>
@@ -18027,7 +18027,7 @@
           <p:cNvPr id="126" name="">
             <a:extLst xmlns:a="http://schemas.openxmlformats.org/drawingml/2006/main">
               <a:ext uri="{FF2B5EF4-FFF2-40B4-BE49-F238E27FC236}">
-                <a16:creationId xmlns:a16="http://schemas.microsoft.com/office/drawing/2014/main" id="{EC83A530-DC83-4CD9-B923-6C5C4C3C7662}"/>
+                <a16:creationId xmlns:a16="http://schemas.microsoft.com/office/drawing/2014/main" id="{7174C830-B56B-44D1-A261-BA4CB586128A}"/>
               </a:ext>
             </a:extLst>
           </p:cNvPr>
@@ -18095,7 +18095,7 @@
           <p:cNvPr id="127" name="">
             <a:extLst xmlns:a="http://schemas.openxmlformats.org/drawingml/2006/main">
               <a:ext uri="{FF2B5EF4-FFF2-40B4-BE49-F238E27FC236}">
-                <a16:creationId xmlns:a16="http://schemas.microsoft.com/office/drawing/2014/main" id="{80B60AE7-F418-4448-B582-5D1DF84BE3EA}"/>
+                <a16:creationId xmlns:a16="http://schemas.microsoft.com/office/drawing/2014/main" id="{259B5F02-A6BE-4639-9365-6DC8352F3C6F}"/>
               </a:ext>
             </a:extLst>
           </p:cNvPr>
@@ -18163,7 +18163,7 @@
           <p:cNvPr id="128" name="">
             <a:extLst xmlns:a="http://schemas.openxmlformats.org/drawingml/2006/main">
               <a:ext uri="{FF2B5EF4-FFF2-40B4-BE49-F238E27FC236}">
-                <a16:creationId xmlns:a16="http://schemas.microsoft.com/office/drawing/2014/main" id="{E8159620-CFAE-4EC2-9241-B70F0D740E2D}"/>
+                <a16:creationId xmlns:a16="http://schemas.microsoft.com/office/drawing/2014/main" id="{5B8460B3-0F57-4A67-8AF7-C140C7B4EBCB}"/>
               </a:ext>
             </a:extLst>
           </p:cNvPr>
@@ -18229,7 +18229,7 @@
     </p:spTree>
     <p:extLst>
       <p:ext uri="{BB962C8B-B14F-4D97-AF65-F5344CB8AC3E}">
-        <p14:creationId xmlns:p14="http://schemas.microsoft.com/office/powerpoint/2010/main" val="756605222"/>
+        <p14:creationId xmlns:p14="http://schemas.microsoft.com/office/powerpoint/2010/main" val="2066894661"/>
       </p:ext>
     </p:extLst>
   </p:cSld>
@@ -18253,7 +18253,7 @@
           <p:cNvPr id="116" name="Google Shape;116;p21">
             <a:extLst xmlns:a="http://schemas.openxmlformats.org/drawingml/2006/main">
               <a:ext uri="{FF2B5EF4-FFF2-40B4-BE49-F238E27FC236}">
-                <a16:creationId xmlns:a16="http://schemas.microsoft.com/office/drawing/2014/main" id="{11486C77-782D-4DAC-9D9F-8250687FA9CA}"/>
+                <a16:creationId xmlns:a16="http://schemas.microsoft.com/office/drawing/2014/main" id="{63F56AE0-387A-4D56-B194-EAB6A6F31C0C}"/>
               </a:ext>
             </a:extLst>
           </p:cNvPr>
@@ -18263,7 +18263,7 @@
           <p:nvPr/>
         </p:nvPicPr>
         <p:blipFill rotWithShape="1">
-          <a:blip xmlns:r="http://schemas.openxmlformats.org/officeDocument/2006/relationships" xmlns:a="http://schemas.openxmlformats.org/drawingml/2006/main" r:embed="Ra73029c09153451b">
+          <a:blip xmlns:r="http://schemas.openxmlformats.org/officeDocument/2006/relationships" xmlns:a="http://schemas.openxmlformats.org/drawingml/2006/main" r:embed="Re3d25324dfab40f7">
             <a:alphaModFix/>
           </a:blip>
           <a:srcRect xmlns:a="http://schemas.openxmlformats.org/drawingml/2006/main" l="0" t="0" r="0" b="98001"/>
@@ -18287,7 +18287,7 @@
           <p:cNvPr id="117" name="Google Shape;117;p21">
             <a:extLst xmlns:a="http://schemas.openxmlformats.org/drawingml/2006/main">
               <a:ext uri="{FF2B5EF4-FFF2-40B4-BE49-F238E27FC236}">
-                <a16:creationId xmlns:a16="http://schemas.microsoft.com/office/drawing/2014/main" id="{0D30487B-F828-4958-BEDB-B9B76C6EF08A}"/>
+                <a16:creationId xmlns:a16="http://schemas.microsoft.com/office/drawing/2014/main" id="{5506ECBD-2B4E-4C73-9CAE-4D769AD461AD}"/>
               </a:ext>
             </a:extLst>
           </p:cNvPr>
@@ -18297,7 +18297,7 @@
           <p:nvPr/>
         </p:nvPicPr>
         <p:blipFill>
-          <a:blip xmlns:r="http://schemas.openxmlformats.org/officeDocument/2006/relationships" xmlns:a="http://schemas.openxmlformats.org/drawingml/2006/main" r:embed="R2c002b9857d046cf">
+          <a:blip xmlns:r="http://schemas.openxmlformats.org/officeDocument/2006/relationships" xmlns:a="http://schemas.openxmlformats.org/drawingml/2006/main" r:embed="R59db2de2e5394bd9">
             <a:alphaModFix/>
           </a:blip>
           <a:stretch xmlns:a="http://schemas.openxmlformats.org/drawingml/2006/main">
@@ -18322,7 +18322,7 @@
           <p:cNvPr id="118" name="Google Shape;118;p21">
             <a:extLst xmlns:a="http://schemas.openxmlformats.org/drawingml/2006/main">
               <a:ext uri="{FF2B5EF4-FFF2-40B4-BE49-F238E27FC236}">
-                <a16:creationId xmlns:a16="http://schemas.microsoft.com/office/drawing/2014/main" id="{6139BEFC-95CD-4857-909A-9078D1EE0C6B}"/>
+                <a16:creationId xmlns:a16="http://schemas.microsoft.com/office/drawing/2014/main" id="{479BA9E1-E12B-4248-A325-0D65FC4E0FA4}"/>
               </a:ext>
             </a:extLst>
           </p:cNvPr>
@@ -18373,7 +18373,7 @@
           <p:cNvPr id="119" name="Google Shape;119;p21">
             <a:extLst xmlns:a="http://schemas.openxmlformats.org/drawingml/2006/main">
               <a:ext uri="{FF2B5EF4-FFF2-40B4-BE49-F238E27FC236}">
-                <a16:creationId xmlns:a16="http://schemas.microsoft.com/office/drawing/2014/main" id="{E6DD6BAA-D7E4-4AF6-BCAE-8AF44174E783}"/>
+                <a16:creationId xmlns:a16="http://schemas.microsoft.com/office/drawing/2014/main" id="{45648D11-4BE4-4ACC-BC54-A961A11F6B03}"/>
               </a:ext>
             </a:extLst>
           </p:cNvPr>
@@ -18453,7 +18453,7 @@
           <p:cNvPr id="120" name="">
             <a:extLst xmlns:a="http://schemas.openxmlformats.org/drawingml/2006/main">
               <a:ext uri="{FF2B5EF4-FFF2-40B4-BE49-F238E27FC236}">
-                <a16:creationId xmlns:a16="http://schemas.microsoft.com/office/drawing/2014/main" id="{9B1ED757-0248-427A-86B6-CF2C9F5DBE09}"/>
+                <a16:creationId xmlns:a16="http://schemas.microsoft.com/office/drawing/2014/main" id="{B4A67E75-5CB1-48F8-ACAC-132C1B759479}"/>
               </a:ext>
             </a:extLst>
           </p:cNvPr>
@@ -19165,7 +19165,7 @@
           <p:cNvPr id="121" name="">
             <a:extLst xmlns:a="http://schemas.openxmlformats.org/drawingml/2006/main">
               <a:ext uri="{FF2B5EF4-FFF2-40B4-BE49-F238E27FC236}">
-                <a16:creationId xmlns:a16="http://schemas.microsoft.com/office/drawing/2014/main" id="{76F2D533-71F9-43E9-939A-AC5CAF3DEA72}"/>
+                <a16:creationId xmlns:a16="http://schemas.microsoft.com/office/drawing/2014/main" id="{8FD3788D-96B5-48DA-8928-4434AC7D646F}"/>
               </a:ext>
             </a:extLst>
           </p:cNvPr>
@@ -19233,7 +19233,7 @@
           <p:cNvPr id="122" name="">
             <a:extLst xmlns:a="http://schemas.openxmlformats.org/drawingml/2006/main">
               <a:ext uri="{FF2B5EF4-FFF2-40B4-BE49-F238E27FC236}">
-                <a16:creationId xmlns:a16="http://schemas.microsoft.com/office/drawing/2014/main" id="{9AA67CB1-14FB-41B7-8709-EDC4EA633064}"/>
+                <a16:creationId xmlns:a16="http://schemas.microsoft.com/office/drawing/2014/main" id="{7E77ECA1-1935-4F46-A346-42045699E326}"/>
               </a:ext>
             </a:extLst>
           </p:cNvPr>
@@ -19299,7 +19299,7 @@
     </p:spTree>
     <p:extLst>
       <p:ext uri="{BB962C8B-B14F-4D97-AF65-F5344CB8AC3E}">
-        <p14:creationId xmlns:p14="http://schemas.microsoft.com/office/powerpoint/2010/main" val="492876361"/>
+        <p14:creationId xmlns:p14="http://schemas.microsoft.com/office/powerpoint/2010/main" val="277734321"/>
       </p:ext>
     </p:extLst>
   </p:cSld>

</xml_diff>